<commit_message>
Tie pitch deck to real Nigeria recall pain and regenerate exports.
Add plain-language slides on the 72-hour freeze gap and how Reton builds undo into the payment itself.
</commit_message>
<xml_diff>
--- a/presentations/Reton-ALATPay-Buildathon-Pitch.pptx
+++ b/presentations/Reton-ALATPay-Buildathon-Pitch.pptx
@@ -19,9 +19,11 @@
     <p:sldId id="267" r:id="rId13"/>
     <p:sldId id="268" r:id="rId14"/>
     <p:sldId id="269" r:id="rId15"/>
+    <p:sldId id="270" r:id="rId16"/>
+    <p:sldId id="271" r:id="rId17"/>
   </p:sldIdLst>
   <p:notesMasterIdLst>
-    <p:notesMasterId r:id="rId16"/>
+    <p:notesMasterId r:id="rId18"/>
   </p:notesMasterIdLst>
   <p:sldSz cx="12191695" cy="6858000"/>
   <p:notesSz cx="6858000" cy="12191695"/>
@@ -979,6 +981,182 @@
             <a:fld id="{F7021451-1387-4CA6-816F-3879F97B5CBC}" type="slidenum">
               <a:rPr lang="en-US"/>
               <a:t>14</a:t>
+            </a:fld>
+            <a:endParaRPr lang="en-US"/>
+          </a:p>
+        </p:txBody>
+      </p:sp>
+    </p:spTree>
+    <p:extLst>
+      <p:ext uri="{BB962C8B-B14F-4D97-AF65-F5344CB8AC3E}">
+        <p14:creationId xmlns:p14="http://schemas.microsoft.com/office/powerpoint/2010/main" val="1024086991"/>
+      </p:ext>
+    </p:extLst>
+  </p:cSld>
+  <p:clrMapOvr>
+    <a:masterClrMapping/>
+  </p:clrMapOvr>
+</p:notes>
+</file>
+
+<file path=ppt/notesSlides/notesSlide15.xml><?xml version="1.0" encoding="utf-8"?>
+<p:notes xmlns:a="http://schemas.openxmlformats.org/drawingml/2006/main" xmlns:r="http://schemas.openxmlformats.org/officeDocument/2006/relationships" xmlns:p="http://schemas.openxmlformats.org/presentationml/2006/main">
+  <p:cSld>
+    <p:spTree>
+      <p:nvGrpSpPr>
+        <p:cNvPr id="1" name=""/>
+        <p:cNvGrpSpPr/>
+        <p:nvPr/>
+      </p:nvGrpSpPr>
+      <p:grpSpPr>
+        <a:xfrm>
+          <a:off x="0" y="0"/>
+          <a:ext cx="0" cy="0"/>
+          <a:chOff x="0" y="0"/>
+          <a:chExt cx="0" cy="0"/>
+        </a:xfrm>
+      </p:grpSpPr>
+      <p:sp>
+        <p:nvSpPr>
+          <p:cNvPr id="2" name="Slide Image Placeholder 1"/>
+          <p:cNvSpPr>
+            <a:spLocks noGrp="1" noRot="1" noChangeAspect="1"/>
+          </p:cNvSpPr>
+          <p:nvPr>
+            <p:ph type="sldImg"/>
+          </p:nvPr>
+        </p:nvSpPr>
+        <p:spPr/>
+      </p:sp>
+      <p:sp>
+        <p:nvSpPr>
+          <p:cNvPr id="3" name="Notes Placeholder 2"/>
+          <p:cNvSpPr>
+            <a:spLocks noGrp="1"/>
+          </p:cNvSpPr>
+          <p:nvPr>
+            <p:ph type="body" idx="1"/>
+          </p:nvPr>
+        </p:nvSpPr>
+        <p:spPr/>
+        <p:txBody>
+          <a:bodyPr/>
+          <a:lstStyle/>
+          <a:p>
+            <a:r>
+              <a:rPr lang="en-US" dirty="0"/>
+              <a:t/>
+            </a:r>
+            <a:endParaRPr lang="en-US" dirty="0"/>
+          </a:p>
+        </p:txBody>
+      </p:sp>
+      <p:sp>
+        <p:nvSpPr>
+          <p:cNvPr id="4" name="Slide Number Placeholder 3"/>
+          <p:cNvSpPr>
+            <a:spLocks noGrp="1"/>
+          </p:cNvSpPr>
+          <p:nvPr>
+            <p:ph type="sldNum" sz="quarter" idx="10"/>
+          </p:nvPr>
+        </p:nvSpPr>
+        <p:spPr/>
+        <p:txBody>
+          <a:bodyPr/>
+          <a:lstStyle/>
+          <a:p>
+            <a:fld id="{F7021451-1387-4CA6-816F-3879F97B5CBC}" type="slidenum">
+              <a:rPr lang="en-US"/>
+              <a:t>15</a:t>
+            </a:fld>
+            <a:endParaRPr lang="en-US"/>
+          </a:p>
+        </p:txBody>
+      </p:sp>
+    </p:spTree>
+    <p:extLst>
+      <p:ext uri="{BB962C8B-B14F-4D97-AF65-F5344CB8AC3E}">
+        <p14:creationId xmlns:p14="http://schemas.microsoft.com/office/powerpoint/2010/main" val="1024086991"/>
+      </p:ext>
+    </p:extLst>
+  </p:cSld>
+  <p:clrMapOvr>
+    <a:masterClrMapping/>
+  </p:clrMapOvr>
+</p:notes>
+</file>
+
+<file path=ppt/notesSlides/notesSlide16.xml><?xml version="1.0" encoding="utf-8"?>
+<p:notes xmlns:a="http://schemas.openxmlformats.org/drawingml/2006/main" xmlns:r="http://schemas.openxmlformats.org/officeDocument/2006/relationships" xmlns:p="http://schemas.openxmlformats.org/presentationml/2006/main">
+  <p:cSld>
+    <p:spTree>
+      <p:nvGrpSpPr>
+        <p:cNvPr id="1" name=""/>
+        <p:cNvGrpSpPr/>
+        <p:nvPr/>
+      </p:nvGrpSpPr>
+      <p:grpSpPr>
+        <a:xfrm>
+          <a:off x="0" y="0"/>
+          <a:ext cx="0" cy="0"/>
+          <a:chOff x="0" y="0"/>
+          <a:chExt cx="0" cy="0"/>
+        </a:xfrm>
+      </p:grpSpPr>
+      <p:sp>
+        <p:nvSpPr>
+          <p:cNvPr id="2" name="Slide Image Placeholder 1"/>
+          <p:cNvSpPr>
+            <a:spLocks noGrp="1" noRot="1" noChangeAspect="1"/>
+          </p:cNvSpPr>
+          <p:nvPr>
+            <p:ph type="sldImg"/>
+          </p:nvPr>
+        </p:nvSpPr>
+        <p:spPr/>
+      </p:sp>
+      <p:sp>
+        <p:nvSpPr>
+          <p:cNvPr id="3" name="Notes Placeholder 2"/>
+          <p:cNvSpPr>
+            <a:spLocks noGrp="1"/>
+          </p:cNvSpPr>
+          <p:nvPr>
+            <p:ph type="body" idx="1"/>
+          </p:nvPr>
+        </p:nvSpPr>
+        <p:spPr/>
+        <p:txBody>
+          <a:bodyPr/>
+          <a:lstStyle/>
+          <a:p>
+            <a:r>
+              <a:rPr lang="en-US" dirty="0"/>
+              <a:t/>
+            </a:r>
+            <a:endParaRPr lang="en-US" dirty="0"/>
+          </a:p>
+        </p:txBody>
+      </p:sp>
+      <p:sp>
+        <p:nvSpPr>
+          <p:cNvPr id="4" name="Slide Number Placeholder 3"/>
+          <p:cNvSpPr>
+            <a:spLocks noGrp="1"/>
+          </p:cNvSpPr>
+          <p:nvPr>
+            <p:ph type="sldNum" sz="quarter" idx="10"/>
+          </p:nvPr>
+        </p:nvSpPr>
+        <p:spPr/>
+        <p:txBody>
+          <a:bodyPr/>
+          <a:lstStyle/>
+          <a:p>
+            <a:fld id="{F7021451-1387-4CA6-816F-3879F97B5CBC}" type="slidenum">
+              <a:rPr lang="en-US"/>
+              <a:t>16</a:t>
             </a:fld>
             <a:endParaRPr lang="en-US"/>
           </a:p>
@@ -2289,7 +2467,7 @@
                 <a:ea typeface="Arial" pitchFamily="34" charset="-122"/>
                 <a:cs typeface="Arial" pitchFamily="34" charset="-120"/>
               </a:rPr>
-              <a:t>Reachable. Self-explanatory.</a:t>
+              <a:t>Security posture. Business on the way.</a:t>
             </a:r>
             <a:endParaRPr lang="en-US" sz="2400" dirty="0"/>
           </a:p>
@@ -2297,7 +2475,7 @@
       </p:sp>
       <p:pic>
         <p:nvPicPr>
-          <p:cNvPr id="4" name="Image 0" descr="C:\Users\roten\Documents\reton\presentations\screenshots\05-contact.png">    </p:cNvPr>
+          <p:cNvPr id="4" name="Image 0" descr="C:\Users\roten\Documents\reton\presentations\screenshots\03-security.png">    </p:cNvPr>
           <p:cNvPicPr>
             <a:picLocks noChangeAspect="1"/>
           </p:cNvPicPr>
@@ -2321,7 +2499,7 @@
       </p:pic>
       <p:pic>
         <p:nvPicPr>
-          <p:cNvPr id="5" name="Image 1" descr="C:\Users\roten\Documents\reton\presentations\screenshots\06-faq.png">    </p:cNvPr>
+          <p:cNvPr id="5" name="Image 1" descr="C:\Users\roten\Documents\reton\presentations\screenshots\04-business.png">    </p:cNvPr>
           <p:cNvPicPr>
             <a:picLocks noChangeAspect="1"/>
           </p:cNvPicPr>
@@ -2408,7 +2586,7 @@
                 <a:ea typeface="Arial" pitchFamily="34" charset="-122"/>
                 <a:cs typeface="Arial" pitchFamily="34" charset="-120"/>
               </a:rPr>
-              <a:t>WHY RETON</a:t>
+              <a:t>ALATPAY INTEGRATION</a:t>
             </a:r>
             <a:endParaRPr lang="en-US" sz="1100" dirty="0"/>
           </a:p>
@@ -2423,23 +2601,23 @@
         <p:spPr>
           <a:xfrm>
             <a:off x="640080" y="777240"/>
-            <a:ext cx="10515600" cy="1280160"/>
-          </a:xfrm>
-          <a:prstGeom prst="rect">
-            <a:avLst/>
-          </a:prstGeom>
-          <a:noFill/>
-          <a:ln/>
-        </p:spPr>
-        <p:txBody>
-          <a:bodyPr wrap="square" rtlCol="0" anchor="ctr"/>
-          <a:lstStyle/>
-          <a:p>
-            <a:pPr indent="0" marL="0">
-              <a:buNone/>
-            </a:pPr>
-            <a:r>
-              <a:rPr lang="en-US" sz="3600" b="1" dirty="0">
+            <a:ext cx="10515600" cy="640080"/>
+          </a:xfrm>
+          <a:prstGeom prst="rect">
+            <a:avLst/>
+          </a:prstGeom>
+          <a:noFill/>
+          <a:ln/>
+        </p:spPr>
+        <p:txBody>
+          <a:bodyPr wrap="square" rtlCol="0" anchor="ctr"/>
+          <a:lstStyle/>
+          <a:p>
+            <a:pPr indent="0" marL="0">
+              <a:buNone/>
+            </a:pPr>
+            <a:r>
+              <a:rPr lang="en-US" sz="3000" b="1" dirty="0">
                 <a:solidFill>
                   <a:srgbClr val="E8F3EE"/>
                 </a:solidFill>
@@ -2447,103 +2625,236 @@
                 <a:ea typeface="Arial" pitchFamily="34" charset="-122"/>
                 <a:cs typeface="Arial" pitchFamily="34" charset="-120"/>
               </a:rPr>
-              <a:t>We’re not another wallet.</a:t>
-            </a:r>
-            <a:endParaRPr lang="en-US" sz="3600" dirty="0"/>
-          </a:p>
-        </p:txBody>
-      </p:sp>
-      <p:sp>
-        <p:nvSpPr>
-          <p:cNvPr id="4" name="Text 2"/>
-          <p:cNvSpPr/>
-          <p:nvPr/>
-        </p:nvSpPr>
-        <p:spPr>
-          <a:xfrm>
-            <a:off x="640080" y="2194560"/>
-            <a:ext cx="10515600" cy="3657600"/>
-          </a:xfrm>
-          <a:prstGeom prst="rect">
-            <a:avLst/>
-          </a:prstGeom>
-          <a:noFill/>
-          <a:ln/>
-        </p:spPr>
-        <p:txBody>
-          <a:bodyPr wrap="square" rtlCol="0" anchor="ctr"/>
-          <a:lstStyle/>
-          <a:p>
-            <a:pPr marL="342900" indent="-342900">
-              <a:buSzPct val="100000"/>
-              <a:buChar char="•"/>
-            </a:pPr>
-            <a:r>
-              <a:rPr lang="en-US" sz="2000" dirty="0">
+              <a:t>Real rails. Not a mock bank.</a:t>
+            </a:r>
+            <a:endParaRPr lang="en-US" sz="3000" dirty="0"/>
+          </a:p>
+        </p:txBody>
+      </p:sp>
+      <p:sp>
+        <p:nvSpPr>
+          <p:cNvPr id="4" name="Shape 2"/>
+          <p:cNvSpPr/>
+          <p:nvPr/>
+        </p:nvSpPr>
+        <p:spPr>
+          <a:xfrm>
+            <a:off x="640080" y="1737360"/>
+            <a:ext cx="5212080" cy="2377440"/>
+          </a:xfrm>
+          <a:prstGeom prst="roundRect">
+            <a:avLst>
+              <a:gd name="adj" fmla="val 7692"/>
+            </a:avLst>
+          </a:prstGeom>
+          <a:solidFill>
+            <a:srgbClr val="0F211C"/>
+          </a:solidFill>
+          <a:ln/>
+        </p:spPr>
+      </p:sp>
+      <p:sp>
+        <p:nvSpPr>
+          <p:cNvPr id="5" name="Text 3"/>
+          <p:cNvSpPr/>
+          <p:nvPr/>
+        </p:nvSpPr>
+        <p:spPr>
+          <a:xfrm>
+            <a:off x="914400" y="1965960"/>
+            <a:ext cx="4663440" cy="365760"/>
+          </a:xfrm>
+          <a:prstGeom prst="rect">
+            <a:avLst/>
+          </a:prstGeom>
+          <a:noFill/>
+          <a:ln/>
+        </p:spPr>
+        <p:txBody>
+          <a:bodyPr wrap="square" rtlCol="0" anchor="ctr"/>
+          <a:lstStyle/>
+          <a:p>
+            <a:pPr indent="0" marL="0">
+              <a:buNone/>
+            </a:pPr>
+            <a:r>
+              <a:rPr lang="en-US" sz="1600" b="1" dirty="0">
                 <a:solidFill>
                   <a:srgbClr val="E8F3EE"/>
+                </a:solidFill>
+              </a:rPr>
+              <a:t>What we use</a:t>
+            </a:r>
+            <a:endParaRPr lang="en-US" sz="1600" dirty="0"/>
+          </a:p>
+        </p:txBody>
+      </p:sp>
+      <p:sp>
+        <p:nvSpPr>
+          <p:cNvPr id="6" name="Text 4"/>
+          <p:cNvSpPr/>
+          <p:nvPr/>
+        </p:nvSpPr>
+        <p:spPr>
+          <a:xfrm>
+            <a:off x="914400" y="2468880"/>
+            <a:ext cx="4663440" cy="1280160"/>
+          </a:xfrm>
+          <a:prstGeom prst="rect">
+            <a:avLst/>
+          </a:prstGeom>
+          <a:noFill/>
+          <a:ln/>
+        </p:spPr>
+        <p:txBody>
+          <a:bodyPr wrap="square" rtlCol="0" anchor="ctr"/>
+          <a:lstStyle/>
+          <a:p>
+            <a:pPr indent="0" marL="0">
+              <a:buNone/>
+            </a:pPr>
+            <a:r>
+              <a:rPr lang="en-US" sz="1500" dirty="0">
+                <a:solidFill>
+                  <a:srgbClr val="8AA89D"/>
+                </a:solidFill>
+              </a:rPr>
+              <a:t>Collections &amp; payment links · Static virtual accounts · BVN OTP · Signed webhooks · Transaction verification</a:t>
+            </a:r>
+            <a:endParaRPr lang="en-US" sz="1500" dirty="0"/>
+          </a:p>
+        </p:txBody>
+      </p:sp>
+      <p:sp>
+        <p:nvSpPr>
+          <p:cNvPr id="7" name="Shape 5"/>
+          <p:cNvSpPr/>
+          <p:nvPr/>
+        </p:nvSpPr>
+        <p:spPr>
+          <a:xfrm>
+            <a:off x="6126480" y="1737360"/>
+            <a:ext cx="5212080" cy="2377440"/>
+          </a:xfrm>
+          <a:prstGeom prst="roundRect">
+            <a:avLst>
+              <a:gd name="adj" fmla="val 7692"/>
+            </a:avLst>
+          </a:prstGeom>
+          <a:solidFill>
+            <a:srgbClr val="0F211C"/>
+          </a:solidFill>
+          <a:ln/>
+        </p:spPr>
+      </p:sp>
+      <p:sp>
+        <p:nvSpPr>
+          <p:cNvPr id="8" name="Text 6"/>
+          <p:cNvSpPr/>
+          <p:nvPr/>
+        </p:nvSpPr>
+        <p:spPr>
+          <a:xfrm>
+            <a:off x="6400800" y="1965960"/>
+            <a:ext cx="4663440" cy="365760"/>
+          </a:xfrm>
+          <a:prstGeom prst="rect">
+            <a:avLst/>
+          </a:prstGeom>
+          <a:noFill/>
+          <a:ln/>
+        </p:spPr>
+        <p:txBody>
+          <a:bodyPr wrap="square" rtlCol="0" anchor="ctr"/>
+          <a:lstStyle/>
+          <a:p>
+            <a:pPr indent="0" marL="0">
+              <a:buNone/>
+            </a:pPr>
+            <a:r>
+              <a:rPr lang="en-US" sz="1600" b="1" dirty="0">
+                <a:solidFill>
+                  <a:srgbClr val="E8F3EE"/>
+                </a:solidFill>
+              </a:rPr>
+              <a:t>Where money enters</a:t>
+            </a:r>
+            <a:endParaRPr lang="en-US" sz="1600" dirty="0"/>
+          </a:p>
+        </p:txBody>
+      </p:sp>
+      <p:sp>
+        <p:nvSpPr>
+          <p:cNvPr id="9" name="Text 7"/>
+          <p:cNvSpPr/>
+          <p:nvPr/>
+        </p:nvSpPr>
+        <p:spPr>
+          <a:xfrm>
+            <a:off x="6400800" y="2468880"/>
+            <a:ext cx="4663440" cy="1280160"/>
+          </a:xfrm>
+          <a:prstGeom prst="rect">
+            <a:avLst/>
+          </a:prstGeom>
+          <a:noFill/>
+          <a:ln/>
+        </p:spPr>
+        <p:txBody>
+          <a:bodyPr wrap="square" rtlCol="0" anchor="ctr"/>
+          <a:lstStyle/>
+          <a:p>
+            <a:pPr indent="0" marL="0">
+              <a:buNone/>
+            </a:pPr>
+            <a:r>
+              <a:rPr lang="en-US" sz="1500" dirty="0">
+                <a:solidFill>
+                  <a:srgbClr val="8AA89D"/>
+                </a:solidFill>
+              </a:rPr>
+              <a:t>Users fund Reton wallets on ALATPay. We credit our ledger only after verified settlement.</a:t>
+            </a:r>
+            <a:endParaRPr lang="en-US" sz="1500" dirty="0"/>
+          </a:p>
+        </p:txBody>
+      </p:sp>
+      <p:sp>
+        <p:nvSpPr>
+          <p:cNvPr id="10" name="Text 8"/>
+          <p:cNvSpPr/>
+          <p:nvPr/>
+        </p:nvSpPr>
+        <p:spPr>
+          <a:xfrm>
+            <a:off x="640080" y="4572000"/>
+            <a:ext cx="10058400" cy="1097280"/>
+          </a:xfrm>
+          <a:prstGeom prst="rect">
+            <a:avLst/>
+          </a:prstGeom>
+          <a:noFill/>
+          <a:ln/>
+        </p:spPr>
+        <p:txBody>
+          <a:bodyPr wrap="square" rtlCol="0" anchor="ctr"/>
+          <a:lstStyle/>
+          <a:p>
+            <a:pPr indent="0" marL="0">
+              <a:buNone/>
+            </a:pPr>
+            <a:r>
+              <a:rPr lang="en-US" sz="1800" dirty="0">
+                <a:solidFill>
+                  <a:srgbClr val="8AA89D"/>
                 </a:solidFill>
                 <a:latin typeface="Arial" pitchFamily="34" charset="0"/>
                 <a:ea typeface="Arial" pitchFamily="34" charset="-122"/>
                 <a:cs typeface="Arial" pitchFamily="34" charset="-120"/>
               </a:rPr>
-              <a:t>Trust layer — protection and recovery are the product.</a:t>
-            </a:r>
-            <a:endParaRPr lang="en-US" sz="2000" dirty="0"/>
-          </a:p>
-          <a:p>
-            <a:pPr marL="342900" indent="-342900">
-              <a:buSzPct val="100000"/>
-              <a:buChar char="•"/>
-            </a:pPr>
-            <a:r>
-              <a:rPr lang="en-US" sz="2000" dirty="0">
-                <a:solidFill>
-                  <a:srgbClr val="E8F3EE"/>
-                </a:solidFill>
-                <a:latin typeface="Arial" pitchFamily="34" charset="0"/>
-                <a:ea typeface="Arial" pitchFamily="34" charset="-122"/>
-                <a:cs typeface="Arial" pitchFamily="34" charset="-120"/>
-              </a:rPr>
-              <a:t>Visible timeline — every money event is explainable.</a:t>
-            </a:r>
-            <a:endParaRPr lang="en-US" sz="2000" dirty="0"/>
-          </a:p>
-          <a:p>
-            <a:pPr marL="342900" indent="-342900">
-              <a:buSzPct val="100000"/>
-              <a:buChar char="•"/>
-            </a:pPr>
-            <a:r>
-              <a:rPr lang="en-US" sz="2000" dirty="0">
-                <a:solidFill>
-                  <a:srgbClr val="E8F3EE"/>
-                </a:solidFill>
-                <a:latin typeface="Arial" pitchFamily="34" charset="0"/>
-                <a:ea typeface="Arial" pitchFamily="34" charset="-122"/>
-                <a:cs typeface="Arial" pitchFamily="34" charset="-120"/>
-              </a:rPr>
-              <a:t>Licensed settlement — ALATPay / Wema.</a:t>
-            </a:r>
-            <a:endParaRPr lang="en-US" sz="2000" dirty="0"/>
-          </a:p>
-          <a:p>
-            <a:pPr marL="342900" indent="-342900">
-              <a:buSzPct val="100000"/>
-              <a:buChar char="•"/>
-            </a:pPr>
-            <a:r>
-              <a:rPr lang="en-US" sz="2000" dirty="0">
-                <a:solidFill>
-                  <a:srgbClr val="E8F3EE"/>
-                </a:solidFill>
-                <a:latin typeface="Arial" pitchFamily="34" charset="0"/>
-                <a:ea typeface="Arial" pitchFamily="34" charset="-122"/>
-                <a:cs typeface="Arial" pitchFamily="34" charset="-120"/>
-              </a:rPr>
-              <a:t>Production mindset — signed webhooks, PINs, encrypted secrets, audited admin.</a:t>
-            </a:r>
-            <a:endParaRPr lang="en-US" sz="2000" dirty="0"/>
+              <a:t>ALAT by Wema gives us a licensed Nigerian bank rail — so Callback Protection sits on infrastructure people can trust.</a:t>
+            </a:r>
+            <a:endParaRPr lang="en-US" sz="1800" dirty="0"/>
           </a:p>
         </p:txBody>
       </p:sp>
@@ -2612,7 +2923,7 @@
                 <a:ea typeface="Arial" pitchFamily="34" charset="-122"/>
                 <a:cs typeface="Arial" pitchFamily="34" charset="-120"/>
               </a:rPr>
-              <a:t>DEMO IN 90 SECONDS</a:t>
+              <a:t>PRODUCT · LIVE</a:t>
             </a:r>
             <a:endParaRPr lang="en-US" sz="1100" dirty="0"/>
           </a:p>
@@ -2626,24 +2937,24 @@
         </p:nvSpPr>
         <p:spPr>
           <a:xfrm>
-            <a:off x="640080" y="777240"/>
-            <a:ext cx="10515600" cy="640080"/>
-          </a:xfrm>
-          <a:prstGeom prst="rect">
-            <a:avLst/>
-          </a:prstGeom>
-          <a:noFill/>
-          <a:ln/>
-        </p:spPr>
-        <p:txBody>
-          <a:bodyPr wrap="square" rtlCol="0" anchor="ctr"/>
-          <a:lstStyle/>
-          <a:p>
-            <a:pPr indent="0" marL="0">
-              <a:buNone/>
-            </a:pPr>
-            <a:r>
-              <a:rPr lang="en-US" sz="3200" b="1" dirty="0">
+            <a:off x="640080" y="640080"/>
+            <a:ext cx="10515600" cy="502920"/>
+          </a:xfrm>
+          <a:prstGeom prst="rect">
+            <a:avLst/>
+          </a:prstGeom>
+          <a:noFill/>
+          <a:ln/>
+        </p:spPr>
+        <p:txBody>
+          <a:bodyPr wrap="square" rtlCol="0" anchor="ctr"/>
+          <a:lstStyle/>
+          <a:p>
+            <a:pPr indent="0" marL="0">
+              <a:buNone/>
+            </a:pPr>
+            <a:r>
+              <a:rPr lang="en-US" sz="2400" b="1" dirty="0">
                 <a:solidFill>
                   <a:srgbClr val="E8F3EE"/>
                 </a:solidFill>
@@ -2651,163 +2962,60 @@
                 <a:ea typeface="Arial" pitchFamily="34" charset="-122"/>
                 <a:cs typeface="Arial" pitchFamily="34" charset="-120"/>
               </a:rPr>
-              <a:t>Show, don’t tell.</a:t>
-            </a:r>
-            <a:endParaRPr lang="en-US" sz="3200" dirty="0"/>
-          </a:p>
-        </p:txBody>
-      </p:sp>
-      <p:sp>
-        <p:nvSpPr>
-          <p:cNvPr id="4" name="Text 2"/>
-          <p:cNvSpPr/>
-          <p:nvPr/>
-        </p:nvSpPr>
-        <p:spPr>
-          <a:xfrm>
-            <a:off x="640080" y="1737360"/>
-            <a:ext cx="10515600" cy="3657600"/>
-          </a:xfrm>
-          <a:prstGeom prst="rect">
-            <a:avLst/>
-          </a:prstGeom>
-          <a:noFill/>
-          <a:ln/>
-        </p:spPr>
-        <p:txBody>
-          <a:bodyPr wrap="square" rtlCol="0" anchor="ctr"/>
-          <a:lstStyle/>
-          <a:p>
-            <a:pPr marL="342900" indent="-342900">
-              <a:buSzPct val="100000"/>
-              <a:buChar char="•"/>
-            </a:pPr>
-            <a:r>
-              <a:rPr lang="en-US" sz="2000" dirty="0">
-                <a:solidFill>
-                  <a:srgbClr val="E8F3EE"/>
-                </a:solidFill>
-                <a:latin typeface="Arial" pitchFamily="34" charset="0"/>
-                <a:ea typeface="Arial" pitchFamily="34" charset="-122"/>
-                <a:cs typeface="Arial" pitchFamily="34" charset="-120"/>
-              </a:rPr>
-              <a:t>Open a wallet — balance &amp; KYC tier</a:t>
-            </a:r>
-            <a:endParaRPr lang="en-US" sz="2000" dirty="0"/>
-          </a:p>
-          <a:p>
-            <a:pPr marL="342900" indent="-342900">
-              <a:buSzPct val="100000"/>
-              <a:buChar char="•"/>
-            </a:pPr>
-            <a:r>
-              <a:rPr lang="en-US" sz="2000" dirty="0">
-                <a:solidFill>
-                  <a:srgbClr val="E8F3EE"/>
-                </a:solidFill>
-                <a:latin typeface="Arial" pitchFamily="34" charset="0"/>
-                <a:ea typeface="Arial" pitchFamily="34" charset="-122"/>
-                <a:cs typeface="Arial" pitchFamily="34" charset="-120"/>
-              </a:rPr>
-              <a:t>Send a protected transfer</a:t>
-            </a:r>
-            <a:endParaRPr lang="en-US" sz="2000" dirty="0"/>
-          </a:p>
-          <a:p>
-            <a:pPr marL="342900" indent="-342900">
-              <a:buSzPct val="100000"/>
-              <a:buChar char="•"/>
-            </a:pPr>
-            <a:r>
-              <a:rPr lang="en-US" sz="2000" dirty="0">
-                <a:solidFill>
-                  <a:srgbClr val="E8F3EE"/>
-                </a:solidFill>
-                <a:latin typeface="Arial" pitchFamily="34" charset="0"/>
-                <a:ea typeface="Arial" pitchFamily="34" charset="-122"/>
-                <a:cs typeface="Arial" pitchFamily="34" charset="-120"/>
-              </a:rPr>
-              <a:t>Receiver sees Payment Protected</a:t>
-            </a:r>
-            <a:endParaRPr lang="en-US" sz="2000" dirty="0"/>
-          </a:p>
-          <a:p>
-            <a:pPr marL="342900" indent="-342900">
-              <a:buSzPct val="100000"/>
-              <a:buChar char="•"/>
-            </a:pPr>
-            <a:r>
-              <a:rPr lang="en-US" sz="2000" dirty="0">
-                <a:solidFill>
-                  <a:srgbClr val="E8F3EE"/>
-                </a:solidFill>
-                <a:latin typeface="Arial" pitchFamily="34" charset="0"/>
-                <a:ea typeface="Arial" pitchFamily="34" charset="-122"/>
-                <a:cs typeface="Arial" pitchFamily="34" charset="-120"/>
-              </a:rPr>
-              <a:t>Request callback — timeline updates live</a:t>
-            </a:r>
-            <a:endParaRPr lang="en-US" sz="2000" dirty="0"/>
-          </a:p>
-          <a:p>
-            <a:pPr marL="342900" indent="-342900">
-              <a:buSzPct val="100000"/>
-              <a:buChar char="•"/>
-            </a:pPr>
-            <a:r>
-              <a:rPr lang="en-US" sz="2000" dirty="0">
-                <a:solidFill>
-                  <a:srgbClr val="E8F3EE"/>
-                </a:solidFill>
-                <a:latin typeface="Arial" pitchFamily="34" charset="0"/>
-                <a:ea typeface="Arial" pitchFamily="34" charset="-122"/>
-                <a:cs typeface="Arial" pitchFamily="34" charset="-120"/>
-              </a:rPr>
-              <a:t>Optional: recovery case or admin fraud view</a:t>
-            </a:r>
-            <a:endParaRPr lang="en-US" sz="2000" dirty="0"/>
-          </a:p>
-        </p:txBody>
-      </p:sp>
-      <p:sp>
-        <p:nvSpPr>
-          <p:cNvPr id="5" name="Text 3"/>
-          <p:cNvSpPr/>
-          <p:nvPr/>
-        </p:nvSpPr>
-        <p:spPr>
-          <a:xfrm>
-            <a:off x="640080" y="5029200"/>
-            <a:ext cx="10058400" cy="1097280"/>
-          </a:xfrm>
-          <a:prstGeom prst="rect">
-            <a:avLst/>
-          </a:prstGeom>
-          <a:noFill/>
-          <a:ln/>
-        </p:spPr>
-        <p:txBody>
-          <a:bodyPr wrap="square" rtlCol="0" anchor="ctr"/>
-          <a:lstStyle/>
-          <a:p>
-            <a:pPr indent="0" marL="0">
-              <a:buNone/>
-            </a:pPr>
-            <a:r>
-              <a:rPr lang="en-US" sz="1800" dirty="0">
-                <a:solidFill>
-                  <a:srgbClr val="1EC98A"/>
-                </a:solidFill>
-                <a:latin typeface="Arial" pitchFamily="34" charset="0"/>
-                <a:ea typeface="Arial" pitchFamily="34" charset="-122"/>
-                <a:cs typeface="Arial" pitchFamily="34" charset="-120"/>
-              </a:rPr>
-              <a:t>The story: money moved — and I still had control.</a:t>
-            </a:r>
-            <a:endParaRPr lang="en-US" sz="1800" dirty="0"/>
-          </a:p>
-        </p:txBody>
-      </p:sp>
+              <a:t>Reachable. Self-explanatory.</a:t>
+            </a:r>
+            <a:endParaRPr lang="en-US" sz="2400" dirty="0"/>
+          </a:p>
+        </p:txBody>
+      </p:sp>
+      <p:pic>
+        <p:nvPicPr>
+          <p:cNvPr id="4" name="Image 0" descr="C:\Users\roten\Documents\reton\presentations\screenshots\05-contact.png">    </p:cNvPr>
+          <p:cNvPicPr>
+            <a:picLocks noChangeAspect="1"/>
+          </p:cNvPicPr>
+          <p:nvPr/>
+        </p:nvPicPr>
+        <p:blipFill>
+          <a:blip r:embed="rId1"/>
+          <a:stretch>
+            <a:fillRect/>
+          </a:stretch>
+        </p:blipFill>
+        <p:spPr>
+          <a:xfrm>
+            <a:off x="502920" y="1280160"/>
+            <a:ext cx="5486400" cy="4846320"/>
+          </a:xfrm>
+          <a:prstGeom prst="rect">
+            <a:avLst/>
+          </a:prstGeom>
+        </p:spPr>
+      </p:pic>
+      <p:pic>
+        <p:nvPicPr>
+          <p:cNvPr id="5" name="Image 1" descr="C:\Users\roten\Documents\reton\presentations\screenshots\06-faq.png">    </p:cNvPr>
+          <p:cNvPicPr>
+            <a:picLocks noChangeAspect="1"/>
+          </p:cNvPicPr>
+          <p:nvPr/>
+        </p:nvPicPr>
+        <p:blipFill>
+          <a:blip r:embed="rId2"/>
+          <a:stretch>
+            <a:fillRect/>
+          </a:stretch>
+        </p:blipFill>
+        <p:spPr>
+          <a:xfrm>
+            <a:off x="6172200" y="1280160"/>
+            <a:ext cx="5486400" cy="4846320"/>
+          </a:xfrm>
+          <a:prstGeom prst="rect">
+            <a:avLst/>
+          </a:prstGeom>
+        </p:spPr>
+      </p:pic>
     </p:spTree>
   </p:cSld>
   <p:clrMapOvr>
@@ -2873,7 +3081,7 @@
                 <a:ea typeface="Arial" pitchFamily="34" charset="-122"/>
                 <a:cs typeface="Arial" pitchFamily="34" charset="-120"/>
               </a:rPr>
-              <a:t>TEAM</a:t>
+              <a:t>WHY RETON</a:t>
             </a:r>
             <a:endParaRPr lang="en-US" sz="1100" dirty="0"/>
           </a:p>
@@ -2887,24 +3095,24 @@
         </p:nvSpPr>
         <p:spPr>
           <a:xfrm>
-            <a:off x="640080" y="822960"/>
-            <a:ext cx="10515600" cy="640080"/>
-          </a:xfrm>
-          <a:prstGeom prst="rect">
-            <a:avLst/>
-          </a:prstGeom>
-          <a:noFill/>
-          <a:ln/>
-        </p:spPr>
-        <p:txBody>
-          <a:bodyPr wrap="square" rtlCol="0" anchor="ctr"/>
-          <a:lstStyle/>
-          <a:p>
-            <a:pPr indent="0" marL="0">
-              <a:buNone/>
-            </a:pPr>
-            <a:r>
-              <a:rPr lang="en-US" sz="3200" b="1" dirty="0">
+            <a:off x="640080" y="777240"/>
+            <a:ext cx="10515600" cy="1280160"/>
+          </a:xfrm>
+          <a:prstGeom prst="rect">
+            <a:avLst/>
+          </a:prstGeom>
+          <a:noFill/>
+          <a:ln/>
+        </p:spPr>
+        <p:txBody>
+          <a:bodyPr wrap="square" rtlCol="0" anchor="ctr"/>
+          <a:lstStyle/>
+          <a:p>
+            <a:pPr indent="0" marL="0">
+              <a:buNone/>
+            </a:pPr>
+            <a:r>
+              <a:rPr lang="en-US" sz="3600" b="1" dirty="0">
                 <a:solidFill>
                   <a:srgbClr val="E8F3EE"/>
                 </a:solidFill>
@@ -2912,236 +3120,103 @@
                 <a:ea typeface="Arial" pitchFamily="34" charset="-122"/>
                 <a:cs typeface="Arial" pitchFamily="34" charset="-120"/>
               </a:rPr>
-              <a:t>RETON PTE LTD</a:t>
-            </a:r>
-            <a:endParaRPr lang="en-US" sz="3200" dirty="0"/>
-          </a:p>
-        </p:txBody>
-      </p:sp>
-      <p:sp>
-        <p:nvSpPr>
-          <p:cNvPr id="4" name="Shape 2"/>
-          <p:cNvSpPr/>
-          <p:nvPr/>
-        </p:nvSpPr>
-        <p:spPr>
-          <a:xfrm>
-            <a:off x="640080" y="1920240"/>
-            <a:ext cx="5029200" cy="1645920"/>
-          </a:xfrm>
-          <a:prstGeom prst="roundRect">
-            <a:avLst>
-              <a:gd name="adj" fmla="val 11111"/>
-            </a:avLst>
-          </a:prstGeom>
-          <a:solidFill>
-            <a:srgbClr val="0F211C"/>
-          </a:solidFill>
-          <a:ln/>
-        </p:spPr>
-      </p:sp>
-      <p:sp>
-        <p:nvSpPr>
-          <p:cNvPr id="5" name="Text 3"/>
-          <p:cNvSpPr/>
-          <p:nvPr/>
-        </p:nvSpPr>
-        <p:spPr>
-          <a:xfrm>
-            <a:off x="914400" y="2240280"/>
-            <a:ext cx="4572000" cy="411480"/>
-          </a:xfrm>
-          <a:prstGeom prst="rect">
-            <a:avLst/>
-          </a:prstGeom>
-          <a:noFill/>
-          <a:ln/>
-        </p:spPr>
-        <p:txBody>
-          <a:bodyPr wrap="square" rtlCol="0" anchor="ctr"/>
-          <a:lstStyle/>
-          <a:p>
-            <a:pPr indent="0" marL="0">
-              <a:buNone/>
-            </a:pPr>
-            <a:r>
-              <a:rPr lang="en-US" sz="1800" b="1" dirty="0">
+              <a:t>We’re not another wallet.</a:t>
+            </a:r>
+            <a:endParaRPr lang="en-US" sz="3600" dirty="0"/>
+          </a:p>
+        </p:txBody>
+      </p:sp>
+      <p:sp>
+        <p:nvSpPr>
+          <p:cNvPr id="4" name="Text 2"/>
+          <p:cNvSpPr/>
+          <p:nvPr/>
+        </p:nvSpPr>
+        <p:spPr>
+          <a:xfrm>
+            <a:off x="640080" y="2194560"/>
+            <a:ext cx="10515600" cy="3657600"/>
+          </a:xfrm>
+          <a:prstGeom prst="rect">
+            <a:avLst/>
+          </a:prstGeom>
+          <a:noFill/>
+          <a:ln/>
+        </p:spPr>
+        <p:txBody>
+          <a:bodyPr wrap="square" rtlCol="0" anchor="ctr"/>
+          <a:lstStyle/>
+          <a:p>
+            <a:pPr marL="342900" indent="-342900">
+              <a:buSzPct val="100000"/>
+              <a:buChar char="•"/>
+            </a:pPr>
+            <a:r>
+              <a:rPr lang="en-US" sz="2000" dirty="0">
                 <a:solidFill>
                   <a:srgbClr val="E8F3EE"/>
-                </a:solidFill>
-              </a:rPr>
-              <a:t>Gabriel Rotimi Mogaji</a:t>
-            </a:r>
-            <a:endParaRPr lang="en-US" sz="1800" dirty="0"/>
-          </a:p>
-        </p:txBody>
-      </p:sp>
-      <p:sp>
-        <p:nvSpPr>
-          <p:cNvPr id="6" name="Text 4"/>
-          <p:cNvSpPr/>
-          <p:nvPr/>
-        </p:nvSpPr>
-        <p:spPr>
-          <a:xfrm>
-            <a:off x="914400" y="2697480"/>
-            <a:ext cx="4572000" cy="365760"/>
-          </a:xfrm>
-          <a:prstGeom prst="rect">
-            <a:avLst/>
-          </a:prstGeom>
-          <a:noFill/>
-          <a:ln/>
-        </p:spPr>
-        <p:txBody>
-          <a:bodyPr wrap="square" rtlCol="0" anchor="ctr"/>
-          <a:lstStyle/>
-          <a:p>
-            <a:pPr indent="0" marL="0">
-              <a:buNone/>
-            </a:pPr>
-            <a:r>
-              <a:rPr lang="en-US" sz="1400" dirty="0">
-                <a:solidFill>
-                  <a:srgbClr val="8AA89D"/>
-                </a:solidFill>
-              </a:rPr>
-              <a:t>Founder &amp; CEO</a:t>
-            </a:r>
-            <a:endParaRPr lang="en-US" sz="1400" dirty="0"/>
-          </a:p>
-        </p:txBody>
-      </p:sp>
-      <p:sp>
-        <p:nvSpPr>
-          <p:cNvPr id="7" name="Shape 5"/>
-          <p:cNvSpPr/>
-          <p:nvPr/>
-        </p:nvSpPr>
-        <p:spPr>
-          <a:xfrm>
-            <a:off x="6035040" y="1920240"/>
-            <a:ext cx="5029200" cy="1645920"/>
-          </a:xfrm>
-          <a:prstGeom prst="roundRect">
-            <a:avLst>
-              <a:gd name="adj" fmla="val 11111"/>
-            </a:avLst>
-          </a:prstGeom>
-          <a:solidFill>
-            <a:srgbClr val="0F211C"/>
-          </a:solidFill>
-          <a:ln/>
-        </p:spPr>
-      </p:sp>
-      <p:sp>
-        <p:nvSpPr>
-          <p:cNvPr id="8" name="Text 6"/>
-          <p:cNvSpPr/>
-          <p:nvPr/>
-        </p:nvSpPr>
-        <p:spPr>
-          <a:xfrm>
-            <a:off x="6309360" y="2240280"/>
-            <a:ext cx="4572000" cy="411480"/>
-          </a:xfrm>
-          <a:prstGeom prst="rect">
-            <a:avLst/>
-          </a:prstGeom>
-          <a:noFill/>
-          <a:ln/>
-        </p:spPr>
-        <p:txBody>
-          <a:bodyPr wrap="square" rtlCol="0" anchor="ctr"/>
-          <a:lstStyle/>
-          <a:p>
-            <a:pPr indent="0" marL="0">
-              <a:buNone/>
-            </a:pPr>
-            <a:r>
-              <a:rPr lang="en-US" sz="1800" b="1" dirty="0">
-                <a:solidFill>
-                  <a:srgbClr val="E8F3EE"/>
-                </a:solidFill>
-              </a:rPr>
-              <a:t>Aina Christana Olajumoke</a:t>
-            </a:r>
-            <a:endParaRPr lang="en-US" sz="1800" dirty="0"/>
-          </a:p>
-        </p:txBody>
-      </p:sp>
-      <p:sp>
-        <p:nvSpPr>
-          <p:cNvPr id="9" name="Text 7"/>
-          <p:cNvSpPr/>
-          <p:nvPr/>
-        </p:nvSpPr>
-        <p:spPr>
-          <a:xfrm>
-            <a:off x="6309360" y="2697480"/>
-            <a:ext cx="4572000" cy="365760"/>
-          </a:xfrm>
-          <a:prstGeom prst="rect">
-            <a:avLst/>
-          </a:prstGeom>
-          <a:noFill/>
-          <a:ln/>
-        </p:spPr>
-        <p:txBody>
-          <a:bodyPr wrap="square" rtlCol="0" anchor="ctr"/>
-          <a:lstStyle/>
-          <a:p>
-            <a:pPr indent="0" marL="0">
-              <a:buNone/>
-            </a:pPr>
-            <a:r>
-              <a:rPr lang="en-US" sz="1400" dirty="0">
-                <a:solidFill>
-                  <a:srgbClr val="8AA89D"/>
-                </a:solidFill>
-              </a:rPr>
-              <a:t>Co-Founder</a:t>
-            </a:r>
-            <a:endParaRPr lang="en-US" sz="1400" dirty="0"/>
-          </a:p>
-        </p:txBody>
-      </p:sp>
-      <p:sp>
-        <p:nvSpPr>
-          <p:cNvPr id="10" name="Text 8"/>
-          <p:cNvSpPr/>
-          <p:nvPr/>
-        </p:nvSpPr>
-        <p:spPr>
-          <a:xfrm>
-            <a:off x="640080" y="4114800"/>
-            <a:ext cx="10058400" cy="1097280"/>
-          </a:xfrm>
-          <a:prstGeom prst="rect">
-            <a:avLst/>
-          </a:prstGeom>
-          <a:noFill/>
-          <a:ln/>
-        </p:spPr>
-        <p:txBody>
-          <a:bodyPr wrap="square" rtlCol="0" anchor="ctr"/>
-          <a:lstStyle/>
-          <a:p>
-            <a:pPr indent="0" marL="0">
-              <a:buNone/>
-            </a:pPr>
-            <a:r>
-              <a:rPr lang="en-US" sz="1800" dirty="0">
-                <a:solidFill>
-                  <a:srgbClr val="8AA89D"/>
                 </a:solidFill>
                 <a:latin typeface="Arial" pitchFamily="34" charset="0"/>
                 <a:ea typeface="Arial" pitchFamily="34" charset="-122"/>
                 <a:cs typeface="Arial" pitchFamily="34" charset="-120"/>
               </a:rPr>
-              <a:t>Building Africa’s trust-first payment platform — one protected transfer at a time.</a:t>
-            </a:r>
-            <a:endParaRPr lang="en-US" sz="1800" dirty="0"/>
+              <a:t>Trust layer — protection and recovery are the product.</a:t>
+            </a:r>
+            <a:endParaRPr lang="en-US" sz="2000" dirty="0"/>
+          </a:p>
+          <a:p>
+            <a:pPr marL="342900" indent="-342900">
+              <a:buSzPct val="100000"/>
+              <a:buChar char="•"/>
+            </a:pPr>
+            <a:r>
+              <a:rPr lang="en-US" sz="2000" dirty="0">
+                <a:solidFill>
+                  <a:srgbClr val="E8F3EE"/>
+                </a:solidFill>
+                <a:latin typeface="Arial" pitchFamily="34" charset="0"/>
+                <a:ea typeface="Arial" pitchFamily="34" charset="-122"/>
+                <a:cs typeface="Arial" pitchFamily="34" charset="-120"/>
+              </a:rPr>
+              <a:t>Visible timeline — every money event is explainable.</a:t>
+            </a:r>
+            <a:endParaRPr lang="en-US" sz="2000" dirty="0"/>
+          </a:p>
+          <a:p>
+            <a:pPr marL="342900" indent="-342900">
+              <a:buSzPct val="100000"/>
+              <a:buChar char="•"/>
+            </a:pPr>
+            <a:r>
+              <a:rPr lang="en-US" sz="2000" dirty="0">
+                <a:solidFill>
+                  <a:srgbClr val="E8F3EE"/>
+                </a:solidFill>
+                <a:latin typeface="Arial" pitchFamily="34" charset="0"/>
+                <a:ea typeface="Arial" pitchFamily="34" charset="-122"/>
+                <a:cs typeface="Arial" pitchFamily="34" charset="-120"/>
+              </a:rPr>
+              <a:t>Licensed settlement — ALATPay / Wema.</a:t>
+            </a:r>
+            <a:endParaRPr lang="en-US" sz="2000" dirty="0"/>
+          </a:p>
+          <a:p>
+            <a:pPr marL="342900" indent="-342900">
+              <a:buSzPct val="100000"/>
+              <a:buChar char="•"/>
+            </a:pPr>
+            <a:r>
+              <a:rPr lang="en-US" sz="2000" dirty="0">
+                <a:solidFill>
+                  <a:srgbClr val="E8F3EE"/>
+                </a:solidFill>
+                <a:latin typeface="Arial" pitchFamily="34" charset="0"/>
+                <a:ea typeface="Arial" pitchFamily="34" charset="-122"/>
+                <a:cs typeface="Arial" pitchFamily="34" charset="-120"/>
+              </a:rPr>
+              <a:t>Production mindset — signed webhooks, PINs, encrypted secrets, audited admin.</a:t>
+            </a:r>
+            <a:endParaRPr lang="en-US" sz="2000" dirty="0"/>
           </a:p>
         </p:txBody>
       </p:sp>
@@ -3185,6 +3260,604 @@
         </p:nvSpPr>
         <p:spPr>
           <a:xfrm>
+            <a:off x="640080" y="411480"/>
+            <a:ext cx="10972800" cy="274320"/>
+          </a:xfrm>
+          <a:prstGeom prst="rect">
+            <a:avLst/>
+          </a:prstGeom>
+          <a:noFill/>
+          <a:ln/>
+        </p:spPr>
+        <p:txBody>
+          <a:bodyPr wrap="square" rtlCol="0" anchor="ctr"/>
+          <a:lstStyle/>
+          <a:p>
+            <a:pPr indent="0" marL="0">
+              <a:buNone/>
+            </a:pPr>
+            <a:r>
+              <a:rPr lang="en-US" sz="1100" b="1" spc="300" kern="0" dirty="0">
+                <a:solidFill>
+                  <a:srgbClr val="1EC98A"/>
+                </a:solidFill>
+                <a:latin typeface="Arial" pitchFamily="34" charset="0"/>
+                <a:ea typeface="Arial" pitchFamily="34" charset="-122"/>
+                <a:cs typeface="Arial" pitchFamily="34" charset="-120"/>
+              </a:rPr>
+              <a:t>DEMO IN 90 SECONDS</a:t>
+            </a:r>
+            <a:endParaRPr lang="en-US" sz="1100" dirty="0"/>
+          </a:p>
+        </p:txBody>
+      </p:sp>
+      <p:sp>
+        <p:nvSpPr>
+          <p:cNvPr id="3" name="Text 1"/>
+          <p:cNvSpPr/>
+          <p:nvPr/>
+        </p:nvSpPr>
+        <p:spPr>
+          <a:xfrm>
+            <a:off x="640080" y="777240"/>
+            <a:ext cx="10515600" cy="640080"/>
+          </a:xfrm>
+          <a:prstGeom prst="rect">
+            <a:avLst/>
+          </a:prstGeom>
+          <a:noFill/>
+          <a:ln/>
+        </p:spPr>
+        <p:txBody>
+          <a:bodyPr wrap="square" rtlCol="0" anchor="ctr"/>
+          <a:lstStyle/>
+          <a:p>
+            <a:pPr indent="0" marL="0">
+              <a:buNone/>
+            </a:pPr>
+            <a:r>
+              <a:rPr lang="en-US" sz="3200" b="1" dirty="0">
+                <a:solidFill>
+                  <a:srgbClr val="E8F3EE"/>
+                </a:solidFill>
+                <a:latin typeface="Arial" pitchFamily="34" charset="0"/>
+                <a:ea typeface="Arial" pitchFamily="34" charset="-122"/>
+                <a:cs typeface="Arial" pitchFamily="34" charset="-120"/>
+              </a:rPr>
+              <a:t>Show, don’t tell.</a:t>
+            </a:r>
+            <a:endParaRPr lang="en-US" sz="3200" dirty="0"/>
+          </a:p>
+        </p:txBody>
+      </p:sp>
+      <p:sp>
+        <p:nvSpPr>
+          <p:cNvPr id="4" name="Text 2"/>
+          <p:cNvSpPr/>
+          <p:nvPr/>
+        </p:nvSpPr>
+        <p:spPr>
+          <a:xfrm>
+            <a:off x="640080" y="1737360"/>
+            <a:ext cx="10515600" cy="3657600"/>
+          </a:xfrm>
+          <a:prstGeom prst="rect">
+            <a:avLst/>
+          </a:prstGeom>
+          <a:noFill/>
+          <a:ln/>
+        </p:spPr>
+        <p:txBody>
+          <a:bodyPr wrap="square" rtlCol="0" anchor="ctr"/>
+          <a:lstStyle/>
+          <a:p>
+            <a:pPr marL="342900" indent="-342900">
+              <a:buSzPct val="100000"/>
+              <a:buChar char="•"/>
+            </a:pPr>
+            <a:r>
+              <a:rPr lang="en-US" sz="2000" dirty="0">
+                <a:solidFill>
+                  <a:srgbClr val="E8F3EE"/>
+                </a:solidFill>
+                <a:latin typeface="Arial" pitchFamily="34" charset="0"/>
+                <a:ea typeface="Arial" pitchFamily="34" charset="-122"/>
+                <a:cs typeface="Arial" pitchFamily="34" charset="-120"/>
+              </a:rPr>
+              <a:t>Open a wallet — balance &amp; KYC tier</a:t>
+            </a:r>
+            <a:endParaRPr lang="en-US" sz="2000" dirty="0"/>
+          </a:p>
+          <a:p>
+            <a:pPr marL="342900" indent="-342900">
+              <a:buSzPct val="100000"/>
+              <a:buChar char="•"/>
+            </a:pPr>
+            <a:r>
+              <a:rPr lang="en-US" sz="2000" dirty="0">
+                <a:solidFill>
+                  <a:srgbClr val="E8F3EE"/>
+                </a:solidFill>
+                <a:latin typeface="Arial" pitchFamily="34" charset="0"/>
+                <a:ea typeface="Arial" pitchFamily="34" charset="-122"/>
+                <a:cs typeface="Arial" pitchFamily="34" charset="-120"/>
+              </a:rPr>
+              <a:t>Send a protected transfer</a:t>
+            </a:r>
+            <a:endParaRPr lang="en-US" sz="2000" dirty="0"/>
+          </a:p>
+          <a:p>
+            <a:pPr marL="342900" indent="-342900">
+              <a:buSzPct val="100000"/>
+              <a:buChar char="•"/>
+            </a:pPr>
+            <a:r>
+              <a:rPr lang="en-US" sz="2000" dirty="0">
+                <a:solidFill>
+                  <a:srgbClr val="E8F3EE"/>
+                </a:solidFill>
+                <a:latin typeface="Arial" pitchFamily="34" charset="0"/>
+                <a:ea typeface="Arial" pitchFamily="34" charset="-122"/>
+                <a:cs typeface="Arial" pitchFamily="34" charset="-120"/>
+              </a:rPr>
+              <a:t>Receiver sees Payment Protected</a:t>
+            </a:r>
+            <a:endParaRPr lang="en-US" sz="2000" dirty="0"/>
+          </a:p>
+          <a:p>
+            <a:pPr marL="342900" indent="-342900">
+              <a:buSzPct val="100000"/>
+              <a:buChar char="•"/>
+            </a:pPr>
+            <a:r>
+              <a:rPr lang="en-US" sz="2000" dirty="0">
+                <a:solidFill>
+                  <a:srgbClr val="E8F3EE"/>
+                </a:solidFill>
+                <a:latin typeface="Arial" pitchFamily="34" charset="0"/>
+                <a:ea typeface="Arial" pitchFamily="34" charset="-122"/>
+                <a:cs typeface="Arial" pitchFamily="34" charset="-120"/>
+              </a:rPr>
+              <a:t>Request callback — timeline updates live</a:t>
+            </a:r>
+            <a:endParaRPr lang="en-US" sz="2000" dirty="0"/>
+          </a:p>
+          <a:p>
+            <a:pPr marL="342900" indent="-342900">
+              <a:buSzPct val="100000"/>
+              <a:buChar char="•"/>
+            </a:pPr>
+            <a:r>
+              <a:rPr lang="en-US" sz="2000" dirty="0">
+                <a:solidFill>
+                  <a:srgbClr val="E8F3EE"/>
+                </a:solidFill>
+                <a:latin typeface="Arial" pitchFamily="34" charset="0"/>
+                <a:ea typeface="Arial" pitchFamily="34" charset="-122"/>
+                <a:cs typeface="Arial" pitchFamily="34" charset="-120"/>
+              </a:rPr>
+              <a:t>Optional: recovery case or admin fraud view</a:t>
+            </a:r>
+            <a:endParaRPr lang="en-US" sz="2000" dirty="0"/>
+          </a:p>
+        </p:txBody>
+      </p:sp>
+      <p:sp>
+        <p:nvSpPr>
+          <p:cNvPr id="5" name="Text 3"/>
+          <p:cNvSpPr/>
+          <p:nvPr/>
+        </p:nvSpPr>
+        <p:spPr>
+          <a:xfrm>
+            <a:off x="640080" y="5029200"/>
+            <a:ext cx="10058400" cy="1097280"/>
+          </a:xfrm>
+          <a:prstGeom prst="rect">
+            <a:avLst/>
+          </a:prstGeom>
+          <a:noFill/>
+          <a:ln/>
+        </p:spPr>
+        <p:txBody>
+          <a:bodyPr wrap="square" rtlCol="0" anchor="ctr"/>
+          <a:lstStyle/>
+          <a:p>
+            <a:pPr indent="0" marL="0">
+              <a:buNone/>
+            </a:pPr>
+            <a:r>
+              <a:rPr lang="en-US" sz="1800" dirty="0">
+                <a:solidFill>
+                  <a:srgbClr val="1EC98A"/>
+                </a:solidFill>
+                <a:latin typeface="Arial" pitchFamily="34" charset="0"/>
+                <a:ea typeface="Arial" pitchFamily="34" charset="-122"/>
+                <a:cs typeface="Arial" pitchFamily="34" charset="-120"/>
+              </a:rPr>
+              <a:t>The story: money moved — and I still had control.</a:t>
+            </a:r>
+            <a:endParaRPr lang="en-US" sz="1800" dirty="0"/>
+          </a:p>
+        </p:txBody>
+      </p:sp>
+    </p:spTree>
+  </p:cSld>
+  <p:clrMapOvr>
+    <a:masterClrMapping/>
+  </p:clrMapOvr>
+</p:sld>
+</file>
+
+<file path=ppt/slides/slide15.xml><?xml version="1.0" encoding="utf-8"?>
+<p:sld xmlns:a="http://schemas.openxmlformats.org/drawingml/2006/main" xmlns:r="http://schemas.openxmlformats.org/officeDocument/2006/relationships" xmlns:p="http://schemas.openxmlformats.org/presentationml/2006/main">
+  <p:cSld name="Slide 15">
+    <p:bg>
+      <p:bgPr>
+        <a:solidFill>
+          <a:srgbClr val="071612"/>
+        </a:solidFill>
+      </p:bgPr>
+    </p:bg>
+    <p:spTree>
+      <p:nvGrpSpPr>
+        <p:cNvPr id="1" name=""/>
+        <p:cNvGrpSpPr/>
+        <p:nvPr/>
+      </p:nvGrpSpPr>
+      <p:grpSpPr>
+        <a:xfrm>
+          <a:off x="0" y="0"/>
+          <a:ext cx="0" cy="0"/>
+          <a:chOff x="0" y="0"/>
+          <a:chExt cx="0" cy="0"/>
+        </a:xfrm>
+      </p:grpSpPr>
+      <p:sp>
+        <p:nvSpPr>
+          <p:cNvPr id="2" name="Text 0"/>
+          <p:cNvSpPr/>
+          <p:nvPr/>
+        </p:nvSpPr>
+        <p:spPr>
+          <a:xfrm>
+            <a:off x="640080" y="411480"/>
+            <a:ext cx="10972800" cy="274320"/>
+          </a:xfrm>
+          <a:prstGeom prst="rect">
+            <a:avLst/>
+          </a:prstGeom>
+          <a:noFill/>
+          <a:ln/>
+        </p:spPr>
+        <p:txBody>
+          <a:bodyPr wrap="square" rtlCol="0" anchor="ctr"/>
+          <a:lstStyle/>
+          <a:p>
+            <a:pPr indent="0" marL="0">
+              <a:buNone/>
+            </a:pPr>
+            <a:r>
+              <a:rPr lang="en-US" sz="1100" b="1" spc="300" kern="0" dirty="0">
+                <a:solidFill>
+                  <a:srgbClr val="1EC98A"/>
+                </a:solidFill>
+                <a:latin typeface="Arial" pitchFamily="34" charset="0"/>
+                <a:ea typeface="Arial" pitchFamily="34" charset="-122"/>
+                <a:cs typeface="Arial" pitchFamily="34" charset="-120"/>
+              </a:rPr>
+              <a:t>TEAM</a:t>
+            </a:r>
+            <a:endParaRPr lang="en-US" sz="1100" dirty="0"/>
+          </a:p>
+        </p:txBody>
+      </p:sp>
+      <p:sp>
+        <p:nvSpPr>
+          <p:cNvPr id="3" name="Text 1"/>
+          <p:cNvSpPr/>
+          <p:nvPr/>
+        </p:nvSpPr>
+        <p:spPr>
+          <a:xfrm>
+            <a:off x="640080" y="822960"/>
+            <a:ext cx="10515600" cy="640080"/>
+          </a:xfrm>
+          <a:prstGeom prst="rect">
+            <a:avLst/>
+          </a:prstGeom>
+          <a:noFill/>
+          <a:ln/>
+        </p:spPr>
+        <p:txBody>
+          <a:bodyPr wrap="square" rtlCol="0" anchor="ctr"/>
+          <a:lstStyle/>
+          <a:p>
+            <a:pPr indent="0" marL="0">
+              <a:buNone/>
+            </a:pPr>
+            <a:r>
+              <a:rPr lang="en-US" sz="3200" b="1" dirty="0">
+                <a:solidFill>
+                  <a:srgbClr val="E8F3EE"/>
+                </a:solidFill>
+                <a:latin typeface="Arial" pitchFamily="34" charset="0"/>
+                <a:ea typeface="Arial" pitchFamily="34" charset="-122"/>
+                <a:cs typeface="Arial" pitchFamily="34" charset="-120"/>
+              </a:rPr>
+              <a:t>RETON PTE LTD</a:t>
+            </a:r>
+            <a:endParaRPr lang="en-US" sz="3200" dirty="0"/>
+          </a:p>
+        </p:txBody>
+      </p:sp>
+      <p:sp>
+        <p:nvSpPr>
+          <p:cNvPr id="4" name="Shape 2"/>
+          <p:cNvSpPr/>
+          <p:nvPr/>
+        </p:nvSpPr>
+        <p:spPr>
+          <a:xfrm>
+            <a:off x="640080" y="1920240"/>
+            <a:ext cx="5029200" cy="1645920"/>
+          </a:xfrm>
+          <a:prstGeom prst="roundRect">
+            <a:avLst>
+              <a:gd name="adj" fmla="val 11111"/>
+            </a:avLst>
+          </a:prstGeom>
+          <a:solidFill>
+            <a:srgbClr val="0F211C"/>
+          </a:solidFill>
+          <a:ln/>
+        </p:spPr>
+      </p:sp>
+      <p:sp>
+        <p:nvSpPr>
+          <p:cNvPr id="5" name="Text 3"/>
+          <p:cNvSpPr/>
+          <p:nvPr/>
+        </p:nvSpPr>
+        <p:spPr>
+          <a:xfrm>
+            <a:off x="914400" y="2240280"/>
+            <a:ext cx="4572000" cy="411480"/>
+          </a:xfrm>
+          <a:prstGeom prst="rect">
+            <a:avLst/>
+          </a:prstGeom>
+          <a:noFill/>
+          <a:ln/>
+        </p:spPr>
+        <p:txBody>
+          <a:bodyPr wrap="square" rtlCol="0" anchor="ctr"/>
+          <a:lstStyle/>
+          <a:p>
+            <a:pPr indent="0" marL="0">
+              <a:buNone/>
+            </a:pPr>
+            <a:r>
+              <a:rPr lang="en-US" sz="1800" b="1" dirty="0">
+                <a:solidFill>
+                  <a:srgbClr val="E8F3EE"/>
+                </a:solidFill>
+              </a:rPr>
+              <a:t>Gabriel Rotimi Mogaji</a:t>
+            </a:r>
+            <a:endParaRPr lang="en-US" sz="1800" dirty="0"/>
+          </a:p>
+        </p:txBody>
+      </p:sp>
+      <p:sp>
+        <p:nvSpPr>
+          <p:cNvPr id="6" name="Text 4"/>
+          <p:cNvSpPr/>
+          <p:nvPr/>
+        </p:nvSpPr>
+        <p:spPr>
+          <a:xfrm>
+            <a:off x="914400" y="2697480"/>
+            <a:ext cx="4572000" cy="365760"/>
+          </a:xfrm>
+          <a:prstGeom prst="rect">
+            <a:avLst/>
+          </a:prstGeom>
+          <a:noFill/>
+          <a:ln/>
+        </p:spPr>
+        <p:txBody>
+          <a:bodyPr wrap="square" rtlCol="0" anchor="ctr"/>
+          <a:lstStyle/>
+          <a:p>
+            <a:pPr indent="0" marL="0">
+              <a:buNone/>
+            </a:pPr>
+            <a:r>
+              <a:rPr lang="en-US" sz="1400" dirty="0">
+                <a:solidFill>
+                  <a:srgbClr val="8AA89D"/>
+                </a:solidFill>
+              </a:rPr>
+              <a:t>Founder &amp; CEO</a:t>
+            </a:r>
+            <a:endParaRPr lang="en-US" sz="1400" dirty="0"/>
+          </a:p>
+        </p:txBody>
+      </p:sp>
+      <p:sp>
+        <p:nvSpPr>
+          <p:cNvPr id="7" name="Shape 5"/>
+          <p:cNvSpPr/>
+          <p:nvPr/>
+        </p:nvSpPr>
+        <p:spPr>
+          <a:xfrm>
+            <a:off x="6035040" y="1920240"/>
+            <a:ext cx="5029200" cy="1645920"/>
+          </a:xfrm>
+          <a:prstGeom prst="roundRect">
+            <a:avLst>
+              <a:gd name="adj" fmla="val 11111"/>
+            </a:avLst>
+          </a:prstGeom>
+          <a:solidFill>
+            <a:srgbClr val="0F211C"/>
+          </a:solidFill>
+          <a:ln/>
+        </p:spPr>
+      </p:sp>
+      <p:sp>
+        <p:nvSpPr>
+          <p:cNvPr id="8" name="Text 6"/>
+          <p:cNvSpPr/>
+          <p:nvPr/>
+        </p:nvSpPr>
+        <p:spPr>
+          <a:xfrm>
+            <a:off x="6309360" y="2240280"/>
+            <a:ext cx="4572000" cy="411480"/>
+          </a:xfrm>
+          <a:prstGeom prst="rect">
+            <a:avLst/>
+          </a:prstGeom>
+          <a:noFill/>
+          <a:ln/>
+        </p:spPr>
+        <p:txBody>
+          <a:bodyPr wrap="square" rtlCol="0" anchor="ctr"/>
+          <a:lstStyle/>
+          <a:p>
+            <a:pPr indent="0" marL="0">
+              <a:buNone/>
+            </a:pPr>
+            <a:r>
+              <a:rPr lang="en-US" sz="1800" b="1" dirty="0">
+                <a:solidFill>
+                  <a:srgbClr val="E8F3EE"/>
+                </a:solidFill>
+              </a:rPr>
+              <a:t>Aina Christana Olajumoke</a:t>
+            </a:r>
+            <a:endParaRPr lang="en-US" sz="1800" dirty="0"/>
+          </a:p>
+        </p:txBody>
+      </p:sp>
+      <p:sp>
+        <p:nvSpPr>
+          <p:cNvPr id="9" name="Text 7"/>
+          <p:cNvSpPr/>
+          <p:nvPr/>
+        </p:nvSpPr>
+        <p:spPr>
+          <a:xfrm>
+            <a:off x="6309360" y="2697480"/>
+            <a:ext cx="4572000" cy="365760"/>
+          </a:xfrm>
+          <a:prstGeom prst="rect">
+            <a:avLst/>
+          </a:prstGeom>
+          <a:noFill/>
+          <a:ln/>
+        </p:spPr>
+        <p:txBody>
+          <a:bodyPr wrap="square" rtlCol="0" anchor="ctr"/>
+          <a:lstStyle/>
+          <a:p>
+            <a:pPr indent="0" marL="0">
+              <a:buNone/>
+            </a:pPr>
+            <a:r>
+              <a:rPr lang="en-US" sz="1400" dirty="0">
+                <a:solidFill>
+                  <a:srgbClr val="8AA89D"/>
+                </a:solidFill>
+              </a:rPr>
+              <a:t>Co-Founder</a:t>
+            </a:r>
+            <a:endParaRPr lang="en-US" sz="1400" dirty="0"/>
+          </a:p>
+        </p:txBody>
+      </p:sp>
+      <p:sp>
+        <p:nvSpPr>
+          <p:cNvPr id="10" name="Text 8"/>
+          <p:cNvSpPr/>
+          <p:nvPr/>
+        </p:nvSpPr>
+        <p:spPr>
+          <a:xfrm>
+            <a:off x="640080" y="4114800"/>
+            <a:ext cx="10058400" cy="1097280"/>
+          </a:xfrm>
+          <a:prstGeom prst="rect">
+            <a:avLst/>
+          </a:prstGeom>
+          <a:noFill/>
+          <a:ln/>
+        </p:spPr>
+        <p:txBody>
+          <a:bodyPr wrap="square" rtlCol="0" anchor="ctr"/>
+          <a:lstStyle/>
+          <a:p>
+            <a:pPr indent="0" marL="0">
+              <a:buNone/>
+            </a:pPr>
+            <a:r>
+              <a:rPr lang="en-US" sz="1800" dirty="0">
+                <a:solidFill>
+                  <a:srgbClr val="8AA89D"/>
+                </a:solidFill>
+                <a:latin typeface="Arial" pitchFamily="34" charset="0"/>
+                <a:ea typeface="Arial" pitchFamily="34" charset="-122"/>
+                <a:cs typeface="Arial" pitchFamily="34" charset="-120"/>
+              </a:rPr>
+              <a:t>Building Africa’s trust-first payment platform — one protected transfer at a time.</a:t>
+            </a:r>
+            <a:endParaRPr lang="en-US" sz="1800" dirty="0"/>
+          </a:p>
+        </p:txBody>
+      </p:sp>
+    </p:spTree>
+  </p:cSld>
+  <p:clrMapOvr>
+    <a:masterClrMapping/>
+  </p:clrMapOvr>
+</p:sld>
+</file>
+
+<file path=ppt/slides/slide16.xml><?xml version="1.0" encoding="utf-8"?>
+<p:sld xmlns:a="http://schemas.openxmlformats.org/drawingml/2006/main" xmlns:r="http://schemas.openxmlformats.org/officeDocument/2006/relationships" xmlns:p="http://schemas.openxmlformats.org/presentationml/2006/main">
+  <p:cSld name="Slide 16">
+    <p:bg>
+      <p:bgPr>
+        <a:solidFill>
+          <a:srgbClr val="071612"/>
+        </a:solidFill>
+      </p:bgPr>
+    </p:bg>
+    <p:spTree>
+      <p:nvGrpSpPr>
+        <p:cNvPr id="1" name=""/>
+        <p:cNvGrpSpPr/>
+        <p:nvPr/>
+      </p:nvGrpSpPr>
+      <p:grpSpPr>
+        <a:xfrm>
+          <a:off x="0" y="0"/>
+          <a:ext cx="0" cy="0"/>
+          <a:chOff x="0" y="0"/>
+          <a:chExt cx="0" cy="0"/>
+        </a:xfrm>
+      </p:grpSpPr>
+      <p:sp>
+        <p:nvSpPr>
+          <p:cNvPr id="2" name="Text 0"/>
+          <p:cNvSpPr/>
+          <p:nvPr/>
+        </p:nvSpPr>
+        <p:spPr>
+          <a:xfrm>
             <a:off x="640080" y="1645920"/>
             <a:ext cx="5486400" cy="320040"/>
           </a:xfrm>
@@ -3633,7 +4306,7 @@
                 <a:ea typeface="Arial" pitchFamily="34" charset="-122"/>
                 <a:cs typeface="Arial" pitchFamily="34" charset="-120"/>
               </a:rPr>
-              <a:t>THE INSIGHT</a:t>
+              <a:t>WHY THIS IS REAL</a:t>
             </a:r>
             <a:endParaRPr lang="en-US" sz="1100" dirty="0"/>
           </a:p>
@@ -3647,8 +4320,8 @@
         </p:nvSpPr>
         <p:spPr>
           <a:xfrm>
-            <a:off x="640080" y="1645920"/>
-            <a:ext cx="10515600" cy="2011680"/>
+            <a:off x="640080" y="777240"/>
+            <a:ext cx="10515600" cy="1188720"/>
           </a:xfrm>
           <a:prstGeom prst="rect">
             <a:avLst/>
@@ -3672,7 +4345,7 @@
                 <a:ea typeface="Arial" pitchFamily="34" charset="-122"/>
                 <a:cs typeface="Arial" pitchFamily="34" charset="-120"/>
               </a:rPr>
-              <a:t>Trust isn’t a badge on the login screen.</a:t>
+              <a:t>When money leaves…</a:t>
             </a:r>
             <a:endParaRPr lang="en-US" sz="3000" dirty="0"/>
           </a:p>
@@ -3689,7 +4362,7 @@
                 <a:ea typeface="Arial" pitchFamily="34" charset="-122"/>
                 <a:cs typeface="Arial" pitchFamily="34" charset="-120"/>
               </a:rPr>
-              <a:t>It’s what happens after the money moves.</a:t>
+              <a:t>getting it back is a war.</a:t>
             </a:r>
             <a:endParaRPr lang="en-US" sz="3000" dirty="0"/>
           </a:p>
@@ -3703,24 +4376,24 @@
         </p:nvSpPr>
         <p:spPr>
           <a:xfrm>
-            <a:off x="640080" y="4023360"/>
-            <a:ext cx="10058400" cy="1097280"/>
-          </a:xfrm>
-          <a:prstGeom prst="rect">
-            <a:avLst/>
-          </a:prstGeom>
-          <a:noFill/>
-          <a:ln/>
-        </p:spPr>
-        <p:txBody>
-          <a:bodyPr wrap="square" rtlCol="0" anchor="ctr"/>
-          <a:lstStyle/>
-          <a:p>
-            <a:pPr indent="0" marL="0">
-              <a:buNone/>
-            </a:pPr>
-            <a:r>
-              <a:rPr lang="en-US" sz="1800" dirty="0">
+            <a:off x="640080" y="2103120"/>
+            <a:ext cx="10058400" cy="1463040"/>
+          </a:xfrm>
+          <a:prstGeom prst="rect">
+            <a:avLst/>
+          </a:prstGeom>
+          <a:noFill/>
+          <a:ln/>
+        </p:spPr>
+        <p:txBody>
+          <a:bodyPr wrap="square" rtlCol="0" anchor="ctr"/>
+          <a:lstStyle/>
+          <a:p>
+            <a:pPr indent="0" marL="0">
+              <a:buNone/>
+            </a:pPr>
+            <a:r>
+              <a:rPr lang="en-US" sz="1600" dirty="0">
                 <a:solidFill>
                   <a:srgbClr val="8AA89D"/>
                 </a:solidFill>
@@ -3728,9 +4401,197 @@
                 <a:ea typeface="Arial" pitchFamily="34" charset="-122"/>
                 <a:cs typeface="Arial" pitchFamily="34" charset="-120"/>
               </a:rPr>
-              <a:t>Reton is built for the moment something goes wrong — not just the moment you hit send.</a:t>
-            </a:r>
-            <a:endParaRPr lang="en-US" sz="1800" dirty="0"/>
+              <a:t>In 2024, about ₦95 million was pulled from a company’s account without permission. Banks rushed “block and recall.” Freezes often last only 72 hours. A court later ordered the money returned — and reversing it still became a legal fight.</a:t>
+            </a:r>
+            <a:endParaRPr lang="en-US" sz="1600" dirty="0"/>
+          </a:p>
+        </p:txBody>
+      </p:sp>
+      <p:sp>
+        <p:nvSpPr>
+          <p:cNvPr id="5" name="Shape 3"/>
+          <p:cNvSpPr/>
+          <p:nvPr/>
+        </p:nvSpPr>
+        <p:spPr>
+          <a:xfrm>
+            <a:off x="640080" y="3749040"/>
+            <a:ext cx="5212080" cy="2103120"/>
+          </a:xfrm>
+          <a:prstGeom prst="roundRect">
+            <a:avLst>
+              <a:gd name="adj" fmla="val 8696"/>
+            </a:avLst>
+          </a:prstGeom>
+          <a:solidFill>
+            <a:srgbClr val="0F211C"/>
+          </a:solidFill>
+          <a:ln/>
+        </p:spPr>
+      </p:sp>
+      <p:sp>
+        <p:nvSpPr>
+          <p:cNvPr id="6" name="Text 4"/>
+          <p:cNvSpPr/>
+          <p:nvPr/>
+        </p:nvSpPr>
+        <p:spPr>
+          <a:xfrm>
+            <a:off x="914400" y="3977640"/>
+            <a:ext cx="4663440" cy="365760"/>
+          </a:xfrm>
+          <a:prstGeom prst="rect">
+            <a:avLst/>
+          </a:prstGeom>
+          <a:noFill/>
+          <a:ln/>
+        </p:spPr>
+        <p:txBody>
+          <a:bodyPr wrap="square" rtlCol="0" anchor="ctr"/>
+          <a:lstStyle/>
+          <a:p>
+            <a:pPr indent="0" marL="0">
+              <a:buNone/>
+            </a:pPr>
+            <a:r>
+              <a:rPr lang="en-US" sz="1500" b="1" dirty="0">
+                <a:solidFill>
+                  <a:srgbClr val="E8F3EE"/>
+                </a:solidFill>
+              </a:rPr>
+              <a:t>How it works today</a:t>
+            </a:r>
+            <a:endParaRPr lang="en-US" sz="1500" dirty="0"/>
+          </a:p>
+        </p:txBody>
+      </p:sp>
+      <p:sp>
+        <p:nvSpPr>
+          <p:cNvPr id="7" name="Text 5"/>
+          <p:cNvSpPr/>
+          <p:nvPr/>
+        </p:nvSpPr>
+        <p:spPr>
+          <a:xfrm>
+            <a:off x="914400" y="4434840"/>
+            <a:ext cx="4663440" cy="1097280"/>
+          </a:xfrm>
+          <a:prstGeom prst="rect">
+            <a:avLst/>
+          </a:prstGeom>
+          <a:noFill/>
+          <a:ln/>
+        </p:spPr>
+        <p:txBody>
+          <a:bodyPr wrap="square" rtlCol="0" anchor="ctr"/>
+          <a:lstStyle/>
+          <a:p>
+            <a:pPr indent="0" marL="0">
+              <a:buNone/>
+            </a:pPr>
+            <a:r>
+              <a:rPr lang="en-US" sz="1400" dirty="0">
+                <a:solidFill>
+                  <a:srgbClr val="8AA89D"/>
+                </a:solidFill>
+              </a:rPr>
+              <a:t>Money flies out → hope a freeze works → race the clock → maybe a court → maybe nothing comes back.</a:t>
+            </a:r>
+            <a:endParaRPr lang="en-US" sz="1400" dirty="0"/>
+          </a:p>
+        </p:txBody>
+      </p:sp>
+      <p:sp>
+        <p:nvSpPr>
+          <p:cNvPr id="8" name="Shape 6"/>
+          <p:cNvSpPr/>
+          <p:nvPr/>
+        </p:nvSpPr>
+        <p:spPr>
+          <a:xfrm>
+            <a:off x="6126480" y="3749040"/>
+            <a:ext cx="5212080" cy="2103120"/>
+          </a:xfrm>
+          <a:prstGeom prst="roundRect">
+            <a:avLst>
+              <a:gd name="adj" fmla="val 8696"/>
+            </a:avLst>
+          </a:prstGeom>
+          <a:solidFill>
+            <a:srgbClr val="0F211C"/>
+          </a:solidFill>
+          <a:ln/>
+        </p:spPr>
+      </p:sp>
+      <p:sp>
+        <p:nvSpPr>
+          <p:cNvPr id="9" name="Text 7"/>
+          <p:cNvSpPr/>
+          <p:nvPr/>
+        </p:nvSpPr>
+        <p:spPr>
+          <a:xfrm>
+            <a:off x="6400800" y="3977640"/>
+            <a:ext cx="4663440" cy="365760"/>
+          </a:xfrm>
+          <a:prstGeom prst="rect">
+            <a:avLst/>
+          </a:prstGeom>
+          <a:noFill/>
+          <a:ln/>
+        </p:spPr>
+        <p:txBody>
+          <a:bodyPr wrap="square" rtlCol="0" anchor="ctr"/>
+          <a:lstStyle/>
+          <a:p>
+            <a:pPr indent="0" marL="0">
+              <a:buNone/>
+            </a:pPr>
+            <a:r>
+              <a:rPr lang="en-US" sz="1500" b="1" dirty="0">
+                <a:solidFill>
+                  <a:srgbClr val="E8F3EE"/>
+                </a:solidFill>
+              </a:rPr>
+              <a:t>What a baby can understand</a:t>
+            </a:r>
+            <a:endParaRPr lang="en-US" sz="1500" dirty="0"/>
+          </a:p>
+        </p:txBody>
+      </p:sp>
+      <p:sp>
+        <p:nvSpPr>
+          <p:cNvPr id="10" name="Text 8"/>
+          <p:cNvSpPr/>
+          <p:nvPr/>
+        </p:nvSpPr>
+        <p:spPr>
+          <a:xfrm>
+            <a:off x="6400800" y="4434840"/>
+            <a:ext cx="4663440" cy="1097280"/>
+          </a:xfrm>
+          <a:prstGeom prst="rect">
+            <a:avLst/>
+          </a:prstGeom>
+          <a:noFill/>
+          <a:ln/>
+        </p:spPr>
+        <p:txBody>
+          <a:bodyPr wrap="square" rtlCol="0" anchor="ctr"/>
+          <a:lstStyle/>
+          <a:p>
+            <a:pPr indent="0" marL="0">
+              <a:buNone/>
+            </a:pPr>
+            <a:r>
+              <a:rPr lang="en-US" sz="1400" dirty="0">
+                <a:solidFill>
+                  <a:srgbClr val="8AA89D"/>
+                </a:solidFill>
+              </a:rPr>
+              <a:t>If you give away a toy and it leaves the room, chasing it is hard. Reton keeps a string on the toy until you say “okay.”</a:t>
+            </a:r>
+            <a:endParaRPr lang="en-US" sz="1400" dirty="0"/>
           </a:p>
         </p:txBody>
       </p:sp>
@@ -3799,7 +4660,7 @@
                 <a:ea typeface="Arial" pitchFamily="34" charset="-122"/>
                 <a:cs typeface="Arial" pitchFamily="34" charset="-120"/>
               </a:rPr>
-              <a:t>PRODUCT · LIVE</a:t>
+              <a:t>RETON’S ANSWER</a:t>
             </a:r>
             <a:endParaRPr lang="en-US" sz="1100" dirty="0"/>
           </a:p>
@@ -3813,24 +4674,24 @@
         </p:nvSpPr>
         <p:spPr>
           <a:xfrm>
-            <a:off x="640080" y="685800"/>
-            <a:ext cx="10515600" cy="640080"/>
-          </a:xfrm>
-          <a:prstGeom prst="rect">
-            <a:avLst/>
-          </a:prstGeom>
-          <a:noFill/>
-          <a:ln/>
-        </p:spPr>
-        <p:txBody>
-          <a:bodyPr wrap="square" rtlCol="0" anchor="ctr"/>
-          <a:lstStyle/>
-          <a:p>
-            <a:pPr indent="0" marL="0">
-              <a:buNone/>
-            </a:pPr>
-            <a:r>
-              <a:rPr lang="en-US" sz="2600" b="1" dirty="0">
+            <a:off x="640080" y="777240"/>
+            <a:ext cx="10515600" cy="1280160"/>
+          </a:xfrm>
+          <a:prstGeom prst="rect">
+            <a:avLst/>
+          </a:prstGeom>
+          <a:noFill/>
+          <a:ln/>
+        </p:spPr>
+        <p:txBody>
+          <a:bodyPr wrap="square" rtlCol="0" anchor="ctr"/>
+          <a:lstStyle/>
+          <a:p>
+            <a:pPr indent="0" marL="0">
+              <a:buNone/>
+            </a:pPr>
+            <a:r>
+              <a:rPr lang="en-US" sz="3600" b="1" dirty="0">
                 <a:solidFill>
                   <a:srgbClr val="E8F3EE"/>
                 </a:solidFill>
@@ -3838,36 +4699,162 @@
                 <a:ea typeface="Arial" pitchFamily="34" charset="-122"/>
                 <a:cs typeface="Arial" pitchFamily="34" charset="-120"/>
               </a:rPr>
-              <a:t>The first wallet with an undo button for money.</a:t>
-            </a:r>
-            <a:endParaRPr lang="en-US" sz="2600" dirty="0"/>
-          </a:p>
-        </p:txBody>
-      </p:sp>
-      <p:pic>
-        <p:nvPicPr>
-          <p:cNvPr id="4" name="Image 0" descr="C:\Users\roten\Documents\reton\presentations\screenshots\01-home.png">    </p:cNvPr>
-          <p:cNvPicPr>
-            <a:picLocks noChangeAspect="1"/>
-          </p:cNvPicPr>
-          <p:nvPr/>
-        </p:nvPicPr>
-        <p:blipFill>
-          <a:blip r:embed="rId1"/>
-          <a:stretch>
-            <a:fillRect/>
-          </a:stretch>
-        </p:blipFill>
-        <p:spPr>
-          <a:xfrm>
-            <a:off x="640080" y="1417320"/>
-            <a:ext cx="10881360" cy="4754880"/>
-          </a:xfrm>
-          <a:prstGeom prst="rect">
-            <a:avLst/>
-          </a:prstGeom>
-        </p:spPr>
-      </p:pic>
+              <a:t>Don’t wait for a chase.</a:t>
+            </a:r>
+            <a:endParaRPr lang="en-US" sz="3600" dirty="0"/>
+          </a:p>
+          <a:p>
+            <a:pPr indent="0" marL="0">
+              <a:buNone/>
+            </a:pPr>
+            <a:r>
+              <a:rPr lang="en-US" sz="3600" b="1" dirty="0">
+                <a:solidFill>
+                  <a:srgbClr val="E8F3EE"/>
+                </a:solidFill>
+                <a:latin typeface="Arial" pitchFamily="34" charset="0"/>
+                <a:ea typeface="Arial" pitchFamily="34" charset="-122"/>
+                <a:cs typeface="Arial" pitchFamily="34" charset="-120"/>
+              </a:rPr>
+              <a:t>Build the undo first.</a:t>
+            </a:r>
+            <a:endParaRPr lang="en-US" sz="3600" dirty="0"/>
+          </a:p>
+        </p:txBody>
+      </p:sp>
+      <p:sp>
+        <p:nvSpPr>
+          <p:cNvPr id="4" name="Text 2"/>
+          <p:cNvSpPr/>
+          <p:nvPr/>
+        </p:nvSpPr>
+        <p:spPr>
+          <a:xfrm>
+            <a:off x="640080" y="2194560"/>
+            <a:ext cx="10515600" cy="3657600"/>
+          </a:xfrm>
+          <a:prstGeom prst="rect">
+            <a:avLst/>
+          </a:prstGeom>
+          <a:noFill/>
+          <a:ln/>
+        </p:spPr>
+        <p:txBody>
+          <a:bodyPr wrap="square" rtlCol="0" anchor="ctr"/>
+          <a:lstStyle/>
+          <a:p>
+            <a:pPr marL="342900" indent="-342900">
+              <a:buSzPct val="100000"/>
+              <a:buChar char="•"/>
+            </a:pPr>
+            <a:r>
+              <a:rPr lang="en-US" sz="2000" dirty="0">
+                <a:solidFill>
+                  <a:srgbClr val="E8F3EE"/>
+                </a:solidFill>
+                <a:latin typeface="Arial" pitchFamily="34" charset="0"/>
+                <a:ea typeface="Arial" pitchFamily="34" charset="-122"/>
+                <a:cs typeface="Arial" pitchFamily="34" charset="-120"/>
+              </a:rPr>
+              <a:t>Callback Protection — hold the payment before it becomes final.</a:t>
+            </a:r>
+            <a:endParaRPr lang="en-US" sz="2000" dirty="0"/>
+          </a:p>
+          <a:p>
+            <a:pPr marL="342900" indent="-342900">
+              <a:buSzPct val="100000"/>
+              <a:buChar char="•"/>
+            </a:pPr>
+            <a:r>
+              <a:rPr lang="en-US" sz="2000" dirty="0">
+                <a:solidFill>
+                  <a:srgbClr val="E8F3EE"/>
+                </a:solidFill>
+                <a:latin typeface="Arial" pitchFamily="34" charset="0"/>
+                <a:ea typeface="Arial" pitchFamily="34" charset="-122"/>
+                <a:cs typeface="Arial" pitchFamily="34" charset="-120"/>
+              </a:rPr>
+              <a:t>Wrong-transfer recovery — freeze eligible funds and open a case.</a:t>
+            </a:r>
+            <a:endParaRPr lang="en-US" sz="2000" dirty="0"/>
+          </a:p>
+          <a:p>
+            <a:pPr marL="342900" indent="-342900">
+              <a:buSzPct val="100000"/>
+              <a:buChar char="•"/>
+            </a:pPr>
+            <a:r>
+              <a:rPr lang="en-US" sz="2000" dirty="0">
+                <a:solidFill>
+                  <a:srgbClr val="E8F3EE"/>
+                </a:solidFill>
+                <a:latin typeface="Arial" pitchFamily="34" charset="0"/>
+                <a:ea typeface="Arial" pitchFamily="34" charset="-122"/>
+                <a:cs typeface="Arial" pitchFamily="34" charset="-120"/>
+              </a:rPr>
+              <a:t>Fraud signals — watch risky moves while money is still in motion.</a:t>
+            </a:r>
+            <a:endParaRPr lang="en-US" sz="2000" dirty="0"/>
+          </a:p>
+          <a:p>
+            <a:pPr marL="342900" indent="-342900">
+              <a:buSzPct val="100000"/>
+              <a:buChar char="•"/>
+            </a:pPr>
+            <a:r>
+              <a:rPr lang="en-US" sz="2000" dirty="0">
+                <a:solidFill>
+                  <a:srgbClr val="E8F3EE"/>
+                </a:solidFill>
+                <a:latin typeface="Arial" pitchFamily="34" charset="0"/>
+                <a:ea typeface="Arial" pitchFamily="34" charset="-122"/>
+                <a:cs typeface="Arial" pitchFamily="34" charset="-120"/>
+              </a:rPr>
+              <a:t>A clear timeline — so everyone can see what happened, step by step.</a:t>
+            </a:r>
+            <a:endParaRPr lang="en-US" sz="2000" dirty="0"/>
+          </a:p>
+        </p:txBody>
+      </p:sp>
+      <p:sp>
+        <p:nvSpPr>
+          <p:cNvPr id="5" name="Text 3"/>
+          <p:cNvSpPr/>
+          <p:nvPr/>
+        </p:nvSpPr>
+        <p:spPr>
+          <a:xfrm>
+            <a:off x="640080" y="5029200"/>
+            <a:ext cx="10058400" cy="1097280"/>
+          </a:xfrm>
+          <a:prstGeom prst="rect">
+            <a:avLst/>
+          </a:prstGeom>
+          <a:noFill/>
+          <a:ln/>
+        </p:spPr>
+        <p:txBody>
+          <a:bodyPr wrap="square" rtlCol="0" anchor="ctr"/>
+          <a:lstStyle/>
+          <a:p>
+            <a:pPr indent="0" marL="0">
+              <a:buNone/>
+            </a:pPr>
+            <a:r>
+              <a:rPr lang="en-US" sz="1600" dirty="0">
+                <a:solidFill>
+                  <a:srgbClr val="1EC98A"/>
+                </a:solidFill>
+                <a:latin typeface="Arial" pitchFamily="34" charset="0"/>
+                <a:ea typeface="Arial" pitchFamily="34" charset="-122"/>
+                <a:cs typeface="Arial" pitchFamily="34" charset="-120"/>
+              </a:rPr>
+              <a:t>Courts and bank recalls still matter. Reton adds something they can’t: protection inside the payment itself.</a:t>
+            </a:r>
+            <a:endParaRPr lang="en-US" sz="1600" dirty="0"/>
+          </a:p>
+        </p:txBody>
+      </p:sp>
     </p:spTree>
   </p:cSld>
   <p:clrMapOvr>
@@ -3933,7 +4920,7 @@
                 <a:ea typeface="Arial" pitchFamily="34" charset="-122"/>
                 <a:cs typeface="Arial" pitchFamily="34" charset="-120"/>
               </a:rPr>
-              <a:t>FLAGSHIP</a:t>
+              <a:t>THE INSIGHT</a:t>
             </a:r>
             <a:endParaRPr lang="en-US" sz="1100" dirty="0"/>
           </a:p>
@@ -3947,24 +4934,24 @@
         </p:nvSpPr>
         <p:spPr>
           <a:xfrm>
-            <a:off x="640080" y="777240"/>
-            <a:ext cx="10515600" cy="640080"/>
-          </a:xfrm>
-          <a:prstGeom prst="rect">
-            <a:avLst/>
-          </a:prstGeom>
-          <a:noFill/>
-          <a:ln/>
-        </p:spPr>
-        <p:txBody>
-          <a:bodyPr wrap="square" rtlCol="0" anchor="ctr"/>
-          <a:lstStyle/>
-          <a:p>
-            <a:pPr indent="0" marL="0">
-              <a:buNone/>
-            </a:pPr>
-            <a:r>
-              <a:rPr lang="en-US" sz="3400" b="1" dirty="0">
+            <a:off x="640080" y="1645920"/>
+            <a:ext cx="10515600" cy="2011680"/>
+          </a:xfrm>
+          <a:prstGeom prst="rect">
+            <a:avLst/>
+          </a:prstGeom>
+          <a:noFill/>
+          <a:ln/>
+        </p:spPr>
+        <p:txBody>
+          <a:bodyPr wrap="square" rtlCol="0" anchor="ctr"/>
+          <a:lstStyle/>
+          <a:p>
+            <a:pPr indent="0" marL="0">
+              <a:buNone/>
+            </a:pPr>
+            <a:r>
+              <a:rPr lang="en-US" sz="3000" b="1" dirty="0">
                 <a:solidFill>
                   <a:srgbClr val="E8F3EE"/>
                 </a:solidFill>
@@ -3972,119 +4959,39 @@
                 <a:ea typeface="Arial" pitchFamily="34" charset="-122"/>
                 <a:cs typeface="Arial" pitchFamily="34" charset="-120"/>
               </a:rPr>
-              <a:t>Callback Protection</a:t>
-            </a:r>
-            <a:endParaRPr lang="en-US" sz="3400" dirty="0"/>
-          </a:p>
-        </p:txBody>
-      </p:sp>
-      <p:sp>
-        <p:nvSpPr>
-          <p:cNvPr id="4" name="Text 2"/>
-          <p:cNvSpPr/>
-          <p:nvPr/>
-        </p:nvSpPr>
-        <p:spPr>
-          <a:xfrm>
-            <a:off x="640080" y="1463040"/>
-            <a:ext cx="10058400" cy="1097280"/>
-          </a:xfrm>
-          <a:prstGeom prst="rect">
-            <a:avLst/>
-          </a:prstGeom>
-          <a:noFill/>
-          <a:ln/>
-        </p:spPr>
-        <p:txBody>
-          <a:bodyPr wrap="square" rtlCol="0" anchor="ctr"/>
-          <a:lstStyle/>
-          <a:p>
-            <a:pPr indent="0" marL="0">
-              <a:buNone/>
-            </a:pPr>
-            <a:r>
-              <a:rPr lang="en-US" sz="1800" dirty="0">
-                <a:solidFill>
-                  <a:srgbClr val="8AA89D"/>
+              <a:t>Trust isn’t a badge on the login screen.</a:t>
+            </a:r>
+            <a:endParaRPr lang="en-US" sz="3000" dirty="0"/>
+          </a:p>
+          <a:p>
+            <a:pPr indent="0" marL="0">
+              <a:buNone/>
+            </a:pPr>
+            <a:r>
+              <a:rPr lang="en-US" sz="3000" b="1" dirty="0">
+                <a:solidFill>
+                  <a:srgbClr val="E8F3EE"/>
                 </a:solidFill>
                 <a:latin typeface="Arial" pitchFamily="34" charset="0"/>
                 <a:ea typeface="Arial" pitchFamily="34" charset="-122"/>
                 <a:cs typeface="Arial" pitchFamily="34" charset="-120"/>
               </a:rPr>
-              <a:t>Hold a payment until you’re ready. Release it when it feels right — or pull it back if something’s off.</a:t>
-            </a:r>
-            <a:endParaRPr lang="en-US" sz="1800" dirty="0"/>
-          </a:p>
-        </p:txBody>
-      </p:sp>
-      <p:sp>
-        <p:nvSpPr>
-          <p:cNvPr id="5" name="Shape 3"/>
-          <p:cNvSpPr/>
-          <p:nvPr/>
-        </p:nvSpPr>
-        <p:spPr>
-          <a:xfrm>
-            <a:off x="640080" y="2651760"/>
-            <a:ext cx="2011680" cy="502920"/>
-          </a:xfrm>
-          <a:prstGeom prst="roundRect">
-            <a:avLst>
-              <a:gd name="adj" fmla="val 45455"/>
-            </a:avLst>
-          </a:prstGeom>
-          <a:solidFill>
-            <a:srgbClr val="0F211C"/>
-          </a:solidFill>
-          <a:ln/>
-        </p:spPr>
-      </p:sp>
-      <p:sp>
-        <p:nvSpPr>
-          <p:cNvPr id="6" name="Text 4"/>
-          <p:cNvSpPr/>
-          <p:nvPr/>
-        </p:nvSpPr>
-        <p:spPr>
-          <a:xfrm>
-            <a:off x="640080" y="2697480"/>
-            <a:ext cx="2011680" cy="411480"/>
-          </a:xfrm>
-          <a:prstGeom prst="rect">
-            <a:avLst/>
-          </a:prstGeom>
-          <a:noFill/>
-          <a:ln/>
-        </p:spPr>
-        <p:txBody>
-          <a:bodyPr wrap="square" rtlCol="0" anchor="ctr"/>
-          <a:lstStyle/>
-          <a:p>
-            <a:pPr algn="ctr" indent="0" marL="0">
-              <a:buNone/>
-            </a:pPr>
-            <a:r>
-              <a:rPr lang="en-US" sz="1400" b="1" dirty="0">
-                <a:solidFill>
-                  <a:srgbClr val="E8F3EE"/>
-                </a:solidFill>
-              </a:rPr>
-              <a:t>Send</a:t>
-            </a:r>
-            <a:endParaRPr lang="en-US" sz="1400" dirty="0"/>
-          </a:p>
-        </p:txBody>
-      </p:sp>
-      <p:sp>
-        <p:nvSpPr>
-          <p:cNvPr id="7" name="Text 5"/>
-          <p:cNvSpPr/>
-          <p:nvPr/>
-        </p:nvSpPr>
-        <p:spPr>
-          <a:xfrm>
-            <a:off x="2743200" y="2697480"/>
-            <a:ext cx="365760" cy="411480"/>
+              <a:t>It’s what happens after the money moves.</a:t>
+            </a:r>
+            <a:endParaRPr lang="en-US" sz="3000" dirty="0"/>
+          </a:p>
+        </p:txBody>
+      </p:sp>
+      <p:sp>
+        <p:nvSpPr>
+          <p:cNvPr id="4" name="Text 2"/>
+          <p:cNvSpPr/>
+          <p:nvPr/>
+        </p:nvSpPr>
+        <p:spPr>
+          <a:xfrm>
+            <a:off x="640080" y="4023360"/>
+            <a:ext cx="10058400" cy="1097280"/>
           </a:xfrm>
           <a:prstGeom prst="rect">
             <a:avLst/>
@@ -4103,275 +5010,14 @@
               <a:rPr lang="en-US" sz="1800" dirty="0">
                 <a:solidFill>
                   <a:srgbClr val="8AA89D"/>
-                </a:solidFill>
-              </a:rPr>
-              <a:t>→</a:t>
-            </a:r>
-            <a:endParaRPr lang="en-US" sz="1800" dirty="0"/>
-          </a:p>
-        </p:txBody>
-      </p:sp>
-      <p:sp>
-        <p:nvSpPr>
-          <p:cNvPr id="8" name="Shape 6"/>
-          <p:cNvSpPr/>
-          <p:nvPr/>
-        </p:nvSpPr>
-        <p:spPr>
-          <a:xfrm>
-            <a:off x="3108960" y="2651760"/>
-            <a:ext cx="2926080" cy="502920"/>
-          </a:xfrm>
-          <a:prstGeom prst="roundRect">
-            <a:avLst>
-              <a:gd name="adj" fmla="val 45455"/>
-            </a:avLst>
-          </a:prstGeom>
-          <a:solidFill>
-            <a:srgbClr val="0F211C"/>
-          </a:solidFill>
-          <a:ln/>
-        </p:spPr>
-      </p:sp>
-      <p:sp>
-        <p:nvSpPr>
-          <p:cNvPr id="9" name="Text 7"/>
-          <p:cNvSpPr/>
-          <p:nvPr/>
-        </p:nvSpPr>
-        <p:spPr>
-          <a:xfrm>
-            <a:off x="3108960" y="2697480"/>
-            <a:ext cx="2926080" cy="411480"/>
-          </a:xfrm>
-          <a:prstGeom prst="rect">
-            <a:avLst/>
-          </a:prstGeom>
-          <a:noFill/>
-          <a:ln/>
-        </p:spPr>
-        <p:txBody>
-          <a:bodyPr wrap="square" rtlCol="0" anchor="ctr"/>
-          <a:lstStyle/>
-          <a:p>
-            <a:pPr algn="ctr" indent="0" marL="0">
-              <a:buNone/>
-            </a:pPr>
-            <a:r>
-              <a:rPr lang="en-US" sz="1400" b="1" dirty="0">
-                <a:solidFill>
-                  <a:srgbClr val="E8A54B"/>
-                </a:solidFill>
-              </a:rPr>
-              <a:t>Protected / Pending</a:t>
-            </a:r>
-            <a:endParaRPr lang="en-US" sz="1400" dirty="0"/>
-          </a:p>
-        </p:txBody>
-      </p:sp>
-      <p:sp>
-        <p:nvSpPr>
-          <p:cNvPr id="10" name="Text 8"/>
-          <p:cNvSpPr/>
-          <p:nvPr/>
-        </p:nvSpPr>
-        <p:spPr>
-          <a:xfrm>
-            <a:off x="6126480" y="2697480"/>
-            <a:ext cx="365760" cy="411480"/>
-          </a:xfrm>
-          <a:prstGeom prst="rect">
-            <a:avLst/>
-          </a:prstGeom>
-          <a:noFill/>
-          <a:ln/>
-        </p:spPr>
-        <p:txBody>
-          <a:bodyPr wrap="square" rtlCol="0" anchor="ctr"/>
-          <a:lstStyle/>
-          <a:p>
-            <a:pPr indent="0" marL="0">
-              <a:buNone/>
-            </a:pPr>
-            <a:r>
-              <a:rPr lang="en-US" sz="1800" dirty="0">
-                <a:solidFill>
-                  <a:srgbClr val="8AA89D"/>
-                </a:solidFill>
-              </a:rPr>
-              <a:t>→</a:t>
-            </a:r>
-            <a:endParaRPr lang="en-US" sz="1800" dirty="0"/>
-          </a:p>
-        </p:txBody>
-      </p:sp>
-      <p:sp>
-        <p:nvSpPr>
-          <p:cNvPr id="11" name="Shape 9"/>
-          <p:cNvSpPr/>
-          <p:nvPr/>
-        </p:nvSpPr>
-        <p:spPr>
-          <a:xfrm>
-            <a:off x="6492240" y="2651760"/>
-            <a:ext cx="2011680" cy="502920"/>
-          </a:xfrm>
-          <a:prstGeom prst="roundRect">
-            <a:avLst>
-              <a:gd name="adj" fmla="val 45455"/>
-            </a:avLst>
-          </a:prstGeom>
-          <a:solidFill>
-            <a:srgbClr val="0F211C"/>
-          </a:solidFill>
-          <a:ln/>
-        </p:spPr>
-      </p:sp>
-      <p:sp>
-        <p:nvSpPr>
-          <p:cNvPr id="12" name="Text 10"/>
-          <p:cNvSpPr/>
-          <p:nvPr/>
-        </p:nvSpPr>
-        <p:spPr>
-          <a:xfrm>
-            <a:off x="6492240" y="2697480"/>
-            <a:ext cx="2011680" cy="411480"/>
-          </a:xfrm>
-          <a:prstGeom prst="rect">
-            <a:avLst/>
-          </a:prstGeom>
-          <a:noFill/>
-          <a:ln/>
-        </p:spPr>
-        <p:txBody>
-          <a:bodyPr wrap="square" rtlCol="0" anchor="ctr"/>
-          <a:lstStyle/>
-          <a:p>
-            <a:pPr algn="ctr" indent="0" marL="0">
-              <a:buNone/>
-            </a:pPr>
-            <a:r>
-              <a:rPr lang="en-US" sz="1400" b="1" dirty="0">
-                <a:solidFill>
-                  <a:srgbClr val="1EC98A"/>
-                </a:solidFill>
-              </a:rPr>
-              <a:t>Release</a:t>
-            </a:r>
-            <a:endParaRPr lang="en-US" sz="1400" dirty="0"/>
-          </a:p>
-        </p:txBody>
-      </p:sp>
-      <p:sp>
-        <p:nvSpPr>
-          <p:cNvPr id="13" name="Text 11"/>
-          <p:cNvSpPr/>
-          <p:nvPr/>
-        </p:nvSpPr>
-        <p:spPr>
-          <a:xfrm>
-            <a:off x="8686800" y="2697480"/>
-            <a:ext cx="2286000" cy="411480"/>
-          </a:xfrm>
-          <a:prstGeom prst="rect">
-            <a:avLst/>
-          </a:prstGeom>
-          <a:noFill/>
-          <a:ln/>
-        </p:spPr>
-        <p:txBody>
-          <a:bodyPr wrap="square" rtlCol="0" anchor="ctr"/>
-          <a:lstStyle/>
-          <a:p>
-            <a:pPr indent="0" marL="0">
-              <a:buNone/>
-            </a:pPr>
-            <a:r>
-              <a:rPr lang="en-US" sz="1400" b="1" dirty="0">
-                <a:solidFill>
-                  <a:srgbClr val="E8F3EE"/>
-                </a:solidFill>
-              </a:rPr>
-              <a:t>or Callback</a:t>
-            </a:r>
-            <a:endParaRPr lang="en-US" sz="1400" dirty="0"/>
-          </a:p>
-        </p:txBody>
-      </p:sp>
-      <p:sp>
-        <p:nvSpPr>
-          <p:cNvPr id="14" name="Text 12"/>
-          <p:cNvSpPr/>
-          <p:nvPr/>
-        </p:nvSpPr>
-        <p:spPr>
-          <a:xfrm>
-            <a:off x="640080" y="3474720"/>
-            <a:ext cx="10515600" cy="3657600"/>
-          </a:xfrm>
-          <a:prstGeom prst="rect">
-            <a:avLst/>
-          </a:prstGeom>
-          <a:noFill/>
-          <a:ln/>
-        </p:spPr>
-        <p:txBody>
-          <a:bodyPr wrap="square" rtlCol="0" anchor="ctr"/>
-          <a:lstStyle/>
-          <a:p>
-            <a:pPr marL="342900" indent="-342900">
-              <a:buSzPct val="100000"/>
-              <a:buChar char="•"/>
-            </a:pPr>
-            <a:r>
-              <a:rPr lang="en-US" sz="2000" dirty="0">
-                <a:solidFill>
-                  <a:srgbClr val="E8F3EE"/>
                 </a:solidFill>
                 <a:latin typeface="Arial" pitchFamily="34" charset="0"/>
                 <a:ea typeface="Arial" pitchFamily="34" charset="-122"/>
                 <a:cs typeface="Arial" pitchFamily="34" charset="-120"/>
               </a:rPr>
-              <a:t>Receiver sees “Payment Protected.”</a:t>
-            </a:r>
-            <a:endParaRPr lang="en-US" sz="2000" dirty="0"/>
-          </a:p>
-          <a:p>
-            <a:pPr marL="342900" indent="-342900">
-              <a:buSzPct val="100000"/>
-              <a:buChar char="•"/>
-            </a:pPr>
-            <a:r>
-              <a:rPr lang="en-US" sz="2000" dirty="0">
-                <a:solidFill>
-                  <a:srgbClr val="E8F3EE"/>
-                </a:solidFill>
-                <a:latin typeface="Arial" pitchFamily="34" charset="0"/>
-                <a:ea typeface="Arial" pitchFamily="34" charset="-122"/>
-                <a:cs typeface="Arial" pitchFamily="34" charset="-120"/>
-              </a:rPr>
-              <a:t>Every step is logged on a visible timeline.</a:t>
-            </a:r>
-            <a:endParaRPr lang="en-US" sz="2000" dirty="0"/>
-          </a:p>
-          <a:p>
-            <a:pPr marL="342900" indent="-342900">
-              <a:buSzPct val="100000"/>
-              <a:buChar char="•"/>
-            </a:pPr>
-            <a:r>
-              <a:rPr lang="en-US" sz="2000" dirty="0">
-                <a:solidFill>
-                  <a:srgbClr val="E8F3EE"/>
-                </a:solidFill>
-                <a:latin typeface="Arial" pitchFamily="34" charset="0"/>
-                <a:ea typeface="Arial" pitchFamily="34" charset="-122"/>
-                <a:cs typeface="Arial" pitchFamily="34" charset="-120"/>
-              </a:rPr>
-              <a:t>Sender, receiver, and admin can act with clarity.</a:t>
-            </a:r>
-            <a:endParaRPr lang="en-US" sz="2000" dirty="0"/>
+              <a:t>Reton is built for the moment something goes wrong — not just the moment you hit send.</a:t>
+            </a:r>
+            <a:endParaRPr lang="en-US" sz="1800" dirty="0"/>
           </a:p>
         </p:txBody>
       </p:sp>
@@ -4440,7 +5086,7 @@
                 <a:ea typeface="Arial" pitchFamily="34" charset="-122"/>
                 <a:cs typeface="Arial" pitchFamily="34" charset="-120"/>
               </a:rPr>
-              <a:t>HOW IT WORKS</a:t>
+              <a:t>PRODUCT · LIVE</a:t>
             </a:r>
             <a:endParaRPr lang="en-US" sz="1100" dirty="0"/>
           </a:p>
@@ -4455,7 +5101,7 @@
         <p:spPr>
           <a:xfrm>
             <a:off x="640080" y="685800"/>
-            <a:ext cx="10515600" cy="548640"/>
+            <a:ext cx="10515600" cy="640080"/>
           </a:xfrm>
           <a:prstGeom prst="rect">
             <a:avLst/>
@@ -4479,7 +5125,7 @@
                 <a:ea typeface="Arial" pitchFamily="34" charset="-122"/>
                 <a:cs typeface="Arial" pitchFamily="34" charset="-120"/>
               </a:rPr>
-              <a:t>Clear flows. Safer money.</a:t>
+              <a:t>The first wallet with an undo button for money.</a:t>
             </a:r>
             <a:endParaRPr lang="en-US" sz="2600" dirty="0"/>
           </a:p>
@@ -4487,7 +5133,7 @@
       </p:sp>
       <p:pic>
         <p:nvPicPr>
-          <p:cNvPr id="4" name="Image 0" descr="C:\Users\roten\Documents\reton\presentations\screenshots\02-how-it-works.png">    </p:cNvPr>
+          <p:cNvPr id="4" name="Image 0" descr="C:\Users\roten\Documents\reton\presentations\screenshots\01-home.png">    </p:cNvPr>
           <p:cNvPicPr>
             <a:picLocks noChangeAspect="1"/>
           </p:cNvPicPr>
@@ -4501,8 +5147,8 @@
         </p:blipFill>
         <p:spPr>
           <a:xfrm>
-            <a:off x="640080" y="1325880"/>
-            <a:ext cx="10881360" cy="4937760"/>
+            <a:off x="640080" y="1417320"/>
+            <a:ext cx="10881360" cy="4754880"/>
           </a:xfrm>
           <a:prstGeom prst="rect">
             <a:avLst/>
@@ -4574,7 +5220,7 @@
                 <a:ea typeface="Arial" pitchFamily="34" charset="-122"/>
                 <a:cs typeface="Arial" pitchFamily="34" charset="-120"/>
               </a:rPr>
-              <a:t>WHAT WE BUILT</a:t>
+              <a:t>FLAGSHIP</a:t>
             </a:r>
             <a:endParaRPr lang="en-US" sz="1100" dirty="0"/>
           </a:p>
@@ -4588,7 +5234,7 @@
         </p:nvSpPr>
         <p:spPr>
           <a:xfrm>
-            <a:off x="640080" y="731520"/>
+            <a:off x="640080" y="777240"/>
             <a:ext cx="10515600" cy="640080"/>
           </a:xfrm>
           <a:prstGeom prst="rect">
@@ -4605,7 +5251,7 @@
               <a:buNone/>
             </a:pPr>
             <a:r>
-              <a:rPr lang="en-US" sz="2800" b="1" dirty="0">
+              <a:rPr lang="en-US" sz="3400" b="1" dirty="0">
                 <a:solidFill>
                   <a:srgbClr val="E8F3EE"/>
                 </a:solidFill>
@@ -4613,26 +5259,65 @@
                 <a:ea typeface="Arial" pitchFamily="34" charset="-122"/>
                 <a:cs typeface="Arial" pitchFamily="34" charset="-120"/>
               </a:rPr>
-              <a:t>A full trust stack — not slideware.</a:t>
-            </a:r>
-            <a:endParaRPr lang="en-US" sz="2800" dirty="0"/>
-          </a:p>
-        </p:txBody>
-      </p:sp>
-      <p:sp>
-        <p:nvSpPr>
-          <p:cNvPr id="4" name="Shape 2"/>
-          <p:cNvSpPr/>
-          <p:nvPr/>
-        </p:nvSpPr>
-        <p:spPr>
-          <a:xfrm>
-            <a:off x="640080" y="1645920"/>
-            <a:ext cx="3520440" cy="1828800"/>
+              <a:t>Callback Protection</a:t>
+            </a:r>
+            <a:endParaRPr lang="en-US" sz="3400" dirty="0"/>
+          </a:p>
+        </p:txBody>
+      </p:sp>
+      <p:sp>
+        <p:nvSpPr>
+          <p:cNvPr id="4" name="Text 2"/>
+          <p:cNvSpPr/>
+          <p:nvPr/>
+        </p:nvSpPr>
+        <p:spPr>
+          <a:xfrm>
+            <a:off x="640080" y="1463040"/>
+            <a:ext cx="10058400" cy="1097280"/>
+          </a:xfrm>
+          <a:prstGeom prst="rect">
+            <a:avLst/>
+          </a:prstGeom>
+          <a:noFill/>
+          <a:ln/>
+        </p:spPr>
+        <p:txBody>
+          <a:bodyPr wrap="square" rtlCol="0" anchor="ctr"/>
+          <a:lstStyle/>
+          <a:p>
+            <a:pPr indent="0" marL="0">
+              <a:buNone/>
+            </a:pPr>
+            <a:r>
+              <a:rPr lang="en-US" sz="1800" dirty="0">
+                <a:solidFill>
+                  <a:srgbClr val="8AA89D"/>
+                </a:solidFill>
+                <a:latin typeface="Arial" pitchFamily="34" charset="0"/>
+                <a:ea typeface="Arial" pitchFamily="34" charset="-122"/>
+                <a:cs typeface="Arial" pitchFamily="34" charset="-120"/>
+              </a:rPr>
+              <a:t>Hold a payment until you’re ready. Release it when it feels right — or pull it back if something’s off.</a:t>
+            </a:r>
+            <a:endParaRPr lang="en-US" sz="1800" dirty="0"/>
+          </a:p>
+        </p:txBody>
+      </p:sp>
+      <p:sp>
+        <p:nvSpPr>
+          <p:cNvPr id="5" name="Shape 3"/>
+          <p:cNvSpPr/>
+          <p:nvPr/>
+        </p:nvSpPr>
+        <p:spPr>
+          <a:xfrm>
+            <a:off x="640080" y="2651760"/>
+            <a:ext cx="2011680" cy="502920"/>
           </a:xfrm>
           <a:prstGeom prst="roundRect">
             <a:avLst>
-              <a:gd name="adj" fmla="val 10000"/>
+              <a:gd name="adj" fmla="val 45455"/>
             </a:avLst>
           </a:prstGeom>
           <a:solidFill>
@@ -4643,90 +5328,90 @@
       </p:sp>
       <p:sp>
         <p:nvSpPr>
-          <p:cNvPr id="5" name="Text 3"/>
-          <p:cNvSpPr/>
-          <p:nvPr/>
-        </p:nvSpPr>
-        <p:spPr>
-          <a:xfrm>
-            <a:off x="868680" y="1965960"/>
-            <a:ext cx="3063240" cy="411480"/>
-          </a:xfrm>
-          <a:prstGeom prst="rect">
-            <a:avLst/>
-          </a:prstGeom>
-          <a:noFill/>
-          <a:ln/>
-        </p:spPr>
-        <p:txBody>
-          <a:bodyPr wrap="square" rtlCol="0" anchor="ctr"/>
-          <a:lstStyle/>
-          <a:p>
-            <a:pPr indent="0" marL="0">
-              <a:buNone/>
-            </a:pPr>
-            <a:r>
-              <a:rPr lang="en-US" sz="1600" b="1" dirty="0">
+          <p:cNvPr id="6" name="Text 4"/>
+          <p:cNvSpPr/>
+          <p:nvPr/>
+        </p:nvSpPr>
+        <p:spPr>
+          <a:xfrm>
+            <a:off x="640080" y="2697480"/>
+            <a:ext cx="2011680" cy="411480"/>
+          </a:xfrm>
+          <a:prstGeom prst="rect">
+            <a:avLst/>
+          </a:prstGeom>
+          <a:noFill/>
+          <a:ln/>
+        </p:spPr>
+        <p:txBody>
+          <a:bodyPr wrap="square" rtlCol="0" anchor="ctr"/>
+          <a:lstStyle/>
+          <a:p>
+            <a:pPr algn="ctr" indent="0" marL="0">
+              <a:buNone/>
+            </a:pPr>
+            <a:r>
+              <a:rPr lang="en-US" sz="1400" b="1" dirty="0">
                 <a:solidFill>
                   <a:srgbClr val="E8F3EE"/>
                 </a:solidFill>
               </a:rPr>
-              <a:t>Wrong-transfer recovery</a:t>
-            </a:r>
-            <a:endParaRPr lang="en-US" sz="1600" dirty="0"/>
-          </a:p>
-        </p:txBody>
-      </p:sp>
-      <p:sp>
-        <p:nvSpPr>
-          <p:cNvPr id="6" name="Text 4"/>
-          <p:cNvSpPr/>
-          <p:nvPr/>
-        </p:nvSpPr>
-        <p:spPr>
-          <a:xfrm>
-            <a:off x="868680" y="2468880"/>
-            <a:ext cx="3063240" cy="731520"/>
-          </a:xfrm>
-          <a:prstGeom prst="rect">
-            <a:avLst/>
-          </a:prstGeom>
-          <a:noFill/>
-          <a:ln/>
-        </p:spPr>
-        <p:txBody>
-          <a:bodyPr wrap="square" rtlCol="0" anchor="ctr"/>
-          <a:lstStyle/>
-          <a:p>
-            <a:pPr indent="0" marL="0">
-              <a:buNone/>
-            </a:pPr>
-            <a:r>
-              <a:rPr lang="en-US" sz="1300" dirty="0">
+              <a:t>Send</a:t>
+            </a:r>
+            <a:endParaRPr lang="en-US" sz="1400" dirty="0"/>
+          </a:p>
+        </p:txBody>
+      </p:sp>
+      <p:sp>
+        <p:nvSpPr>
+          <p:cNvPr id="7" name="Text 5"/>
+          <p:cNvSpPr/>
+          <p:nvPr/>
+        </p:nvSpPr>
+        <p:spPr>
+          <a:xfrm>
+            <a:off x="2743200" y="2697480"/>
+            <a:ext cx="365760" cy="411480"/>
+          </a:xfrm>
+          <a:prstGeom prst="rect">
+            <a:avLst/>
+          </a:prstGeom>
+          <a:noFill/>
+          <a:ln/>
+        </p:spPr>
+        <p:txBody>
+          <a:bodyPr wrap="square" rtlCol="0" anchor="ctr"/>
+          <a:lstStyle/>
+          <a:p>
+            <a:pPr indent="0" marL="0">
+              <a:buNone/>
+            </a:pPr>
+            <a:r>
+              <a:rPr lang="en-US" sz="1800" dirty="0">
                 <a:solidFill>
                   <a:srgbClr val="8AA89D"/>
                 </a:solidFill>
               </a:rPr>
-              <a:t>Report a mistake. Hold eligible funds. Track the case.</a:t>
-            </a:r>
-            <a:endParaRPr lang="en-US" sz="1300" dirty="0"/>
-          </a:p>
-        </p:txBody>
-      </p:sp>
-      <p:sp>
-        <p:nvSpPr>
-          <p:cNvPr id="7" name="Shape 5"/>
-          <p:cNvSpPr/>
-          <p:nvPr/>
-        </p:nvSpPr>
-        <p:spPr>
-          <a:xfrm>
-            <a:off x="4389120" y="1645920"/>
-            <a:ext cx="3520440" cy="1828800"/>
+              <a:t>→</a:t>
+            </a:r>
+            <a:endParaRPr lang="en-US" sz="1800" dirty="0"/>
+          </a:p>
+        </p:txBody>
+      </p:sp>
+      <p:sp>
+        <p:nvSpPr>
+          <p:cNvPr id="8" name="Shape 6"/>
+          <p:cNvSpPr/>
+          <p:nvPr/>
+        </p:nvSpPr>
+        <p:spPr>
+          <a:xfrm>
+            <a:off x="3108960" y="2651760"/>
+            <a:ext cx="2926080" cy="502920"/>
           </a:xfrm>
           <a:prstGeom prst="roundRect">
             <a:avLst>
-              <a:gd name="adj" fmla="val 10000"/>
+              <a:gd name="adj" fmla="val 45455"/>
             </a:avLst>
           </a:prstGeom>
           <a:solidFill>
@@ -4737,90 +5422,90 @@
       </p:sp>
       <p:sp>
         <p:nvSpPr>
-          <p:cNvPr id="8" name="Text 6"/>
-          <p:cNvSpPr/>
-          <p:nvPr/>
-        </p:nvSpPr>
-        <p:spPr>
-          <a:xfrm>
-            <a:off x="4617720" y="1965960"/>
-            <a:ext cx="3063240" cy="411480"/>
-          </a:xfrm>
-          <a:prstGeom prst="rect">
-            <a:avLst/>
-          </a:prstGeom>
-          <a:noFill/>
-          <a:ln/>
-        </p:spPr>
-        <p:txBody>
-          <a:bodyPr wrap="square" rtlCol="0" anchor="ctr"/>
-          <a:lstStyle/>
-          <a:p>
-            <a:pPr indent="0" marL="0">
-              <a:buNone/>
-            </a:pPr>
-            <a:r>
-              <a:rPr lang="en-US" sz="1600" b="1" dirty="0">
-                <a:solidFill>
-                  <a:srgbClr val="E8F3EE"/>
-                </a:solidFill>
-              </a:rPr>
-              <a:t>Fraud signals</a:t>
-            </a:r>
-            <a:endParaRPr lang="en-US" sz="1600" dirty="0"/>
-          </a:p>
-        </p:txBody>
-      </p:sp>
-      <p:sp>
-        <p:nvSpPr>
           <p:cNvPr id="9" name="Text 7"/>
           <p:cNvSpPr/>
           <p:nvPr/>
         </p:nvSpPr>
         <p:spPr>
           <a:xfrm>
-            <a:off x="4617720" y="2468880"/>
-            <a:ext cx="3063240" cy="731520"/>
-          </a:xfrm>
-          <a:prstGeom prst="rect">
-            <a:avLst/>
-          </a:prstGeom>
-          <a:noFill/>
-          <a:ln/>
-        </p:spPr>
-        <p:txBody>
-          <a:bodyPr wrap="square" rtlCol="0" anchor="ctr"/>
-          <a:lstStyle/>
-          <a:p>
-            <a:pPr indent="0" marL="0">
-              <a:buNone/>
-            </a:pPr>
-            <a:r>
-              <a:rPr lang="en-US" sz="1300" dirty="0">
+            <a:off x="3108960" y="2697480"/>
+            <a:ext cx="2926080" cy="411480"/>
+          </a:xfrm>
+          <a:prstGeom prst="rect">
+            <a:avLst/>
+          </a:prstGeom>
+          <a:noFill/>
+          <a:ln/>
+        </p:spPr>
+        <p:txBody>
+          <a:bodyPr wrap="square" rtlCol="0" anchor="ctr"/>
+          <a:lstStyle/>
+          <a:p>
+            <a:pPr algn="ctr" indent="0" marL="0">
+              <a:buNone/>
+            </a:pPr>
+            <a:r>
+              <a:rPr lang="en-US" sz="1400" b="1" dirty="0">
+                <a:solidFill>
+                  <a:srgbClr val="E8A54B"/>
+                </a:solidFill>
+              </a:rPr>
+              <a:t>Protected / Pending</a:t>
+            </a:r>
+            <a:endParaRPr lang="en-US" sz="1400" dirty="0"/>
+          </a:p>
+        </p:txBody>
+      </p:sp>
+      <p:sp>
+        <p:nvSpPr>
+          <p:cNvPr id="10" name="Text 8"/>
+          <p:cNvSpPr/>
+          <p:nvPr/>
+        </p:nvSpPr>
+        <p:spPr>
+          <a:xfrm>
+            <a:off x="6126480" y="2697480"/>
+            <a:ext cx="365760" cy="411480"/>
+          </a:xfrm>
+          <a:prstGeom prst="rect">
+            <a:avLst/>
+          </a:prstGeom>
+          <a:noFill/>
+          <a:ln/>
+        </p:spPr>
+        <p:txBody>
+          <a:bodyPr wrap="square" rtlCol="0" anchor="ctr"/>
+          <a:lstStyle/>
+          <a:p>
+            <a:pPr indent="0" marL="0">
+              <a:buNone/>
+            </a:pPr>
+            <a:r>
+              <a:rPr lang="en-US" sz="1800" dirty="0">
                 <a:solidFill>
                   <a:srgbClr val="8AA89D"/>
                 </a:solidFill>
               </a:rPr>
-              <a:t>Rule-based scoring with admin visibility.</a:t>
-            </a:r>
-            <a:endParaRPr lang="en-US" sz="1300" dirty="0"/>
-          </a:p>
-        </p:txBody>
-      </p:sp>
-      <p:sp>
-        <p:nvSpPr>
-          <p:cNvPr id="10" name="Shape 8"/>
-          <p:cNvSpPr/>
-          <p:nvPr/>
-        </p:nvSpPr>
-        <p:spPr>
-          <a:xfrm>
-            <a:off x="8138160" y="1645920"/>
-            <a:ext cx="3520440" cy="1828800"/>
+              <a:t>→</a:t>
+            </a:r>
+            <a:endParaRPr lang="en-US" sz="1800" dirty="0"/>
+          </a:p>
+        </p:txBody>
+      </p:sp>
+      <p:sp>
+        <p:nvSpPr>
+          <p:cNvPr id="11" name="Shape 9"/>
+          <p:cNvSpPr/>
+          <p:nvPr/>
+        </p:nvSpPr>
+        <p:spPr>
+          <a:xfrm>
+            <a:off x="6492240" y="2651760"/>
+            <a:ext cx="2011680" cy="502920"/>
           </a:xfrm>
           <a:prstGeom prst="roundRect">
             <a:avLst>
-              <a:gd name="adj" fmla="val 10000"/>
+              <a:gd name="adj" fmla="val 45455"/>
             </a:avLst>
           </a:prstGeom>
           <a:solidFill>
@@ -4831,97 +5516,75 @@
       </p:sp>
       <p:sp>
         <p:nvSpPr>
-          <p:cNvPr id="11" name="Text 9"/>
-          <p:cNvSpPr/>
-          <p:nvPr/>
-        </p:nvSpPr>
-        <p:spPr>
-          <a:xfrm>
-            <a:off x="8366760" y="1965960"/>
-            <a:ext cx="3063240" cy="411480"/>
-          </a:xfrm>
-          <a:prstGeom prst="rect">
-            <a:avLst/>
-          </a:prstGeom>
-          <a:noFill/>
-          <a:ln/>
-        </p:spPr>
-        <p:txBody>
-          <a:bodyPr wrap="square" rtlCol="0" anchor="ctr"/>
-          <a:lstStyle/>
-          <a:p>
-            <a:pPr indent="0" marL="0">
-              <a:buNone/>
-            </a:pPr>
-            <a:r>
-              <a:rPr lang="en-US" sz="1600" b="1" dirty="0">
+          <p:cNvPr id="12" name="Text 10"/>
+          <p:cNvSpPr/>
+          <p:nvPr/>
+        </p:nvSpPr>
+        <p:spPr>
+          <a:xfrm>
+            <a:off x="6492240" y="2697480"/>
+            <a:ext cx="2011680" cy="411480"/>
+          </a:xfrm>
+          <a:prstGeom prst="rect">
+            <a:avLst/>
+          </a:prstGeom>
+          <a:noFill/>
+          <a:ln/>
+        </p:spPr>
+        <p:txBody>
+          <a:bodyPr wrap="square" rtlCol="0" anchor="ctr"/>
+          <a:lstStyle/>
+          <a:p>
+            <a:pPr algn="ctr" indent="0" marL="0">
+              <a:buNone/>
+            </a:pPr>
+            <a:r>
+              <a:rPr lang="en-US" sz="1400" b="1" dirty="0">
+                <a:solidFill>
+                  <a:srgbClr val="1EC98A"/>
+                </a:solidFill>
+              </a:rPr>
+              <a:t>Release</a:t>
+            </a:r>
+            <a:endParaRPr lang="en-US" sz="1400" dirty="0"/>
+          </a:p>
+        </p:txBody>
+      </p:sp>
+      <p:sp>
+        <p:nvSpPr>
+          <p:cNvPr id="13" name="Text 11"/>
+          <p:cNvSpPr/>
+          <p:nvPr/>
+        </p:nvSpPr>
+        <p:spPr>
+          <a:xfrm>
+            <a:off x="8686800" y="2697480"/>
+            <a:ext cx="2286000" cy="411480"/>
+          </a:xfrm>
+          <a:prstGeom prst="rect">
+            <a:avLst/>
+          </a:prstGeom>
+          <a:noFill/>
+          <a:ln/>
+        </p:spPr>
+        <p:txBody>
+          <a:bodyPr wrap="square" rtlCol="0" anchor="ctr"/>
+          <a:lstStyle/>
+          <a:p>
+            <a:pPr indent="0" marL="0">
+              <a:buNone/>
+            </a:pPr>
+            <a:r>
+              <a:rPr lang="en-US" sz="1400" b="1" dirty="0">
                 <a:solidFill>
                   <a:srgbClr val="E8F3EE"/>
                 </a:solidFill>
               </a:rPr>
-              <a:t>Double-entry wallet</a:t>
-            </a:r>
-            <a:endParaRPr lang="en-US" sz="1600" dirty="0"/>
-          </a:p>
-        </p:txBody>
-      </p:sp>
-      <p:sp>
-        <p:nvSpPr>
-          <p:cNvPr id="12" name="Text 10"/>
-          <p:cNvSpPr/>
-          <p:nvPr/>
-        </p:nvSpPr>
-        <p:spPr>
-          <a:xfrm>
-            <a:off x="8366760" y="2468880"/>
-            <a:ext cx="3063240" cy="731520"/>
-          </a:xfrm>
-          <a:prstGeom prst="rect">
-            <a:avLst/>
-          </a:prstGeom>
-          <a:noFill/>
-          <a:ln/>
-        </p:spPr>
-        <p:txBody>
-          <a:bodyPr wrap="square" rtlCol="0" anchor="ctr"/>
-          <a:lstStyle/>
-          <a:p>
-            <a:pPr indent="0" marL="0">
-              <a:buNone/>
-            </a:pPr>
-            <a:r>
-              <a:rPr lang="en-US" sz="1300" dirty="0">
-                <a:solidFill>
-                  <a:srgbClr val="8AA89D"/>
-                </a:solidFill>
-              </a:rPr>
-              <a:t>Every naira ledgered — no silent tweaks.</a:t>
-            </a:r>
-            <a:endParaRPr lang="en-US" sz="1300" dirty="0"/>
-          </a:p>
-        </p:txBody>
-      </p:sp>
-      <p:sp>
-        <p:nvSpPr>
-          <p:cNvPr id="13" name="Shape 11"/>
-          <p:cNvSpPr/>
-          <p:nvPr/>
-        </p:nvSpPr>
-        <p:spPr>
-          <a:xfrm>
-            <a:off x="640080" y="3749040"/>
-            <a:ext cx="3520440" cy="1828800"/>
-          </a:xfrm>
-          <a:prstGeom prst="roundRect">
-            <a:avLst>
-              <a:gd name="adj" fmla="val 10000"/>
-            </a:avLst>
-          </a:prstGeom>
-          <a:solidFill>
-            <a:srgbClr val="0F211C"/>
-          </a:solidFill>
-          <a:ln/>
-        </p:spPr>
+              <a:t>or Callback</a:t>
+            </a:r>
+            <a:endParaRPr lang="en-US" sz="1400" dirty="0"/>
+          </a:p>
+        </p:txBody>
       </p:sp>
       <p:sp>
         <p:nvSpPr>
@@ -4931,255 +5594,71 @@
         </p:nvSpPr>
         <p:spPr>
           <a:xfrm>
-            <a:off x="868680" y="4069080"/>
-            <a:ext cx="3063240" cy="411480"/>
-          </a:xfrm>
-          <a:prstGeom prst="rect">
-            <a:avLst/>
-          </a:prstGeom>
-          <a:noFill/>
-          <a:ln/>
-        </p:spPr>
-        <p:txBody>
-          <a:bodyPr wrap="square" rtlCol="0" anchor="ctr"/>
-          <a:lstStyle/>
-          <a:p>
-            <a:pPr indent="0" marL="0">
-              <a:buNone/>
-            </a:pPr>
-            <a:r>
-              <a:rPr lang="en-US" sz="1600" b="1" dirty="0">
+            <a:off x="640080" y="3474720"/>
+            <a:ext cx="10515600" cy="3657600"/>
+          </a:xfrm>
+          <a:prstGeom prst="rect">
+            <a:avLst/>
+          </a:prstGeom>
+          <a:noFill/>
+          <a:ln/>
+        </p:spPr>
+        <p:txBody>
+          <a:bodyPr wrap="square" rtlCol="0" anchor="ctr"/>
+          <a:lstStyle/>
+          <a:p>
+            <a:pPr marL="342900" indent="-342900">
+              <a:buSzPct val="100000"/>
+              <a:buChar char="•"/>
+            </a:pPr>
+            <a:r>
+              <a:rPr lang="en-US" sz="2000" dirty="0">
                 <a:solidFill>
                   <a:srgbClr val="E8F3EE"/>
                 </a:solidFill>
-              </a:rPr>
-              <a:t>KYC tiers</a:t>
-            </a:r>
-            <a:endParaRPr lang="en-US" sz="1600" dirty="0"/>
-          </a:p>
-        </p:txBody>
-      </p:sp>
-      <p:sp>
-        <p:nvSpPr>
-          <p:cNvPr id="15" name="Text 13"/>
-          <p:cNvSpPr/>
-          <p:nvPr/>
-        </p:nvSpPr>
-        <p:spPr>
-          <a:xfrm>
-            <a:off x="868680" y="4572000"/>
-            <a:ext cx="3063240" cy="731520"/>
-          </a:xfrm>
-          <a:prstGeom prst="rect">
-            <a:avLst/>
-          </a:prstGeom>
-          <a:noFill/>
-          <a:ln/>
-        </p:spPr>
-        <p:txBody>
-          <a:bodyPr wrap="square" rtlCol="0" anchor="ctr"/>
-          <a:lstStyle/>
-          <a:p>
-            <a:pPr indent="0" marL="0">
-              <a:buNone/>
-            </a:pPr>
-            <a:r>
-              <a:rPr lang="en-US" sz="1300" dirty="0">
-                <a:solidFill>
-                  <a:srgbClr val="8AA89D"/>
-                </a:solidFill>
-              </a:rPr>
-              <a:t>CBN-aligned limits. BVN unlock for funding.</a:t>
-            </a:r>
-            <a:endParaRPr lang="en-US" sz="1300" dirty="0"/>
-          </a:p>
-        </p:txBody>
-      </p:sp>
-      <p:sp>
-        <p:nvSpPr>
-          <p:cNvPr id="16" name="Shape 14"/>
-          <p:cNvSpPr/>
-          <p:nvPr/>
-        </p:nvSpPr>
-        <p:spPr>
-          <a:xfrm>
-            <a:off x="4389120" y="3749040"/>
-            <a:ext cx="3520440" cy="1828800"/>
-          </a:xfrm>
-          <a:prstGeom prst="roundRect">
-            <a:avLst>
-              <a:gd name="adj" fmla="val 10000"/>
-            </a:avLst>
-          </a:prstGeom>
-          <a:solidFill>
-            <a:srgbClr val="0F211C"/>
-          </a:solidFill>
-          <a:ln/>
-        </p:spPr>
-      </p:sp>
-      <p:sp>
-        <p:nvSpPr>
-          <p:cNvPr id="17" name="Text 15"/>
-          <p:cNvSpPr/>
-          <p:nvPr/>
-        </p:nvSpPr>
-        <p:spPr>
-          <a:xfrm>
-            <a:off x="4617720" y="4069080"/>
-            <a:ext cx="3063240" cy="411480"/>
-          </a:xfrm>
-          <a:prstGeom prst="rect">
-            <a:avLst/>
-          </a:prstGeom>
-          <a:noFill/>
-          <a:ln/>
-        </p:spPr>
-        <p:txBody>
-          <a:bodyPr wrap="square" rtlCol="0" anchor="ctr"/>
-          <a:lstStyle/>
-          <a:p>
-            <a:pPr indent="0" marL="0">
-              <a:buNone/>
-            </a:pPr>
-            <a:r>
-              <a:rPr lang="en-US" sz="1600" b="1" dirty="0">
+                <a:latin typeface="Arial" pitchFamily="34" charset="0"/>
+                <a:ea typeface="Arial" pitchFamily="34" charset="-122"/>
+                <a:cs typeface="Arial" pitchFamily="34" charset="-120"/>
+              </a:rPr>
+              <a:t>Receiver sees “Payment Protected.”</a:t>
+            </a:r>
+            <a:endParaRPr lang="en-US" sz="2000" dirty="0"/>
+          </a:p>
+          <a:p>
+            <a:pPr marL="342900" indent="-342900">
+              <a:buSzPct val="100000"/>
+              <a:buChar char="•"/>
+            </a:pPr>
+            <a:r>
+              <a:rPr lang="en-US" sz="2000" dirty="0">
                 <a:solidFill>
                   <a:srgbClr val="E8F3EE"/>
                 </a:solidFill>
-              </a:rPr>
-              <a:t>Protected marketplace</a:t>
-            </a:r>
-            <a:endParaRPr lang="en-US" sz="1600" dirty="0"/>
-          </a:p>
-        </p:txBody>
-      </p:sp>
-      <p:sp>
-        <p:nvSpPr>
-          <p:cNvPr id="18" name="Text 16"/>
-          <p:cNvSpPr/>
-          <p:nvPr/>
-        </p:nvSpPr>
-        <p:spPr>
-          <a:xfrm>
-            <a:off x="4617720" y="4572000"/>
-            <a:ext cx="3063240" cy="731520"/>
-          </a:xfrm>
-          <a:prstGeom prst="rect">
-            <a:avLst/>
-          </a:prstGeom>
-          <a:noFill/>
-          <a:ln/>
-        </p:spPr>
-        <p:txBody>
-          <a:bodyPr wrap="square" rtlCol="0" anchor="ctr"/>
-          <a:lstStyle/>
-          <a:p>
-            <a:pPr indent="0" marL="0">
-              <a:buNone/>
-            </a:pPr>
-            <a:r>
-              <a:rPr lang="en-US" sz="1300" dirty="0">
-                <a:solidFill>
-                  <a:srgbClr val="8AA89D"/>
-                </a:solidFill>
-              </a:rPr>
-              <a:t>Escrow-style protection until delivery confirmed.</a:t>
-            </a:r>
-            <a:endParaRPr lang="en-US" sz="1300" dirty="0"/>
-          </a:p>
-        </p:txBody>
-      </p:sp>
-      <p:sp>
-        <p:nvSpPr>
-          <p:cNvPr id="19" name="Shape 17"/>
-          <p:cNvSpPr/>
-          <p:nvPr/>
-        </p:nvSpPr>
-        <p:spPr>
-          <a:xfrm>
-            <a:off x="8138160" y="3749040"/>
-            <a:ext cx="3520440" cy="1828800"/>
-          </a:xfrm>
-          <a:prstGeom prst="roundRect">
-            <a:avLst>
-              <a:gd name="adj" fmla="val 10000"/>
-            </a:avLst>
-          </a:prstGeom>
-          <a:solidFill>
-            <a:srgbClr val="0F211C"/>
-          </a:solidFill>
-          <a:ln/>
-        </p:spPr>
-      </p:sp>
-      <p:sp>
-        <p:nvSpPr>
-          <p:cNvPr id="20" name="Text 18"/>
-          <p:cNvSpPr/>
-          <p:nvPr/>
-        </p:nvSpPr>
-        <p:spPr>
-          <a:xfrm>
-            <a:off x="8366760" y="4069080"/>
-            <a:ext cx="3063240" cy="411480"/>
-          </a:xfrm>
-          <a:prstGeom prst="rect">
-            <a:avLst/>
-          </a:prstGeom>
-          <a:noFill/>
-          <a:ln/>
-        </p:spPr>
-        <p:txBody>
-          <a:bodyPr wrap="square" rtlCol="0" anchor="ctr"/>
-          <a:lstStyle/>
-          <a:p>
-            <a:pPr indent="0" marL="0">
-              <a:buNone/>
-            </a:pPr>
-            <a:r>
-              <a:rPr lang="en-US" sz="1600" b="1" dirty="0">
+                <a:latin typeface="Arial" pitchFamily="34" charset="0"/>
+                <a:ea typeface="Arial" pitchFamily="34" charset="-122"/>
+                <a:cs typeface="Arial" pitchFamily="34" charset="-120"/>
+              </a:rPr>
+              <a:t>Every step is logged on a visible timeline.</a:t>
+            </a:r>
+            <a:endParaRPr lang="en-US" sz="2000" dirty="0"/>
+          </a:p>
+          <a:p>
+            <a:pPr marL="342900" indent="-342900">
+              <a:buSzPct val="100000"/>
+              <a:buChar char="•"/>
+            </a:pPr>
+            <a:r>
+              <a:rPr lang="en-US" sz="2000" dirty="0">
                 <a:solidFill>
                   <a:srgbClr val="E8F3EE"/>
                 </a:solidFill>
-              </a:rPr>
-              <a:t>Money-aware support</a:t>
-            </a:r>
-            <a:endParaRPr lang="en-US" sz="1600" dirty="0"/>
-          </a:p>
-        </p:txBody>
-      </p:sp>
-      <p:sp>
-        <p:nvSpPr>
-          <p:cNvPr id="21" name="Text 19"/>
-          <p:cNvSpPr/>
-          <p:nvPr/>
-        </p:nvSpPr>
-        <p:spPr>
-          <a:xfrm>
-            <a:off x="8366760" y="4572000"/>
-            <a:ext cx="3063240" cy="731520"/>
-          </a:xfrm>
-          <a:prstGeom prst="rect">
-            <a:avLst/>
-          </a:prstGeom>
-          <a:noFill/>
-          <a:ln/>
-        </p:spPr>
-        <p:txBody>
-          <a:bodyPr wrap="square" rtlCol="0" anchor="ctr"/>
-          <a:lstStyle/>
-          <a:p>
-            <a:pPr indent="0" marL="0">
-              <a:buNone/>
-            </a:pPr>
-            <a:r>
-              <a:rPr lang="en-US" sz="1300" dirty="0">
-                <a:solidFill>
-                  <a:srgbClr val="8AA89D"/>
-                </a:solidFill>
-              </a:rPr>
-              <a:t>Find a tx, explain protection, escalate.</a:t>
-            </a:r>
-            <a:endParaRPr lang="en-US" sz="1300" dirty="0"/>
+                <a:latin typeface="Arial" pitchFamily="34" charset="0"/>
+                <a:ea typeface="Arial" pitchFamily="34" charset="-122"/>
+                <a:cs typeface="Arial" pitchFamily="34" charset="-120"/>
+              </a:rPr>
+              <a:t>Sender, receiver, and admin can act with clarity.</a:t>
+            </a:r>
+            <a:endParaRPr lang="en-US" sz="2000" dirty="0"/>
           </a:p>
         </p:txBody>
       </p:sp>
@@ -5248,7 +5727,7 @@
                 <a:ea typeface="Arial" pitchFamily="34" charset="-122"/>
                 <a:cs typeface="Arial" pitchFamily="34" charset="-120"/>
               </a:rPr>
-              <a:t>PRODUCT · LIVE</a:t>
+              <a:t>HOW IT WORKS</a:t>
             </a:r>
             <a:endParaRPr lang="en-US" sz="1100" dirty="0"/>
           </a:p>
@@ -5262,24 +5741,24 @@
         </p:nvSpPr>
         <p:spPr>
           <a:xfrm>
-            <a:off x="640080" y="640080"/>
-            <a:ext cx="10515600" cy="502920"/>
-          </a:xfrm>
-          <a:prstGeom prst="rect">
-            <a:avLst/>
-          </a:prstGeom>
-          <a:noFill/>
-          <a:ln/>
-        </p:spPr>
-        <p:txBody>
-          <a:bodyPr wrap="square" rtlCol="0" anchor="ctr"/>
-          <a:lstStyle/>
-          <a:p>
-            <a:pPr indent="0" marL="0">
-              <a:buNone/>
-            </a:pPr>
-            <a:r>
-              <a:rPr lang="en-US" sz="2400" b="1" dirty="0">
+            <a:off x="640080" y="685800"/>
+            <a:ext cx="10515600" cy="548640"/>
+          </a:xfrm>
+          <a:prstGeom prst="rect">
+            <a:avLst/>
+          </a:prstGeom>
+          <a:noFill/>
+          <a:ln/>
+        </p:spPr>
+        <p:txBody>
+          <a:bodyPr wrap="square" rtlCol="0" anchor="ctr"/>
+          <a:lstStyle/>
+          <a:p>
+            <a:pPr indent="0" marL="0">
+              <a:buNone/>
+            </a:pPr>
+            <a:r>
+              <a:rPr lang="en-US" sz="2600" b="1" dirty="0">
                 <a:solidFill>
                   <a:srgbClr val="E8F3EE"/>
                 </a:solidFill>
@@ -5287,15 +5766,15 @@
                 <a:ea typeface="Arial" pitchFamily="34" charset="-122"/>
                 <a:cs typeface="Arial" pitchFamily="34" charset="-120"/>
               </a:rPr>
-              <a:t>Security posture. Business on the way.</a:t>
-            </a:r>
-            <a:endParaRPr lang="en-US" sz="2400" dirty="0"/>
+              <a:t>Clear flows. Safer money.</a:t>
+            </a:r>
+            <a:endParaRPr lang="en-US" sz="2600" dirty="0"/>
           </a:p>
         </p:txBody>
       </p:sp>
       <p:pic>
         <p:nvPicPr>
-          <p:cNvPr id="4" name="Image 0" descr="C:\Users\roten\Documents\reton\presentations\screenshots\03-security.png">    </p:cNvPr>
+          <p:cNvPr id="4" name="Image 0" descr="C:\Users\roten\Documents\reton\presentations\screenshots\02-how-it-works.png">    </p:cNvPr>
           <p:cNvPicPr>
             <a:picLocks noChangeAspect="1"/>
           </p:cNvPicPr>
@@ -5309,32 +5788,8 @@
         </p:blipFill>
         <p:spPr>
           <a:xfrm>
-            <a:off x="502920" y="1280160"/>
-            <a:ext cx="5486400" cy="4846320"/>
-          </a:xfrm>
-          <a:prstGeom prst="rect">
-            <a:avLst/>
-          </a:prstGeom>
-        </p:spPr>
-      </p:pic>
-      <p:pic>
-        <p:nvPicPr>
-          <p:cNvPr id="5" name="Image 1" descr="C:\Users\roten\Documents\reton\presentations\screenshots\04-business.png">    </p:cNvPr>
-          <p:cNvPicPr>
-            <a:picLocks noChangeAspect="1"/>
-          </p:cNvPicPr>
-          <p:nvPr/>
-        </p:nvPicPr>
-        <p:blipFill>
-          <a:blip r:embed="rId2"/>
-          <a:stretch>
-            <a:fillRect/>
-          </a:stretch>
-        </p:blipFill>
-        <p:spPr>
-          <a:xfrm>
-            <a:off x="6172200" y="1280160"/>
-            <a:ext cx="5486400" cy="4846320"/>
+            <a:off x="640080" y="1325880"/>
+            <a:ext cx="10881360" cy="4937760"/>
           </a:xfrm>
           <a:prstGeom prst="rect">
             <a:avLst/>
@@ -5406,7 +5861,7 @@
                 <a:ea typeface="Arial" pitchFamily="34" charset="-122"/>
                 <a:cs typeface="Arial" pitchFamily="34" charset="-120"/>
               </a:rPr>
-              <a:t>ALATPAY INTEGRATION</a:t>
+              <a:t>WHAT WE BUILT</a:t>
             </a:r>
             <a:endParaRPr lang="en-US" sz="1100" dirty="0"/>
           </a:p>
@@ -5420,7 +5875,7 @@
         </p:nvSpPr>
         <p:spPr>
           <a:xfrm>
-            <a:off x="640080" y="777240"/>
+            <a:off x="640080" y="731520"/>
             <a:ext cx="10515600" cy="640080"/>
           </a:xfrm>
           <a:prstGeom prst="rect">
@@ -5437,7 +5892,7 @@
               <a:buNone/>
             </a:pPr>
             <a:r>
-              <a:rPr lang="en-US" sz="3000" b="1" dirty="0">
+              <a:rPr lang="en-US" sz="2800" b="1" dirty="0">
                 <a:solidFill>
                   <a:srgbClr val="E8F3EE"/>
                 </a:solidFill>
@@ -5445,9 +5900,9 @@
                 <a:ea typeface="Arial" pitchFamily="34" charset="-122"/>
                 <a:cs typeface="Arial" pitchFamily="34" charset="-120"/>
               </a:rPr>
-              <a:t>Real rails. Not a mock bank.</a:t>
-            </a:r>
-            <a:endParaRPr lang="en-US" sz="3000" dirty="0"/>
+              <a:t>A full trust stack — not slideware.</a:t>
+            </a:r>
+            <a:endParaRPr lang="en-US" sz="2800" dirty="0"/>
           </a:p>
         </p:txBody>
       </p:sp>
@@ -5459,12 +5914,12 @@
         </p:nvSpPr>
         <p:spPr>
           <a:xfrm>
-            <a:off x="640080" y="1737360"/>
-            <a:ext cx="5212080" cy="2377440"/>
+            <a:off x="640080" y="1645920"/>
+            <a:ext cx="3520440" cy="1828800"/>
           </a:xfrm>
           <a:prstGeom prst="roundRect">
             <a:avLst>
-              <a:gd name="adj" fmla="val 7692"/>
+              <a:gd name="adj" fmla="val 10000"/>
             </a:avLst>
           </a:prstGeom>
           <a:solidFill>
@@ -5481,8 +5936,8 @@
         </p:nvSpPr>
         <p:spPr>
           <a:xfrm>
-            <a:off x="914400" y="1965960"/>
-            <a:ext cx="4663440" cy="365760"/>
+            <a:off x="868680" y="1965960"/>
+            <a:ext cx="3063240" cy="411480"/>
           </a:xfrm>
           <a:prstGeom prst="rect">
             <a:avLst/>
@@ -5503,7 +5958,7 @@
                   <a:srgbClr val="E8F3EE"/>
                 </a:solidFill>
               </a:rPr>
-              <a:t>What we use</a:t>
+              <a:t>Wrong-transfer recovery</a:t>
             </a:r>
             <a:endParaRPr lang="en-US" sz="1600" dirty="0"/>
           </a:p>
@@ -5517,31 +5972,31 @@
         </p:nvSpPr>
         <p:spPr>
           <a:xfrm>
-            <a:off x="914400" y="2468880"/>
-            <a:ext cx="4663440" cy="1280160"/>
-          </a:xfrm>
-          <a:prstGeom prst="rect">
-            <a:avLst/>
-          </a:prstGeom>
-          <a:noFill/>
-          <a:ln/>
-        </p:spPr>
-        <p:txBody>
-          <a:bodyPr wrap="square" rtlCol="0" anchor="ctr"/>
-          <a:lstStyle/>
-          <a:p>
-            <a:pPr indent="0" marL="0">
-              <a:buNone/>
-            </a:pPr>
-            <a:r>
-              <a:rPr lang="en-US" sz="1500" dirty="0">
+            <a:off x="868680" y="2468880"/>
+            <a:ext cx="3063240" cy="731520"/>
+          </a:xfrm>
+          <a:prstGeom prst="rect">
+            <a:avLst/>
+          </a:prstGeom>
+          <a:noFill/>
+          <a:ln/>
+        </p:spPr>
+        <p:txBody>
+          <a:bodyPr wrap="square" rtlCol="0" anchor="ctr"/>
+          <a:lstStyle/>
+          <a:p>
+            <a:pPr indent="0" marL="0">
+              <a:buNone/>
+            </a:pPr>
+            <a:r>
+              <a:rPr lang="en-US" sz="1300" dirty="0">
                 <a:solidFill>
                   <a:srgbClr val="8AA89D"/>
                 </a:solidFill>
               </a:rPr>
-              <a:t>Collections &amp; payment links · Static virtual accounts · BVN OTP · Signed webhooks · Transaction verification</a:t>
-            </a:r>
-            <a:endParaRPr lang="en-US" sz="1500" dirty="0"/>
+              <a:t>Report a mistake. Hold eligible funds. Track the case.</a:t>
+            </a:r>
+            <a:endParaRPr lang="en-US" sz="1300" dirty="0"/>
           </a:p>
         </p:txBody>
       </p:sp>
@@ -5553,12 +6008,12 @@
         </p:nvSpPr>
         <p:spPr>
           <a:xfrm>
-            <a:off x="6126480" y="1737360"/>
-            <a:ext cx="5212080" cy="2377440"/>
+            <a:off x="4389120" y="1645920"/>
+            <a:ext cx="3520440" cy="1828800"/>
           </a:xfrm>
           <a:prstGeom prst="roundRect">
             <a:avLst>
-              <a:gd name="adj" fmla="val 7692"/>
+              <a:gd name="adj" fmla="val 10000"/>
             </a:avLst>
           </a:prstGeom>
           <a:solidFill>
@@ -5575,8 +6030,8 @@
         </p:nvSpPr>
         <p:spPr>
           <a:xfrm>
-            <a:off x="6400800" y="1965960"/>
-            <a:ext cx="4663440" cy="365760"/>
+            <a:off x="4617720" y="1965960"/>
+            <a:ext cx="3063240" cy="411480"/>
           </a:xfrm>
           <a:prstGeom prst="rect">
             <a:avLst/>
@@ -5597,7 +6052,7 @@
                   <a:srgbClr val="E8F3EE"/>
                 </a:solidFill>
               </a:rPr>
-              <a:t>Where money enters</a:t>
+              <a:t>Fraud signals</a:t>
             </a:r>
             <a:endParaRPr lang="en-US" sz="1600" dirty="0"/>
           </a:p>
@@ -5611,70 +6066,407 @@
         </p:nvSpPr>
         <p:spPr>
           <a:xfrm>
-            <a:off x="6400800" y="2468880"/>
-            <a:ext cx="4663440" cy="1280160"/>
-          </a:xfrm>
-          <a:prstGeom prst="rect">
-            <a:avLst/>
-          </a:prstGeom>
-          <a:noFill/>
-          <a:ln/>
-        </p:spPr>
-        <p:txBody>
-          <a:bodyPr wrap="square" rtlCol="0" anchor="ctr"/>
-          <a:lstStyle/>
-          <a:p>
-            <a:pPr indent="0" marL="0">
-              <a:buNone/>
-            </a:pPr>
-            <a:r>
-              <a:rPr lang="en-US" sz="1500" dirty="0">
+            <a:off x="4617720" y="2468880"/>
+            <a:ext cx="3063240" cy="731520"/>
+          </a:xfrm>
+          <a:prstGeom prst="rect">
+            <a:avLst/>
+          </a:prstGeom>
+          <a:noFill/>
+          <a:ln/>
+        </p:spPr>
+        <p:txBody>
+          <a:bodyPr wrap="square" rtlCol="0" anchor="ctr"/>
+          <a:lstStyle/>
+          <a:p>
+            <a:pPr indent="0" marL="0">
+              <a:buNone/>
+            </a:pPr>
+            <a:r>
+              <a:rPr lang="en-US" sz="1300" dirty="0">
                 <a:solidFill>
                   <a:srgbClr val="8AA89D"/>
                 </a:solidFill>
               </a:rPr>
-              <a:t>Users fund Reton wallets on ALATPay. We credit our ledger only after verified settlement.</a:t>
-            </a:r>
-            <a:endParaRPr lang="en-US" sz="1500" dirty="0"/>
-          </a:p>
-        </p:txBody>
-      </p:sp>
-      <p:sp>
-        <p:nvSpPr>
-          <p:cNvPr id="10" name="Text 8"/>
-          <p:cNvSpPr/>
-          <p:nvPr/>
-        </p:nvSpPr>
-        <p:spPr>
-          <a:xfrm>
-            <a:off x="640080" y="4572000"/>
-            <a:ext cx="10058400" cy="1097280"/>
-          </a:xfrm>
-          <a:prstGeom prst="rect">
-            <a:avLst/>
-          </a:prstGeom>
-          <a:noFill/>
-          <a:ln/>
-        </p:spPr>
-        <p:txBody>
-          <a:bodyPr wrap="square" rtlCol="0" anchor="ctr"/>
-          <a:lstStyle/>
-          <a:p>
-            <a:pPr indent="0" marL="0">
-              <a:buNone/>
-            </a:pPr>
-            <a:r>
-              <a:rPr lang="en-US" sz="1800" dirty="0">
+              <a:t>Rule-based scoring with admin visibility.</a:t>
+            </a:r>
+            <a:endParaRPr lang="en-US" sz="1300" dirty="0"/>
+          </a:p>
+        </p:txBody>
+      </p:sp>
+      <p:sp>
+        <p:nvSpPr>
+          <p:cNvPr id="10" name="Shape 8"/>
+          <p:cNvSpPr/>
+          <p:nvPr/>
+        </p:nvSpPr>
+        <p:spPr>
+          <a:xfrm>
+            <a:off x="8138160" y="1645920"/>
+            <a:ext cx="3520440" cy="1828800"/>
+          </a:xfrm>
+          <a:prstGeom prst="roundRect">
+            <a:avLst>
+              <a:gd name="adj" fmla="val 10000"/>
+            </a:avLst>
+          </a:prstGeom>
+          <a:solidFill>
+            <a:srgbClr val="0F211C"/>
+          </a:solidFill>
+          <a:ln/>
+        </p:spPr>
+      </p:sp>
+      <p:sp>
+        <p:nvSpPr>
+          <p:cNvPr id="11" name="Text 9"/>
+          <p:cNvSpPr/>
+          <p:nvPr/>
+        </p:nvSpPr>
+        <p:spPr>
+          <a:xfrm>
+            <a:off x="8366760" y="1965960"/>
+            <a:ext cx="3063240" cy="411480"/>
+          </a:xfrm>
+          <a:prstGeom prst="rect">
+            <a:avLst/>
+          </a:prstGeom>
+          <a:noFill/>
+          <a:ln/>
+        </p:spPr>
+        <p:txBody>
+          <a:bodyPr wrap="square" rtlCol="0" anchor="ctr"/>
+          <a:lstStyle/>
+          <a:p>
+            <a:pPr indent="0" marL="0">
+              <a:buNone/>
+            </a:pPr>
+            <a:r>
+              <a:rPr lang="en-US" sz="1600" b="1" dirty="0">
+                <a:solidFill>
+                  <a:srgbClr val="E8F3EE"/>
+                </a:solidFill>
+              </a:rPr>
+              <a:t>Double-entry wallet</a:t>
+            </a:r>
+            <a:endParaRPr lang="en-US" sz="1600" dirty="0"/>
+          </a:p>
+        </p:txBody>
+      </p:sp>
+      <p:sp>
+        <p:nvSpPr>
+          <p:cNvPr id="12" name="Text 10"/>
+          <p:cNvSpPr/>
+          <p:nvPr/>
+        </p:nvSpPr>
+        <p:spPr>
+          <a:xfrm>
+            <a:off x="8366760" y="2468880"/>
+            <a:ext cx="3063240" cy="731520"/>
+          </a:xfrm>
+          <a:prstGeom prst="rect">
+            <a:avLst/>
+          </a:prstGeom>
+          <a:noFill/>
+          <a:ln/>
+        </p:spPr>
+        <p:txBody>
+          <a:bodyPr wrap="square" rtlCol="0" anchor="ctr"/>
+          <a:lstStyle/>
+          <a:p>
+            <a:pPr indent="0" marL="0">
+              <a:buNone/>
+            </a:pPr>
+            <a:r>
+              <a:rPr lang="en-US" sz="1300" dirty="0">
                 <a:solidFill>
                   <a:srgbClr val="8AA89D"/>
                 </a:solidFill>
-                <a:latin typeface="Arial" pitchFamily="34" charset="0"/>
-                <a:ea typeface="Arial" pitchFamily="34" charset="-122"/>
-                <a:cs typeface="Arial" pitchFamily="34" charset="-120"/>
-              </a:rPr>
-              <a:t>ALAT by Wema gives us a licensed Nigerian bank rail — so Callback Protection sits on infrastructure people can trust.</a:t>
-            </a:r>
-            <a:endParaRPr lang="en-US" sz="1800" dirty="0"/>
+              </a:rPr>
+              <a:t>Every naira ledgered — no silent tweaks.</a:t>
+            </a:r>
+            <a:endParaRPr lang="en-US" sz="1300" dirty="0"/>
+          </a:p>
+        </p:txBody>
+      </p:sp>
+      <p:sp>
+        <p:nvSpPr>
+          <p:cNvPr id="13" name="Shape 11"/>
+          <p:cNvSpPr/>
+          <p:nvPr/>
+        </p:nvSpPr>
+        <p:spPr>
+          <a:xfrm>
+            <a:off x="640080" y="3749040"/>
+            <a:ext cx="3520440" cy="1828800"/>
+          </a:xfrm>
+          <a:prstGeom prst="roundRect">
+            <a:avLst>
+              <a:gd name="adj" fmla="val 10000"/>
+            </a:avLst>
+          </a:prstGeom>
+          <a:solidFill>
+            <a:srgbClr val="0F211C"/>
+          </a:solidFill>
+          <a:ln/>
+        </p:spPr>
+      </p:sp>
+      <p:sp>
+        <p:nvSpPr>
+          <p:cNvPr id="14" name="Text 12"/>
+          <p:cNvSpPr/>
+          <p:nvPr/>
+        </p:nvSpPr>
+        <p:spPr>
+          <a:xfrm>
+            <a:off x="868680" y="4069080"/>
+            <a:ext cx="3063240" cy="411480"/>
+          </a:xfrm>
+          <a:prstGeom prst="rect">
+            <a:avLst/>
+          </a:prstGeom>
+          <a:noFill/>
+          <a:ln/>
+        </p:spPr>
+        <p:txBody>
+          <a:bodyPr wrap="square" rtlCol="0" anchor="ctr"/>
+          <a:lstStyle/>
+          <a:p>
+            <a:pPr indent="0" marL="0">
+              <a:buNone/>
+            </a:pPr>
+            <a:r>
+              <a:rPr lang="en-US" sz="1600" b="1" dirty="0">
+                <a:solidFill>
+                  <a:srgbClr val="E8F3EE"/>
+                </a:solidFill>
+              </a:rPr>
+              <a:t>KYC tiers</a:t>
+            </a:r>
+            <a:endParaRPr lang="en-US" sz="1600" dirty="0"/>
+          </a:p>
+        </p:txBody>
+      </p:sp>
+      <p:sp>
+        <p:nvSpPr>
+          <p:cNvPr id="15" name="Text 13"/>
+          <p:cNvSpPr/>
+          <p:nvPr/>
+        </p:nvSpPr>
+        <p:spPr>
+          <a:xfrm>
+            <a:off x="868680" y="4572000"/>
+            <a:ext cx="3063240" cy="731520"/>
+          </a:xfrm>
+          <a:prstGeom prst="rect">
+            <a:avLst/>
+          </a:prstGeom>
+          <a:noFill/>
+          <a:ln/>
+        </p:spPr>
+        <p:txBody>
+          <a:bodyPr wrap="square" rtlCol="0" anchor="ctr"/>
+          <a:lstStyle/>
+          <a:p>
+            <a:pPr indent="0" marL="0">
+              <a:buNone/>
+            </a:pPr>
+            <a:r>
+              <a:rPr lang="en-US" sz="1300" dirty="0">
+                <a:solidFill>
+                  <a:srgbClr val="8AA89D"/>
+                </a:solidFill>
+              </a:rPr>
+              <a:t>CBN-aligned limits. BVN unlock for funding.</a:t>
+            </a:r>
+            <a:endParaRPr lang="en-US" sz="1300" dirty="0"/>
+          </a:p>
+        </p:txBody>
+      </p:sp>
+      <p:sp>
+        <p:nvSpPr>
+          <p:cNvPr id="16" name="Shape 14"/>
+          <p:cNvSpPr/>
+          <p:nvPr/>
+        </p:nvSpPr>
+        <p:spPr>
+          <a:xfrm>
+            <a:off x="4389120" y="3749040"/>
+            <a:ext cx="3520440" cy="1828800"/>
+          </a:xfrm>
+          <a:prstGeom prst="roundRect">
+            <a:avLst>
+              <a:gd name="adj" fmla="val 10000"/>
+            </a:avLst>
+          </a:prstGeom>
+          <a:solidFill>
+            <a:srgbClr val="0F211C"/>
+          </a:solidFill>
+          <a:ln/>
+        </p:spPr>
+      </p:sp>
+      <p:sp>
+        <p:nvSpPr>
+          <p:cNvPr id="17" name="Text 15"/>
+          <p:cNvSpPr/>
+          <p:nvPr/>
+        </p:nvSpPr>
+        <p:spPr>
+          <a:xfrm>
+            <a:off x="4617720" y="4069080"/>
+            <a:ext cx="3063240" cy="411480"/>
+          </a:xfrm>
+          <a:prstGeom prst="rect">
+            <a:avLst/>
+          </a:prstGeom>
+          <a:noFill/>
+          <a:ln/>
+        </p:spPr>
+        <p:txBody>
+          <a:bodyPr wrap="square" rtlCol="0" anchor="ctr"/>
+          <a:lstStyle/>
+          <a:p>
+            <a:pPr indent="0" marL="0">
+              <a:buNone/>
+            </a:pPr>
+            <a:r>
+              <a:rPr lang="en-US" sz="1600" b="1" dirty="0">
+                <a:solidFill>
+                  <a:srgbClr val="E8F3EE"/>
+                </a:solidFill>
+              </a:rPr>
+              <a:t>Protected marketplace</a:t>
+            </a:r>
+            <a:endParaRPr lang="en-US" sz="1600" dirty="0"/>
+          </a:p>
+        </p:txBody>
+      </p:sp>
+      <p:sp>
+        <p:nvSpPr>
+          <p:cNvPr id="18" name="Text 16"/>
+          <p:cNvSpPr/>
+          <p:nvPr/>
+        </p:nvSpPr>
+        <p:spPr>
+          <a:xfrm>
+            <a:off x="4617720" y="4572000"/>
+            <a:ext cx="3063240" cy="731520"/>
+          </a:xfrm>
+          <a:prstGeom prst="rect">
+            <a:avLst/>
+          </a:prstGeom>
+          <a:noFill/>
+          <a:ln/>
+        </p:spPr>
+        <p:txBody>
+          <a:bodyPr wrap="square" rtlCol="0" anchor="ctr"/>
+          <a:lstStyle/>
+          <a:p>
+            <a:pPr indent="0" marL="0">
+              <a:buNone/>
+            </a:pPr>
+            <a:r>
+              <a:rPr lang="en-US" sz="1300" dirty="0">
+                <a:solidFill>
+                  <a:srgbClr val="8AA89D"/>
+                </a:solidFill>
+              </a:rPr>
+              <a:t>Escrow-style protection until delivery confirmed.</a:t>
+            </a:r>
+            <a:endParaRPr lang="en-US" sz="1300" dirty="0"/>
+          </a:p>
+        </p:txBody>
+      </p:sp>
+      <p:sp>
+        <p:nvSpPr>
+          <p:cNvPr id="19" name="Shape 17"/>
+          <p:cNvSpPr/>
+          <p:nvPr/>
+        </p:nvSpPr>
+        <p:spPr>
+          <a:xfrm>
+            <a:off x="8138160" y="3749040"/>
+            <a:ext cx="3520440" cy="1828800"/>
+          </a:xfrm>
+          <a:prstGeom prst="roundRect">
+            <a:avLst>
+              <a:gd name="adj" fmla="val 10000"/>
+            </a:avLst>
+          </a:prstGeom>
+          <a:solidFill>
+            <a:srgbClr val="0F211C"/>
+          </a:solidFill>
+          <a:ln/>
+        </p:spPr>
+      </p:sp>
+      <p:sp>
+        <p:nvSpPr>
+          <p:cNvPr id="20" name="Text 18"/>
+          <p:cNvSpPr/>
+          <p:nvPr/>
+        </p:nvSpPr>
+        <p:spPr>
+          <a:xfrm>
+            <a:off x="8366760" y="4069080"/>
+            <a:ext cx="3063240" cy="411480"/>
+          </a:xfrm>
+          <a:prstGeom prst="rect">
+            <a:avLst/>
+          </a:prstGeom>
+          <a:noFill/>
+          <a:ln/>
+        </p:spPr>
+        <p:txBody>
+          <a:bodyPr wrap="square" rtlCol="0" anchor="ctr"/>
+          <a:lstStyle/>
+          <a:p>
+            <a:pPr indent="0" marL="0">
+              <a:buNone/>
+            </a:pPr>
+            <a:r>
+              <a:rPr lang="en-US" sz="1600" b="1" dirty="0">
+                <a:solidFill>
+                  <a:srgbClr val="E8F3EE"/>
+                </a:solidFill>
+              </a:rPr>
+              <a:t>Money-aware support</a:t>
+            </a:r>
+            <a:endParaRPr lang="en-US" sz="1600" dirty="0"/>
+          </a:p>
+        </p:txBody>
+      </p:sp>
+      <p:sp>
+        <p:nvSpPr>
+          <p:cNvPr id="21" name="Text 19"/>
+          <p:cNvSpPr/>
+          <p:nvPr/>
+        </p:nvSpPr>
+        <p:spPr>
+          <a:xfrm>
+            <a:off x="8366760" y="4572000"/>
+            <a:ext cx="3063240" cy="731520"/>
+          </a:xfrm>
+          <a:prstGeom prst="rect">
+            <a:avLst/>
+          </a:prstGeom>
+          <a:noFill/>
+          <a:ln/>
+        </p:spPr>
+        <p:txBody>
+          <a:bodyPr wrap="square" rtlCol="0" anchor="ctr"/>
+          <a:lstStyle/>
+          <a:p>
+            <a:pPr indent="0" marL="0">
+              <a:buNone/>
+            </a:pPr>
+            <a:r>
+              <a:rPr lang="en-US" sz="1300" dirty="0">
+                <a:solidFill>
+                  <a:srgbClr val="8AA89D"/>
+                </a:solidFill>
+              </a:rPr>
+              <a:t>Find a tx, explain protection, escalate.</a:t>
+            </a:r>
+            <a:endParaRPr lang="en-US" sz="1300" dirty="0"/>
           </a:p>
         </p:txBody>
       </p:sp>

</xml_diff>

<commit_message>
Surface protected shop listings on public pages and pitch deck.
Add a human Sell with protection teaser so Callback Protection has a concrete commerce story for the buildathon.
</commit_message>
<xml_diff>
--- a/presentations/Reton-ALATPay-Buildathon-Pitch.pptx
+++ b/presentations/Reton-ALATPay-Buildathon-Pitch.pptx
@@ -21,9 +21,10 @@
     <p:sldId id="269" r:id="rId15"/>
     <p:sldId id="270" r:id="rId16"/>
     <p:sldId id="271" r:id="rId17"/>
+    <p:sldId id="272" r:id="rId18"/>
   </p:sldIdLst>
   <p:notesMasterIdLst>
-    <p:notesMasterId r:id="rId18"/>
+    <p:notesMasterId r:id="rId19"/>
   </p:notesMasterIdLst>
   <p:sldSz cx="12191695" cy="6858000"/>
   <p:notesSz cx="6858000" cy="12191695"/>
@@ -1157,6 +1158,94 @@
             <a:fld id="{F7021451-1387-4CA6-816F-3879F97B5CBC}" type="slidenum">
               <a:rPr lang="en-US"/>
               <a:t>16</a:t>
+            </a:fld>
+            <a:endParaRPr lang="en-US"/>
+          </a:p>
+        </p:txBody>
+      </p:sp>
+    </p:spTree>
+    <p:extLst>
+      <p:ext uri="{BB962C8B-B14F-4D97-AF65-F5344CB8AC3E}">
+        <p14:creationId xmlns:p14="http://schemas.microsoft.com/office/powerpoint/2010/main" val="1024086991"/>
+      </p:ext>
+    </p:extLst>
+  </p:cSld>
+  <p:clrMapOvr>
+    <a:masterClrMapping/>
+  </p:clrMapOvr>
+</p:notes>
+</file>
+
+<file path=ppt/notesSlides/notesSlide17.xml><?xml version="1.0" encoding="utf-8"?>
+<p:notes xmlns:a="http://schemas.openxmlformats.org/drawingml/2006/main" xmlns:r="http://schemas.openxmlformats.org/officeDocument/2006/relationships" xmlns:p="http://schemas.openxmlformats.org/presentationml/2006/main">
+  <p:cSld>
+    <p:spTree>
+      <p:nvGrpSpPr>
+        <p:cNvPr id="1" name=""/>
+        <p:cNvGrpSpPr/>
+        <p:nvPr/>
+      </p:nvGrpSpPr>
+      <p:grpSpPr>
+        <a:xfrm>
+          <a:off x="0" y="0"/>
+          <a:ext cx="0" cy="0"/>
+          <a:chOff x="0" y="0"/>
+          <a:chExt cx="0" cy="0"/>
+        </a:xfrm>
+      </p:grpSpPr>
+      <p:sp>
+        <p:nvSpPr>
+          <p:cNvPr id="2" name="Slide Image Placeholder 1"/>
+          <p:cNvSpPr>
+            <a:spLocks noGrp="1" noRot="1" noChangeAspect="1"/>
+          </p:cNvSpPr>
+          <p:nvPr>
+            <p:ph type="sldImg"/>
+          </p:nvPr>
+        </p:nvSpPr>
+        <p:spPr/>
+      </p:sp>
+      <p:sp>
+        <p:nvSpPr>
+          <p:cNvPr id="3" name="Notes Placeholder 2"/>
+          <p:cNvSpPr>
+            <a:spLocks noGrp="1"/>
+          </p:cNvSpPr>
+          <p:nvPr>
+            <p:ph type="body" idx="1"/>
+          </p:nvPr>
+        </p:nvSpPr>
+        <p:spPr/>
+        <p:txBody>
+          <a:bodyPr/>
+          <a:lstStyle/>
+          <a:p>
+            <a:r>
+              <a:rPr lang="en-US" dirty="0"/>
+              <a:t/>
+            </a:r>
+            <a:endParaRPr lang="en-US" dirty="0"/>
+          </a:p>
+        </p:txBody>
+      </p:sp>
+      <p:sp>
+        <p:nvSpPr>
+          <p:cNvPr id="4" name="Slide Number Placeholder 3"/>
+          <p:cNvSpPr>
+            <a:spLocks noGrp="1"/>
+          </p:cNvSpPr>
+          <p:nvPr>
+            <p:ph type="sldNum" sz="quarter" idx="10"/>
+          </p:nvPr>
+        </p:nvSpPr>
+        <p:spPr/>
+        <p:txBody>
+          <a:bodyPr/>
+          <a:lstStyle/>
+          <a:p>
+            <a:fld id="{F7021451-1387-4CA6-816F-3879F97B5CBC}" type="slidenum">
+              <a:rPr lang="en-US"/>
+              <a:t>17</a:t>
             </a:fld>
             <a:endParaRPr lang="en-US"/>
           </a:p>
@@ -2428,7 +2517,7 @@
                 <a:ea typeface="Arial" pitchFamily="34" charset="-122"/>
                 <a:cs typeface="Arial" pitchFamily="34" charset="-120"/>
               </a:rPr>
-              <a:t>PRODUCT · LIVE</a:t>
+              <a:t>SHOP &amp; LISTINGS</a:t>
             </a:r>
             <a:endParaRPr lang="en-US" sz="1100" dirty="0"/>
           </a:p>
@@ -2442,24 +2531,24 @@
         </p:nvSpPr>
         <p:spPr>
           <a:xfrm>
-            <a:off x="640080" y="640080"/>
-            <a:ext cx="10515600" cy="502920"/>
-          </a:xfrm>
-          <a:prstGeom prst="rect">
-            <a:avLst/>
-          </a:prstGeom>
-          <a:noFill/>
-          <a:ln/>
-        </p:spPr>
-        <p:txBody>
-          <a:bodyPr wrap="square" rtlCol="0" anchor="ctr"/>
-          <a:lstStyle/>
-          <a:p>
-            <a:pPr indent="0" marL="0">
-              <a:buNone/>
-            </a:pPr>
-            <a:r>
-              <a:rPr lang="en-US" sz="2400" b="1" dirty="0">
+            <a:off x="640080" y="777240"/>
+            <a:ext cx="10515600" cy="1280160"/>
+          </a:xfrm>
+          <a:prstGeom prst="rect">
+            <a:avLst/>
+          </a:prstGeom>
+          <a:noFill/>
+          <a:ln/>
+        </p:spPr>
+        <p:txBody>
+          <a:bodyPr wrap="square" rtlCol="0" anchor="ctr"/>
+          <a:lstStyle/>
+          <a:p>
+            <a:pPr indent="0" marL="0">
+              <a:buNone/>
+            </a:pPr>
+            <a:r>
+              <a:rPr lang="en-US" sz="3600" b="1" dirty="0">
                 <a:solidFill>
                   <a:srgbClr val="E8F3EE"/>
                 </a:solidFill>
@@ -2467,60 +2556,162 @@
                 <a:ea typeface="Arial" pitchFamily="34" charset="-122"/>
                 <a:cs typeface="Arial" pitchFamily="34" charset="-120"/>
               </a:rPr>
-              <a:t>Security posture. Business on the way.</a:t>
-            </a:r>
-            <a:endParaRPr lang="en-US" sz="2400" dirty="0"/>
-          </a:p>
-        </p:txBody>
-      </p:sp>
-      <p:pic>
-        <p:nvPicPr>
-          <p:cNvPr id="4" name="Image 0" descr="C:\Users\roten\Documents\reton\presentations\screenshots\03-security.png">    </p:cNvPr>
-          <p:cNvPicPr>
-            <a:picLocks noChangeAspect="1"/>
-          </p:cNvPicPr>
-          <p:nvPr/>
-        </p:nvPicPr>
-        <p:blipFill>
-          <a:blip r:embed="rId1"/>
-          <a:stretch>
-            <a:fillRect/>
-          </a:stretch>
-        </p:blipFill>
-        <p:spPr>
-          <a:xfrm>
-            <a:off x="502920" y="1280160"/>
-            <a:ext cx="5486400" cy="4846320"/>
-          </a:xfrm>
-          <a:prstGeom prst="rect">
-            <a:avLst/>
-          </a:prstGeom>
-        </p:spPr>
-      </p:pic>
-      <p:pic>
-        <p:nvPicPr>
-          <p:cNvPr id="5" name="Image 1" descr="C:\Users\roten\Documents\reton\presentations\screenshots\04-business.png">    </p:cNvPr>
-          <p:cNvPicPr>
-            <a:picLocks noChangeAspect="1"/>
-          </p:cNvPicPr>
-          <p:nvPr/>
-        </p:nvPicPr>
-        <p:blipFill>
-          <a:blip r:embed="rId2"/>
-          <a:stretch>
-            <a:fillRect/>
-          </a:stretch>
-        </p:blipFill>
-        <p:spPr>
-          <a:xfrm>
-            <a:off x="6172200" y="1280160"/>
-            <a:ext cx="5486400" cy="4846320"/>
-          </a:xfrm>
-          <a:prstGeom prst="rect">
-            <a:avLst/>
-          </a:prstGeom>
-        </p:spPr>
-      </p:pic>
+              <a:t>Sell something.</a:t>
+            </a:r>
+            <a:endParaRPr lang="en-US" sz="3600" dirty="0"/>
+          </a:p>
+          <a:p>
+            <a:pPr indent="0" marL="0">
+              <a:buNone/>
+            </a:pPr>
+            <a:r>
+              <a:rPr lang="en-US" sz="3600" b="1" dirty="0">
+                <a:solidFill>
+                  <a:srgbClr val="E8F3EE"/>
+                </a:solidFill>
+                <a:latin typeface="Arial" pitchFamily="34" charset="0"/>
+                <a:ea typeface="Arial" pitchFamily="34" charset="-122"/>
+                <a:cs typeface="Arial" pitchFamily="34" charset="-120"/>
+              </a:rPr>
+              <a:t>Get paid — safely.</a:t>
+            </a:r>
+            <a:endParaRPr lang="en-US" sz="3600" dirty="0"/>
+          </a:p>
+        </p:txBody>
+      </p:sp>
+      <p:sp>
+        <p:nvSpPr>
+          <p:cNvPr id="4" name="Text 2"/>
+          <p:cNvSpPr/>
+          <p:nvPr/>
+        </p:nvSpPr>
+        <p:spPr>
+          <a:xfrm>
+            <a:off x="640080" y="2103120"/>
+            <a:ext cx="10058400" cy="1005840"/>
+          </a:xfrm>
+          <a:prstGeom prst="rect">
+            <a:avLst/>
+          </a:prstGeom>
+          <a:noFill/>
+          <a:ln/>
+        </p:spPr>
+        <p:txBody>
+          <a:bodyPr wrap="square" rtlCol="0" anchor="ctr"/>
+          <a:lstStyle/>
+          <a:p>
+            <a:pPr indent="0" marL="0">
+              <a:buNone/>
+            </a:pPr>
+            <a:r>
+              <a:rPr lang="en-US" sz="1800" dirty="0">
+                <a:solidFill>
+                  <a:srgbClr val="8AA89D"/>
+                </a:solidFill>
+                <a:latin typeface="Arial" pitchFamily="34" charset="0"/>
+                <a:ea typeface="Arial" pitchFamily="34" charset="-122"/>
+                <a:cs typeface="Arial" pitchFamily="34" charset="-120"/>
+              </a:rPr>
+              <a:t>List an item. Share the link on WhatsApp. The buyer’s money stays protected until you deliver and they confirm.</a:t>
+            </a:r>
+            <a:endParaRPr lang="en-US" sz="1800" dirty="0"/>
+          </a:p>
+        </p:txBody>
+      </p:sp>
+      <p:sp>
+        <p:nvSpPr>
+          <p:cNvPr id="5" name="Text 3"/>
+          <p:cNvSpPr/>
+          <p:nvPr/>
+        </p:nvSpPr>
+        <p:spPr>
+          <a:xfrm>
+            <a:off x="640080" y="3200400"/>
+            <a:ext cx="10515600" cy="3657600"/>
+          </a:xfrm>
+          <a:prstGeom prst="rect">
+            <a:avLst/>
+          </a:prstGeom>
+          <a:noFill/>
+          <a:ln/>
+        </p:spPr>
+        <p:txBody>
+          <a:bodyPr wrap="square" rtlCol="0" anchor="ctr"/>
+          <a:lstStyle/>
+          <a:p>
+            <a:pPr marL="342900" indent="-342900">
+              <a:buSzPct val="100000"/>
+              <a:buChar char="•"/>
+            </a:pPr>
+            <a:r>
+              <a:rPr lang="en-US" sz="2000" dirty="0">
+                <a:solidFill>
+                  <a:srgbClr val="E8F3EE"/>
+                </a:solidFill>
+                <a:latin typeface="Arial" pitchFamily="34" charset="0"/>
+                <a:ea typeface="Arial" pitchFamily="34" charset="-122"/>
+                <a:cs typeface="Arial" pitchFamily="34" charset="-120"/>
+              </a:rPr>
+              <a:t>Create a listing &amp; share your link</a:t>
+            </a:r>
+            <a:endParaRPr lang="en-US" sz="2000" dirty="0"/>
+          </a:p>
+          <a:p>
+            <a:pPr marL="342900" indent="-342900">
+              <a:buSzPct val="100000"/>
+              <a:buChar char="•"/>
+            </a:pPr>
+            <a:r>
+              <a:rPr lang="en-US" sz="2000" dirty="0">
+                <a:solidFill>
+                  <a:srgbClr val="E8F3EE"/>
+                </a:solidFill>
+                <a:latin typeface="Arial" pitchFamily="34" charset="0"/>
+                <a:ea typeface="Arial" pitchFamily="34" charset="-122"/>
+                <a:cs typeface="Arial" pitchFamily="34" charset="-120"/>
+              </a:rPr>
+              <a:t>Buyer pays with Callback Protection</a:t>
+            </a:r>
+            <a:endParaRPr lang="en-US" sz="2000" dirty="0"/>
+          </a:p>
+          <a:p>
+            <a:pPr marL="342900" indent="-342900">
+              <a:buSzPct val="100000"/>
+              <a:buChar char="•"/>
+            </a:pPr>
+            <a:r>
+              <a:rPr lang="en-US" sz="2000" dirty="0">
+                <a:solidFill>
+                  <a:srgbClr val="E8F3EE"/>
+                </a:solidFill>
+                <a:latin typeface="Arial" pitchFamily="34" charset="0"/>
+                <a:ea typeface="Arial" pitchFamily="34" charset="-122"/>
+                <a:cs typeface="Arial" pitchFamily="34" charset="-120"/>
+              </a:rPr>
+              <a:t>You deliver · they confirm · money releases</a:t>
+            </a:r>
+            <a:endParaRPr lang="en-US" sz="2000" dirty="0"/>
+          </a:p>
+          <a:p>
+            <a:pPr marL="342900" indent="-342900">
+              <a:buSzPct val="100000"/>
+              <a:buChar char="•"/>
+            </a:pPr>
+            <a:r>
+              <a:rPr lang="en-US" sz="2000" dirty="0">
+                <a:solidFill>
+                  <a:srgbClr val="E8F3EE"/>
+                </a:solidFill>
+                <a:latin typeface="Arial" pitchFamily="34" charset="0"/>
+                <a:ea typeface="Arial" pitchFamily="34" charset="-122"/>
+                <a:cs typeface="Arial" pitchFamily="34" charset="-120"/>
+              </a:rPr>
+              <a:t>Same undo button for money — now for real sales. No public mall browse.</a:t>
+            </a:r>
+            <a:endParaRPr lang="en-US" sz="2000" dirty="0"/>
+          </a:p>
+        </p:txBody>
+      </p:sp>
     </p:spTree>
   </p:cSld>
   <p:clrMapOvr>
@@ -2586,7 +2777,7 @@
                 <a:ea typeface="Arial" pitchFamily="34" charset="-122"/>
                 <a:cs typeface="Arial" pitchFamily="34" charset="-120"/>
               </a:rPr>
-              <a:t>ALATPAY INTEGRATION</a:t>
+              <a:t>PRODUCT · LIVE</a:t>
             </a:r>
             <a:endParaRPr lang="en-US" sz="1100" dirty="0"/>
           </a:p>
@@ -2600,24 +2791,24 @@
         </p:nvSpPr>
         <p:spPr>
           <a:xfrm>
-            <a:off x="640080" y="777240"/>
-            <a:ext cx="10515600" cy="640080"/>
-          </a:xfrm>
-          <a:prstGeom prst="rect">
-            <a:avLst/>
-          </a:prstGeom>
-          <a:noFill/>
-          <a:ln/>
-        </p:spPr>
-        <p:txBody>
-          <a:bodyPr wrap="square" rtlCol="0" anchor="ctr"/>
-          <a:lstStyle/>
-          <a:p>
-            <a:pPr indent="0" marL="0">
-              <a:buNone/>
-            </a:pPr>
-            <a:r>
-              <a:rPr lang="en-US" sz="3000" b="1" dirty="0">
+            <a:off x="640080" y="640080"/>
+            <a:ext cx="10515600" cy="502920"/>
+          </a:xfrm>
+          <a:prstGeom prst="rect">
+            <a:avLst/>
+          </a:prstGeom>
+          <a:noFill/>
+          <a:ln/>
+        </p:spPr>
+        <p:txBody>
+          <a:bodyPr wrap="square" rtlCol="0" anchor="ctr"/>
+          <a:lstStyle/>
+          <a:p>
+            <a:pPr indent="0" marL="0">
+              <a:buNone/>
+            </a:pPr>
+            <a:r>
+              <a:rPr lang="en-US" sz="2400" b="1" dirty="0">
                 <a:solidFill>
                   <a:srgbClr val="E8F3EE"/>
                 </a:solidFill>
@@ -2625,239 +2816,60 @@
                 <a:ea typeface="Arial" pitchFamily="34" charset="-122"/>
                 <a:cs typeface="Arial" pitchFamily="34" charset="-120"/>
               </a:rPr>
-              <a:t>Real rails. Not a mock bank.</a:t>
-            </a:r>
-            <a:endParaRPr lang="en-US" sz="3000" dirty="0"/>
-          </a:p>
-        </p:txBody>
-      </p:sp>
-      <p:sp>
-        <p:nvSpPr>
-          <p:cNvPr id="4" name="Shape 2"/>
-          <p:cNvSpPr/>
-          <p:nvPr/>
-        </p:nvSpPr>
-        <p:spPr>
-          <a:xfrm>
-            <a:off x="640080" y="1737360"/>
-            <a:ext cx="5212080" cy="2377440"/>
-          </a:xfrm>
-          <a:prstGeom prst="roundRect">
-            <a:avLst>
-              <a:gd name="adj" fmla="val 7692"/>
-            </a:avLst>
-          </a:prstGeom>
-          <a:solidFill>
-            <a:srgbClr val="0F211C"/>
-          </a:solidFill>
-          <a:ln/>
-        </p:spPr>
-      </p:sp>
-      <p:sp>
-        <p:nvSpPr>
-          <p:cNvPr id="5" name="Text 3"/>
-          <p:cNvSpPr/>
-          <p:nvPr/>
-        </p:nvSpPr>
-        <p:spPr>
-          <a:xfrm>
-            <a:off x="914400" y="1965960"/>
-            <a:ext cx="4663440" cy="365760"/>
-          </a:xfrm>
-          <a:prstGeom prst="rect">
-            <a:avLst/>
-          </a:prstGeom>
-          <a:noFill/>
-          <a:ln/>
-        </p:spPr>
-        <p:txBody>
-          <a:bodyPr wrap="square" rtlCol="0" anchor="ctr"/>
-          <a:lstStyle/>
-          <a:p>
-            <a:pPr indent="0" marL="0">
-              <a:buNone/>
-            </a:pPr>
-            <a:r>
-              <a:rPr lang="en-US" sz="1600" b="1" dirty="0">
-                <a:solidFill>
-                  <a:srgbClr val="E8F3EE"/>
-                </a:solidFill>
-              </a:rPr>
-              <a:t>What we use</a:t>
-            </a:r>
-            <a:endParaRPr lang="en-US" sz="1600" dirty="0"/>
-          </a:p>
-        </p:txBody>
-      </p:sp>
-      <p:sp>
-        <p:nvSpPr>
-          <p:cNvPr id="6" name="Text 4"/>
-          <p:cNvSpPr/>
-          <p:nvPr/>
-        </p:nvSpPr>
-        <p:spPr>
-          <a:xfrm>
-            <a:off x="914400" y="2468880"/>
-            <a:ext cx="4663440" cy="1280160"/>
-          </a:xfrm>
-          <a:prstGeom prst="rect">
-            <a:avLst/>
-          </a:prstGeom>
-          <a:noFill/>
-          <a:ln/>
-        </p:spPr>
-        <p:txBody>
-          <a:bodyPr wrap="square" rtlCol="0" anchor="ctr"/>
-          <a:lstStyle/>
-          <a:p>
-            <a:pPr indent="0" marL="0">
-              <a:buNone/>
-            </a:pPr>
-            <a:r>
-              <a:rPr lang="en-US" sz="1500" dirty="0">
-                <a:solidFill>
-                  <a:srgbClr val="8AA89D"/>
-                </a:solidFill>
-              </a:rPr>
-              <a:t>Collections &amp; payment links · Static virtual accounts · BVN OTP · Signed webhooks · Transaction verification</a:t>
-            </a:r>
-            <a:endParaRPr lang="en-US" sz="1500" dirty="0"/>
-          </a:p>
-        </p:txBody>
-      </p:sp>
-      <p:sp>
-        <p:nvSpPr>
-          <p:cNvPr id="7" name="Shape 5"/>
-          <p:cNvSpPr/>
-          <p:nvPr/>
-        </p:nvSpPr>
-        <p:spPr>
-          <a:xfrm>
-            <a:off x="6126480" y="1737360"/>
-            <a:ext cx="5212080" cy="2377440"/>
-          </a:xfrm>
-          <a:prstGeom prst="roundRect">
-            <a:avLst>
-              <a:gd name="adj" fmla="val 7692"/>
-            </a:avLst>
-          </a:prstGeom>
-          <a:solidFill>
-            <a:srgbClr val="0F211C"/>
-          </a:solidFill>
-          <a:ln/>
-        </p:spPr>
-      </p:sp>
-      <p:sp>
-        <p:nvSpPr>
-          <p:cNvPr id="8" name="Text 6"/>
-          <p:cNvSpPr/>
-          <p:nvPr/>
-        </p:nvSpPr>
-        <p:spPr>
-          <a:xfrm>
-            <a:off x="6400800" y="1965960"/>
-            <a:ext cx="4663440" cy="365760"/>
-          </a:xfrm>
-          <a:prstGeom prst="rect">
-            <a:avLst/>
-          </a:prstGeom>
-          <a:noFill/>
-          <a:ln/>
-        </p:spPr>
-        <p:txBody>
-          <a:bodyPr wrap="square" rtlCol="0" anchor="ctr"/>
-          <a:lstStyle/>
-          <a:p>
-            <a:pPr indent="0" marL="0">
-              <a:buNone/>
-            </a:pPr>
-            <a:r>
-              <a:rPr lang="en-US" sz="1600" b="1" dirty="0">
-                <a:solidFill>
-                  <a:srgbClr val="E8F3EE"/>
-                </a:solidFill>
-              </a:rPr>
-              <a:t>Where money enters</a:t>
-            </a:r>
-            <a:endParaRPr lang="en-US" sz="1600" dirty="0"/>
-          </a:p>
-        </p:txBody>
-      </p:sp>
-      <p:sp>
-        <p:nvSpPr>
-          <p:cNvPr id="9" name="Text 7"/>
-          <p:cNvSpPr/>
-          <p:nvPr/>
-        </p:nvSpPr>
-        <p:spPr>
-          <a:xfrm>
-            <a:off x="6400800" y="2468880"/>
-            <a:ext cx="4663440" cy="1280160"/>
-          </a:xfrm>
-          <a:prstGeom prst="rect">
-            <a:avLst/>
-          </a:prstGeom>
-          <a:noFill/>
-          <a:ln/>
-        </p:spPr>
-        <p:txBody>
-          <a:bodyPr wrap="square" rtlCol="0" anchor="ctr"/>
-          <a:lstStyle/>
-          <a:p>
-            <a:pPr indent="0" marL="0">
-              <a:buNone/>
-            </a:pPr>
-            <a:r>
-              <a:rPr lang="en-US" sz="1500" dirty="0">
-                <a:solidFill>
-                  <a:srgbClr val="8AA89D"/>
-                </a:solidFill>
-              </a:rPr>
-              <a:t>Users fund Reton wallets on ALATPay. We credit our ledger only after verified settlement.</a:t>
-            </a:r>
-            <a:endParaRPr lang="en-US" sz="1500" dirty="0"/>
-          </a:p>
-        </p:txBody>
-      </p:sp>
-      <p:sp>
-        <p:nvSpPr>
-          <p:cNvPr id="10" name="Text 8"/>
-          <p:cNvSpPr/>
-          <p:nvPr/>
-        </p:nvSpPr>
-        <p:spPr>
-          <a:xfrm>
-            <a:off x="640080" y="4572000"/>
-            <a:ext cx="10058400" cy="1097280"/>
-          </a:xfrm>
-          <a:prstGeom prst="rect">
-            <a:avLst/>
-          </a:prstGeom>
-          <a:noFill/>
-          <a:ln/>
-        </p:spPr>
-        <p:txBody>
-          <a:bodyPr wrap="square" rtlCol="0" anchor="ctr"/>
-          <a:lstStyle/>
-          <a:p>
-            <a:pPr indent="0" marL="0">
-              <a:buNone/>
-            </a:pPr>
-            <a:r>
-              <a:rPr lang="en-US" sz="1800" dirty="0">
-                <a:solidFill>
-                  <a:srgbClr val="8AA89D"/>
-                </a:solidFill>
-                <a:latin typeface="Arial" pitchFamily="34" charset="0"/>
-                <a:ea typeface="Arial" pitchFamily="34" charset="-122"/>
-                <a:cs typeface="Arial" pitchFamily="34" charset="-120"/>
-              </a:rPr>
-              <a:t>ALAT by Wema gives us a licensed Nigerian bank rail — so Callback Protection sits on infrastructure people can trust.</a:t>
-            </a:r>
-            <a:endParaRPr lang="en-US" sz="1800" dirty="0"/>
-          </a:p>
-        </p:txBody>
-      </p:sp>
+              <a:t>Security posture. Business on the way.</a:t>
+            </a:r>
+            <a:endParaRPr lang="en-US" sz="2400" dirty="0"/>
+          </a:p>
+        </p:txBody>
+      </p:sp>
+      <p:pic>
+        <p:nvPicPr>
+          <p:cNvPr id="4" name="Image 0" descr="C:\Users\roten\Documents\reton\presentations\screenshots\03-security.png">    </p:cNvPr>
+          <p:cNvPicPr>
+            <a:picLocks noChangeAspect="1"/>
+          </p:cNvPicPr>
+          <p:nvPr/>
+        </p:nvPicPr>
+        <p:blipFill>
+          <a:blip r:embed="rId1"/>
+          <a:stretch>
+            <a:fillRect/>
+          </a:stretch>
+        </p:blipFill>
+        <p:spPr>
+          <a:xfrm>
+            <a:off x="502920" y="1280160"/>
+            <a:ext cx="5486400" cy="4846320"/>
+          </a:xfrm>
+          <a:prstGeom prst="rect">
+            <a:avLst/>
+          </a:prstGeom>
+        </p:spPr>
+      </p:pic>
+      <p:pic>
+        <p:nvPicPr>
+          <p:cNvPr id="5" name="Image 1" descr="C:\Users\roten\Documents\reton\presentations\screenshots\04-business.png">    </p:cNvPr>
+          <p:cNvPicPr>
+            <a:picLocks noChangeAspect="1"/>
+          </p:cNvPicPr>
+          <p:nvPr/>
+        </p:nvPicPr>
+        <p:blipFill>
+          <a:blip r:embed="rId2"/>
+          <a:stretch>
+            <a:fillRect/>
+          </a:stretch>
+        </p:blipFill>
+        <p:spPr>
+          <a:xfrm>
+            <a:off x="6172200" y="1280160"/>
+            <a:ext cx="5486400" cy="4846320"/>
+          </a:xfrm>
+          <a:prstGeom prst="rect">
+            <a:avLst/>
+          </a:prstGeom>
+        </p:spPr>
+      </p:pic>
     </p:spTree>
   </p:cSld>
   <p:clrMapOvr>
@@ -2923,7 +2935,7 @@
                 <a:ea typeface="Arial" pitchFamily="34" charset="-122"/>
                 <a:cs typeface="Arial" pitchFamily="34" charset="-120"/>
               </a:rPr>
-              <a:t>PRODUCT · LIVE</a:t>
+              <a:t>ALATPAY INTEGRATION</a:t>
             </a:r>
             <a:endParaRPr lang="en-US" sz="1100" dirty="0"/>
           </a:p>
@@ -2937,24 +2949,24 @@
         </p:nvSpPr>
         <p:spPr>
           <a:xfrm>
-            <a:off x="640080" y="640080"/>
-            <a:ext cx="10515600" cy="502920"/>
-          </a:xfrm>
-          <a:prstGeom prst="rect">
-            <a:avLst/>
-          </a:prstGeom>
-          <a:noFill/>
-          <a:ln/>
-        </p:spPr>
-        <p:txBody>
-          <a:bodyPr wrap="square" rtlCol="0" anchor="ctr"/>
-          <a:lstStyle/>
-          <a:p>
-            <a:pPr indent="0" marL="0">
-              <a:buNone/>
-            </a:pPr>
-            <a:r>
-              <a:rPr lang="en-US" sz="2400" b="1" dirty="0">
+            <a:off x="640080" y="777240"/>
+            <a:ext cx="10515600" cy="640080"/>
+          </a:xfrm>
+          <a:prstGeom prst="rect">
+            <a:avLst/>
+          </a:prstGeom>
+          <a:noFill/>
+          <a:ln/>
+        </p:spPr>
+        <p:txBody>
+          <a:bodyPr wrap="square" rtlCol="0" anchor="ctr"/>
+          <a:lstStyle/>
+          <a:p>
+            <a:pPr indent="0" marL="0">
+              <a:buNone/>
+            </a:pPr>
+            <a:r>
+              <a:rPr lang="en-US" sz="3000" b="1" dirty="0">
                 <a:solidFill>
                   <a:srgbClr val="E8F3EE"/>
                 </a:solidFill>
@@ -2962,60 +2974,239 @@
                 <a:ea typeface="Arial" pitchFamily="34" charset="-122"/>
                 <a:cs typeface="Arial" pitchFamily="34" charset="-120"/>
               </a:rPr>
-              <a:t>Reachable. Self-explanatory.</a:t>
-            </a:r>
-            <a:endParaRPr lang="en-US" sz="2400" dirty="0"/>
-          </a:p>
-        </p:txBody>
-      </p:sp>
-      <p:pic>
-        <p:nvPicPr>
-          <p:cNvPr id="4" name="Image 0" descr="C:\Users\roten\Documents\reton\presentations\screenshots\05-contact.png">    </p:cNvPr>
-          <p:cNvPicPr>
-            <a:picLocks noChangeAspect="1"/>
-          </p:cNvPicPr>
-          <p:nvPr/>
-        </p:nvPicPr>
-        <p:blipFill>
-          <a:blip r:embed="rId1"/>
-          <a:stretch>
-            <a:fillRect/>
-          </a:stretch>
-        </p:blipFill>
-        <p:spPr>
-          <a:xfrm>
-            <a:off x="502920" y="1280160"/>
-            <a:ext cx="5486400" cy="4846320"/>
-          </a:xfrm>
-          <a:prstGeom prst="rect">
-            <a:avLst/>
-          </a:prstGeom>
-        </p:spPr>
-      </p:pic>
-      <p:pic>
-        <p:nvPicPr>
-          <p:cNvPr id="5" name="Image 1" descr="C:\Users\roten\Documents\reton\presentations\screenshots\06-faq.png">    </p:cNvPr>
-          <p:cNvPicPr>
-            <a:picLocks noChangeAspect="1"/>
-          </p:cNvPicPr>
-          <p:nvPr/>
-        </p:nvPicPr>
-        <p:blipFill>
-          <a:blip r:embed="rId2"/>
-          <a:stretch>
-            <a:fillRect/>
-          </a:stretch>
-        </p:blipFill>
-        <p:spPr>
-          <a:xfrm>
-            <a:off x="6172200" y="1280160"/>
-            <a:ext cx="5486400" cy="4846320"/>
-          </a:xfrm>
-          <a:prstGeom prst="rect">
-            <a:avLst/>
-          </a:prstGeom>
-        </p:spPr>
-      </p:pic>
+              <a:t>Real rails. Not a mock bank.</a:t>
+            </a:r>
+            <a:endParaRPr lang="en-US" sz="3000" dirty="0"/>
+          </a:p>
+        </p:txBody>
+      </p:sp>
+      <p:sp>
+        <p:nvSpPr>
+          <p:cNvPr id="4" name="Shape 2"/>
+          <p:cNvSpPr/>
+          <p:nvPr/>
+        </p:nvSpPr>
+        <p:spPr>
+          <a:xfrm>
+            <a:off x="640080" y="1737360"/>
+            <a:ext cx="5212080" cy="2377440"/>
+          </a:xfrm>
+          <a:prstGeom prst="roundRect">
+            <a:avLst>
+              <a:gd name="adj" fmla="val 7692"/>
+            </a:avLst>
+          </a:prstGeom>
+          <a:solidFill>
+            <a:srgbClr val="0F211C"/>
+          </a:solidFill>
+          <a:ln/>
+        </p:spPr>
+      </p:sp>
+      <p:sp>
+        <p:nvSpPr>
+          <p:cNvPr id="5" name="Text 3"/>
+          <p:cNvSpPr/>
+          <p:nvPr/>
+        </p:nvSpPr>
+        <p:spPr>
+          <a:xfrm>
+            <a:off x="914400" y="1965960"/>
+            <a:ext cx="4663440" cy="365760"/>
+          </a:xfrm>
+          <a:prstGeom prst="rect">
+            <a:avLst/>
+          </a:prstGeom>
+          <a:noFill/>
+          <a:ln/>
+        </p:spPr>
+        <p:txBody>
+          <a:bodyPr wrap="square" rtlCol="0" anchor="ctr"/>
+          <a:lstStyle/>
+          <a:p>
+            <a:pPr indent="0" marL="0">
+              <a:buNone/>
+            </a:pPr>
+            <a:r>
+              <a:rPr lang="en-US" sz="1600" b="1" dirty="0">
+                <a:solidFill>
+                  <a:srgbClr val="E8F3EE"/>
+                </a:solidFill>
+              </a:rPr>
+              <a:t>What we use</a:t>
+            </a:r>
+            <a:endParaRPr lang="en-US" sz="1600" dirty="0"/>
+          </a:p>
+        </p:txBody>
+      </p:sp>
+      <p:sp>
+        <p:nvSpPr>
+          <p:cNvPr id="6" name="Text 4"/>
+          <p:cNvSpPr/>
+          <p:nvPr/>
+        </p:nvSpPr>
+        <p:spPr>
+          <a:xfrm>
+            <a:off x="914400" y="2468880"/>
+            <a:ext cx="4663440" cy="1280160"/>
+          </a:xfrm>
+          <a:prstGeom prst="rect">
+            <a:avLst/>
+          </a:prstGeom>
+          <a:noFill/>
+          <a:ln/>
+        </p:spPr>
+        <p:txBody>
+          <a:bodyPr wrap="square" rtlCol="0" anchor="ctr"/>
+          <a:lstStyle/>
+          <a:p>
+            <a:pPr indent="0" marL="0">
+              <a:buNone/>
+            </a:pPr>
+            <a:r>
+              <a:rPr lang="en-US" sz="1500" dirty="0">
+                <a:solidFill>
+                  <a:srgbClr val="8AA89D"/>
+                </a:solidFill>
+              </a:rPr>
+              <a:t>Collections &amp; payment links · Static virtual accounts · BVN OTP · Signed webhooks · Transaction verification</a:t>
+            </a:r>
+            <a:endParaRPr lang="en-US" sz="1500" dirty="0"/>
+          </a:p>
+        </p:txBody>
+      </p:sp>
+      <p:sp>
+        <p:nvSpPr>
+          <p:cNvPr id="7" name="Shape 5"/>
+          <p:cNvSpPr/>
+          <p:nvPr/>
+        </p:nvSpPr>
+        <p:spPr>
+          <a:xfrm>
+            <a:off x="6126480" y="1737360"/>
+            <a:ext cx="5212080" cy="2377440"/>
+          </a:xfrm>
+          <a:prstGeom prst="roundRect">
+            <a:avLst>
+              <a:gd name="adj" fmla="val 7692"/>
+            </a:avLst>
+          </a:prstGeom>
+          <a:solidFill>
+            <a:srgbClr val="0F211C"/>
+          </a:solidFill>
+          <a:ln/>
+        </p:spPr>
+      </p:sp>
+      <p:sp>
+        <p:nvSpPr>
+          <p:cNvPr id="8" name="Text 6"/>
+          <p:cNvSpPr/>
+          <p:nvPr/>
+        </p:nvSpPr>
+        <p:spPr>
+          <a:xfrm>
+            <a:off x="6400800" y="1965960"/>
+            <a:ext cx="4663440" cy="365760"/>
+          </a:xfrm>
+          <a:prstGeom prst="rect">
+            <a:avLst/>
+          </a:prstGeom>
+          <a:noFill/>
+          <a:ln/>
+        </p:spPr>
+        <p:txBody>
+          <a:bodyPr wrap="square" rtlCol="0" anchor="ctr"/>
+          <a:lstStyle/>
+          <a:p>
+            <a:pPr indent="0" marL="0">
+              <a:buNone/>
+            </a:pPr>
+            <a:r>
+              <a:rPr lang="en-US" sz="1600" b="1" dirty="0">
+                <a:solidFill>
+                  <a:srgbClr val="E8F3EE"/>
+                </a:solidFill>
+              </a:rPr>
+              <a:t>Where money enters</a:t>
+            </a:r>
+            <a:endParaRPr lang="en-US" sz="1600" dirty="0"/>
+          </a:p>
+        </p:txBody>
+      </p:sp>
+      <p:sp>
+        <p:nvSpPr>
+          <p:cNvPr id="9" name="Text 7"/>
+          <p:cNvSpPr/>
+          <p:nvPr/>
+        </p:nvSpPr>
+        <p:spPr>
+          <a:xfrm>
+            <a:off x="6400800" y="2468880"/>
+            <a:ext cx="4663440" cy="1280160"/>
+          </a:xfrm>
+          <a:prstGeom prst="rect">
+            <a:avLst/>
+          </a:prstGeom>
+          <a:noFill/>
+          <a:ln/>
+        </p:spPr>
+        <p:txBody>
+          <a:bodyPr wrap="square" rtlCol="0" anchor="ctr"/>
+          <a:lstStyle/>
+          <a:p>
+            <a:pPr indent="0" marL="0">
+              <a:buNone/>
+            </a:pPr>
+            <a:r>
+              <a:rPr lang="en-US" sz="1500" dirty="0">
+                <a:solidFill>
+                  <a:srgbClr val="8AA89D"/>
+                </a:solidFill>
+              </a:rPr>
+              <a:t>Users fund Reton wallets on ALATPay. We credit our ledger only after verified settlement.</a:t>
+            </a:r>
+            <a:endParaRPr lang="en-US" sz="1500" dirty="0"/>
+          </a:p>
+        </p:txBody>
+      </p:sp>
+      <p:sp>
+        <p:nvSpPr>
+          <p:cNvPr id="10" name="Text 8"/>
+          <p:cNvSpPr/>
+          <p:nvPr/>
+        </p:nvSpPr>
+        <p:spPr>
+          <a:xfrm>
+            <a:off x="640080" y="4572000"/>
+            <a:ext cx="10058400" cy="1097280"/>
+          </a:xfrm>
+          <a:prstGeom prst="rect">
+            <a:avLst/>
+          </a:prstGeom>
+          <a:noFill/>
+          <a:ln/>
+        </p:spPr>
+        <p:txBody>
+          <a:bodyPr wrap="square" rtlCol="0" anchor="ctr"/>
+          <a:lstStyle/>
+          <a:p>
+            <a:pPr indent="0" marL="0">
+              <a:buNone/>
+            </a:pPr>
+            <a:r>
+              <a:rPr lang="en-US" sz="1800" dirty="0">
+                <a:solidFill>
+                  <a:srgbClr val="8AA89D"/>
+                </a:solidFill>
+                <a:latin typeface="Arial" pitchFamily="34" charset="0"/>
+                <a:ea typeface="Arial" pitchFamily="34" charset="-122"/>
+                <a:cs typeface="Arial" pitchFamily="34" charset="-120"/>
+              </a:rPr>
+              <a:t>ALAT by Wema gives us a licensed Nigerian bank rail — so Callback Protection sits on infrastructure people can trust.</a:t>
+            </a:r>
+            <a:endParaRPr lang="en-US" sz="1800" dirty="0"/>
+          </a:p>
+        </p:txBody>
+      </p:sp>
     </p:spTree>
   </p:cSld>
   <p:clrMapOvr>
@@ -3081,7 +3272,7 @@
                 <a:ea typeface="Arial" pitchFamily="34" charset="-122"/>
                 <a:cs typeface="Arial" pitchFamily="34" charset="-120"/>
               </a:rPr>
-              <a:t>WHY RETON</a:t>
+              <a:t>PRODUCT · LIVE</a:t>
             </a:r>
             <a:endParaRPr lang="en-US" sz="1100" dirty="0"/>
           </a:p>
@@ -3095,24 +3286,24 @@
         </p:nvSpPr>
         <p:spPr>
           <a:xfrm>
-            <a:off x="640080" y="777240"/>
-            <a:ext cx="10515600" cy="1280160"/>
-          </a:xfrm>
-          <a:prstGeom prst="rect">
-            <a:avLst/>
-          </a:prstGeom>
-          <a:noFill/>
-          <a:ln/>
-        </p:spPr>
-        <p:txBody>
-          <a:bodyPr wrap="square" rtlCol="0" anchor="ctr"/>
-          <a:lstStyle/>
-          <a:p>
-            <a:pPr indent="0" marL="0">
-              <a:buNone/>
-            </a:pPr>
-            <a:r>
-              <a:rPr lang="en-US" sz="3600" b="1" dirty="0">
+            <a:off x="640080" y="640080"/>
+            <a:ext cx="10515600" cy="502920"/>
+          </a:xfrm>
+          <a:prstGeom prst="rect">
+            <a:avLst/>
+          </a:prstGeom>
+          <a:noFill/>
+          <a:ln/>
+        </p:spPr>
+        <p:txBody>
+          <a:bodyPr wrap="square" rtlCol="0" anchor="ctr"/>
+          <a:lstStyle/>
+          <a:p>
+            <a:pPr indent="0" marL="0">
+              <a:buNone/>
+            </a:pPr>
+            <a:r>
+              <a:rPr lang="en-US" sz="2400" b="1" dirty="0">
                 <a:solidFill>
                   <a:srgbClr val="E8F3EE"/>
                 </a:solidFill>
@@ -3120,106 +3311,60 @@
                 <a:ea typeface="Arial" pitchFamily="34" charset="-122"/>
                 <a:cs typeface="Arial" pitchFamily="34" charset="-120"/>
               </a:rPr>
-              <a:t>We’re not another wallet.</a:t>
-            </a:r>
-            <a:endParaRPr lang="en-US" sz="3600" dirty="0"/>
-          </a:p>
-        </p:txBody>
-      </p:sp>
-      <p:sp>
-        <p:nvSpPr>
-          <p:cNvPr id="4" name="Text 2"/>
-          <p:cNvSpPr/>
-          <p:nvPr/>
-        </p:nvSpPr>
-        <p:spPr>
-          <a:xfrm>
-            <a:off x="640080" y="2194560"/>
-            <a:ext cx="10515600" cy="3657600"/>
-          </a:xfrm>
-          <a:prstGeom prst="rect">
-            <a:avLst/>
-          </a:prstGeom>
-          <a:noFill/>
-          <a:ln/>
-        </p:spPr>
-        <p:txBody>
-          <a:bodyPr wrap="square" rtlCol="0" anchor="ctr"/>
-          <a:lstStyle/>
-          <a:p>
-            <a:pPr marL="342900" indent="-342900">
-              <a:buSzPct val="100000"/>
-              <a:buChar char="•"/>
-            </a:pPr>
-            <a:r>
-              <a:rPr lang="en-US" sz="2000" dirty="0">
-                <a:solidFill>
-                  <a:srgbClr val="E8F3EE"/>
-                </a:solidFill>
-                <a:latin typeface="Arial" pitchFamily="34" charset="0"/>
-                <a:ea typeface="Arial" pitchFamily="34" charset="-122"/>
-                <a:cs typeface="Arial" pitchFamily="34" charset="-120"/>
-              </a:rPr>
-              <a:t>Trust layer — protection and recovery are the product.</a:t>
-            </a:r>
-            <a:endParaRPr lang="en-US" sz="2000" dirty="0"/>
-          </a:p>
-          <a:p>
-            <a:pPr marL="342900" indent="-342900">
-              <a:buSzPct val="100000"/>
-              <a:buChar char="•"/>
-            </a:pPr>
-            <a:r>
-              <a:rPr lang="en-US" sz="2000" dirty="0">
-                <a:solidFill>
-                  <a:srgbClr val="E8F3EE"/>
-                </a:solidFill>
-                <a:latin typeface="Arial" pitchFamily="34" charset="0"/>
-                <a:ea typeface="Arial" pitchFamily="34" charset="-122"/>
-                <a:cs typeface="Arial" pitchFamily="34" charset="-120"/>
-              </a:rPr>
-              <a:t>Visible timeline — every money event is explainable.</a:t>
-            </a:r>
-            <a:endParaRPr lang="en-US" sz="2000" dirty="0"/>
-          </a:p>
-          <a:p>
-            <a:pPr marL="342900" indent="-342900">
-              <a:buSzPct val="100000"/>
-              <a:buChar char="•"/>
-            </a:pPr>
-            <a:r>
-              <a:rPr lang="en-US" sz="2000" dirty="0">
-                <a:solidFill>
-                  <a:srgbClr val="E8F3EE"/>
-                </a:solidFill>
-                <a:latin typeface="Arial" pitchFamily="34" charset="0"/>
-                <a:ea typeface="Arial" pitchFamily="34" charset="-122"/>
-                <a:cs typeface="Arial" pitchFamily="34" charset="-120"/>
-              </a:rPr>
-              <a:t>Licensed settlement — ALATPay / Wema.</a:t>
-            </a:r>
-            <a:endParaRPr lang="en-US" sz="2000" dirty="0"/>
-          </a:p>
-          <a:p>
-            <a:pPr marL="342900" indent="-342900">
-              <a:buSzPct val="100000"/>
-              <a:buChar char="•"/>
-            </a:pPr>
-            <a:r>
-              <a:rPr lang="en-US" sz="2000" dirty="0">
-                <a:solidFill>
-                  <a:srgbClr val="E8F3EE"/>
-                </a:solidFill>
-                <a:latin typeface="Arial" pitchFamily="34" charset="0"/>
-                <a:ea typeface="Arial" pitchFamily="34" charset="-122"/>
-                <a:cs typeface="Arial" pitchFamily="34" charset="-120"/>
-              </a:rPr>
-              <a:t>Production mindset — signed webhooks, PINs, encrypted secrets, audited admin.</a:t>
-            </a:r>
-            <a:endParaRPr lang="en-US" sz="2000" dirty="0"/>
-          </a:p>
-        </p:txBody>
-      </p:sp>
+              <a:t>Reachable. Self-explanatory.</a:t>
+            </a:r>
+            <a:endParaRPr lang="en-US" sz="2400" dirty="0"/>
+          </a:p>
+        </p:txBody>
+      </p:sp>
+      <p:pic>
+        <p:nvPicPr>
+          <p:cNvPr id="4" name="Image 0" descr="C:\Users\roten\Documents\reton\presentations\screenshots\05-contact.png">    </p:cNvPr>
+          <p:cNvPicPr>
+            <a:picLocks noChangeAspect="1"/>
+          </p:cNvPicPr>
+          <p:nvPr/>
+        </p:nvPicPr>
+        <p:blipFill>
+          <a:blip r:embed="rId1"/>
+          <a:stretch>
+            <a:fillRect/>
+          </a:stretch>
+        </p:blipFill>
+        <p:spPr>
+          <a:xfrm>
+            <a:off x="502920" y="1280160"/>
+            <a:ext cx="5486400" cy="4846320"/>
+          </a:xfrm>
+          <a:prstGeom prst="rect">
+            <a:avLst/>
+          </a:prstGeom>
+        </p:spPr>
+      </p:pic>
+      <p:pic>
+        <p:nvPicPr>
+          <p:cNvPr id="5" name="Image 1" descr="C:\Users\roten\Documents\reton\presentations\screenshots\06-faq.png">    </p:cNvPr>
+          <p:cNvPicPr>
+            <a:picLocks noChangeAspect="1"/>
+          </p:cNvPicPr>
+          <p:nvPr/>
+        </p:nvPicPr>
+        <p:blipFill>
+          <a:blip r:embed="rId2"/>
+          <a:stretch>
+            <a:fillRect/>
+          </a:stretch>
+        </p:blipFill>
+        <p:spPr>
+          <a:xfrm>
+            <a:off x="6172200" y="1280160"/>
+            <a:ext cx="5486400" cy="4846320"/>
+          </a:xfrm>
+          <a:prstGeom prst="rect">
+            <a:avLst/>
+          </a:prstGeom>
+        </p:spPr>
+      </p:pic>
     </p:spTree>
   </p:cSld>
   <p:clrMapOvr>
@@ -3285,7 +3430,7 @@
                 <a:ea typeface="Arial" pitchFamily="34" charset="-122"/>
                 <a:cs typeface="Arial" pitchFamily="34" charset="-120"/>
               </a:rPr>
-              <a:t>DEMO IN 90 SECONDS</a:t>
+              <a:t>WHY RETON</a:t>
             </a:r>
             <a:endParaRPr lang="en-US" sz="1100" dirty="0"/>
           </a:p>
@@ -3300,23 +3445,23 @@
         <p:spPr>
           <a:xfrm>
             <a:off x="640080" y="777240"/>
-            <a:ext cx="10515600" cy="640080"/>
-          </a:xfrm>
-          <a:prstGeom prst="rect">
-            <a:avLst/>
-          </a:prstGeom>
-          <a:noFill/>
-          <a:ln/>
-        </p:spPr>
-        <p:txBody>
-          <a:bodyPr wrap="square" rtlCol="0" anchor="ctr"/>
-          <a:lstStyle/>
-          <a:p>
-            <a:pPr indent="0" marL="0">
-              <a:buNone/>
-            </a:pPr>
-            <a:r>
-              <a:rPr lang="en-US" sz="3200" b="1" dirty="0">
+            <a:ext cx="10515600" cy="1280160"/>
+          </a:xfrm>
+          <a:prstGeom prst="rect">
+            <a:avLst/>
+          </a:prstGeom>
+          <a:noFill/>
+          <a:ln/>
+        </p:spPr>
+        <p:txBody>
+          <a:bodyPr wrap="square" rtlCol="0" anchor="ctr"/>
+          <a:lstStyle/>
+          <a:p>
+            <a:pPr indent="0" marL="0">
+              <a:buNone/>
+            </a:pPr>
+            <a:r>
+              <a:rPr lang="en-US" sz="3600" b="1" dirty="0">
                 <a:solidFill>
                   <a:srgbClr val="E8F3EE"/>
                 </a:solidFill>
@@ -3324,9 +3469,9 @@
                 <a:ea typeface="Arial" pitchFamily="34" charset="-122"/>
                 <a:cs typeface="Arial" pitchFamily="34" charset="-120"/>
               </a:rPr>
-              <a:t>Show, don’t tell.</a:t>
-            </a:r>
-            <a:endParaRPr lang="en-US" sz="3200" dirty="0"/>
+              <a:t>We’re not another wallet.</a:t>
+            </a:r>
+            <a:endParaRPr lang="en-US" sz="3600" dirty="0"/>
           </a:p>
         </p:txBody>
       </p:sp>
@@ -3338,7 +3483,7 @@
         </p:nvSpPr>
         <p:spPr>
           <a:xfrm>
-            <a:off x="640080" y="1737360"/>
+            <a:off x="640080" y="2194560"/>
             <a:ext cx="10515600" cy="3657600"/>
           </a:xfrm>
           <a:prstGeom prst="rect">
@@ -3364,7 +3509,7 @@
                 <a:ea typeface="Arial" pitchFamily="34" charset="-122"/>
                 <a:cs typeface="Arial" pitchFamily="34" charset="-120"/>
               </a:rPr>
-              <a:t>Open a wallet — balance &amp; KYC tier</a:t>
+              <a:t>Trust layer — protection and recovery are the product.</a:t>
             </a:r>
             <a:endParaRPr lang="en-US" sz="2000" dirty="0"/>
           </a:p>
@@ -3382,7 +3527,7 @@
                 <a:ea typeface="Arial" pitchFamily="34" charset="-122"/>
                 <a:cs typeface="Arial" pitchFamily="34" charset="-120"/>
               </a:rPr>
-              <a:t>Send a protected transfer</a:t>
+              <a:t>Visible timeline — every money event is explainable.</a:t>
             </a:r>
             <a:endParaRPr lang="en-US" sz="2000" dirty="0"/>
           </a:p>
@@ -3400,7 +3545,7 @@
                 <a:ea typeface="Arial" pitchFamily="34" charset="-122"/>
                 <a:cs typeface="Arial" pitchFamily="34" charset="-120"/>
               </a:rPr>
-              <a:t>Receiver sees Payment Protected</a:t>
+              <a:t>Licensed settlement — ALATPay / Wema.</a:t>
             </a:r>
             <a:endParaRPr lang="en-US" sz="2000" dirty="0"/>
           </a:p>
@@ -3418,66 +3563,9 @@
                 <a:ea typeface="Arial" pitchFamily="34" charset="-122"/>
                 <a:cs typeface="Arial" pitchFamily="34" charset="-120"/>
               </a:rPr>
-              <a:t>Request callback — timeline updates live</a:t>
+              <a:t>Production mindset — signed webhooks, PINs, encrypted secrets, audited admin.</a:t>
             </a:r>
             <a:endParaRPr lang="en-US" sz="2000" dirty="0"/>
-          </a:p>
-          <a:p>
-            <a:pPr marL="342900" indent="-342900">
-              <a:buSzPct val="100000"/>
-              <a:buChar char="•"/>
-            </a:pPr>
-            <a:r>
-              <a:rPr lang="en-US" sz="2000" dirty="0">
-                <a:solidFill>
-                  <a:srgbClr val="E8F3EE"/>
-                </a:solidFill>
-                <a:latin typeface="Arial" pitchFamily="34" charset="0"/>
-                <a:ea typeface="Arial" pitchFamily="34" charset="-122"/>
-                <a:cs typeface="Arial" pitchFamily="34" charset="-120"/>
-              </a:rPr>
-              <a:t>Optional: recovery case or admin fraud view</a:t>
-            </a:r>
-            <a:endParaRPr lang="en-US" sz="2000" dirty="0"/>
-          </a:p>
-        </p:txBody>
-      </p:sp>
-      <p:sp>
-        <p:nvSpPr>
-          <p:cNvPr id="5" name="Text 3"/>
-          <p:cNvSpPr/>
-          <p:nvPr/>
-        </p:nvSpPr>
-        <p:spPr>
-          <a:xfrm>
-            <a:off x="640080" y="5029200"/>
-            <a:ext cx="10058400" cy="1097280"/>
-          </a:xfrm>
-          <a:prstGeom prst="rect">
-            <a:avLst/>
-          </a:prstGeom>
-          <a:noFill/>
-          <a:ln/>
-        </p:spPr>
-        <p:txBody>
-          <a:bodyPr wrap="square" rtlCol="0" anchor="ctr"/>
-          <a:lstStyle/>
-          <a:p>
-            <a:pPr indent="0" marL="0">
-              <a:buNone/>
-            </a:pPr>
-            <a:r>
-              <a:rPr lang="en-US" sz="1800" dirty="0">
-                <a:solidFill>
-                  <a:srgbClr val="1EC98A"/>
-                </a:solidFill>
-                <a:latin typeface="Arial" pitchFamily="34" charset="0"/>
-                <a:ea typeface="Arial" pitchFamily="34" charset="-122"/>
-                <a:cs typeface="Arial" pitchFamily="34" charset="-120"/>
-              </a:rPr>
-              <a:t>The story: money moved — and I still had control.</a:t>
-            </a:r>
-            <a:endParaRPr lang="en-US" sz="1800" dirty="0"/>
           </a:p>
         </p:txBody>
       </p:sp>
@@ -3546,7 +3634,7 @@
                 <a:ea typeface="Arial" pitchFamily="34" charset="-122"/>
                 <a:cs typeface="Arial" pitchFamily="34" charset="-120"/>
               </a:rPr>
-              <a:t>TEAM</a:t>
+              <a:t>DEMO IN 90 SECONDS</a:t>
             </a:r>
             <a:endParaRPr lang="en-US" sz="1100" dirty="0"/>
           </a:p>
@@ -3560,7 +3648,7 @@
         </p:nvSpPr>
         <p:spPr>
           <a:xfrm>
-            <a:off x="640080" y="822960"/>
+            <a:off x="640080" y="777240"/>
             <a:ext cx="10515600" cy="640080"/>
           </a:xfrm>
           <a:prstGeom prst="rect">
@@ -3585,7 +3673,7 @@
                 <a:ea typeface="Arial" pitchFamily="34" charset="-122"/>
                 <a:cs typeface="Arial" pitchFamily="34" charset="-120"/>
               </a:rPr>
-              <a:t>RETON PTE LTD</a:t>
+              <a:t>Show, don’t tell.</a:t>
             </a:r>
             <a:endParaRPr lang="en-US" sz="3200" dirty="0"/>
           </a:p>
@@ -3593,25 +3681,115 @@
       </p:sp>
       <p:sp>
         <p:nvSpPr>
-          <p:cNvPr id="4" name="Shape 2"/>
-          <p:cNvSpPr/>
-          <p:nvPr/>
-        </p:nvSpPr>
-        <p:spPr>
-          <a:xfrm>
-            <a:off x="640080" y="1920240"/>
-            <a:ext cx="5029200" cy="1645920"/>
-          </a:xfrm>
-          <a:prstGeom prst="roundRect">
-            <a:avLst>
-              <a:gd name="adj" fmla="val 11111"/>
-            </a:avLst>
-          </a:prstGeom>
-          <a:solidFill>
-            <a:srgbClr val="0F211C"/>
-          </a:solidFill>
-          <a:ln/>
-        </p:spPr>
+          <p:cNvPr id="4" name="Text 2"/>
+          <p:cNvSpPr/>
+          <p:nvPr/>
+        </p:nvSpPr>
+        <p:spPr>
+          <a:xfrm>
+            <a:off x="640080" y="1737360"/>
+            <a:ext cx="10515600" cy="3657600"/>
+          </a:xfrm>
+          <a:prstGeom prst="rect">
+            <a:avLst/>
+          </a:prstGeom>
+          <a:noFill/>
+          <a:ln/>
+        </p:spPr>
+        <p:txBody>
+          <a:bodyPr wrap="square" rtlCol="0" anchor="ctr"/>
+          <a:lstStyle/>
+          <a:p>
+            <a:pPr marL="342900" indent="-342900">
+              <a:buSzPct val="100000"/>
+              <a:buChar char="•"/>
+            </a:pPr>
+            <a:r>
+              <a:rPr lang="en-US" sz="2000" dirty="0">
+                <a:solidFill>
+                  <a:srgbClr val="E8F3EE"/>
+                </a:solidFill>
+                <a:latin typeface="Arial" pitchFamily="34" charset="0"/>
+                <a:ea typeface="Arial" pitchFamily="34" charset="-122"/>
+                <a:cs typeface="Arial" pitchFamily="34" charset="-120"/>
+              </a:rPr>
+              <a:t>Open a wallet — balance &amp; KYC tier</a:t>
+            </a:r>
+            <a:endParaRPr lang="en-US" sz="2000" dirty="0"/>
+          </a:p>
+          <a:p>
+            <a:pPr marL="342900" indent="-342900">
+              <a:buSzPct val="100000"/>
+              <a:buChar char="•"/>
+            </a:pPr>
+            <a:r>
+              <a:rPr lang="en-US" sz="2000" dirty="0">
+                <a:solidFill>
+                  <a:srgbClr val="E8F3EE"/>
+                </a:solidFill>
+                <a:latin typeface="Arial" pitchFamily="34" charset="0"/>
+                <a:ea typeface="Arial" pitchFamily="34" charset="-122"/>
+                <a:cs typeface="Arial" pitchFamily="34" charset="-120"/>
+              </a:rPr>
+              <a:t>Send a protected transfer</a:t>
+            </a:r>
+            <a:endParaRPr lang="en-US" sz="2000" dirty="0"/>
+          </a:p>
+          <a:p>
+            <a:pPr marL="342900" indent="-342900">
+              <a:buSzPct val="100000"/>
+              <a:buChar char="•"/>
+            </a:pPr>
+            <a:r>
+              <a:rPr lang="en-US" sz="2000" dirty="0">
+                <a:solidFill>
+                  <a:srgbClr val="E8F3EE"/>
+                </a:solidFill>
+                <a:latin typeface="Arial" pitchFamily="34" charset="0"/>
+                <a:ea typeface="Arial" pitchFamily="34" charset="-122"/>
+                <a:cs typeface="Arial" pitchFamily="34" charset="-120"/>
+              </a:rPr>
+              <a:t>Receiver sees Payment Protected</a:t>
+            </a:r>
+            <a:endParaRPr lang="en-US" sz="2000" dirty="0"/>
+          </a:p>
+          <a:p>
+            <a:pPr marL="342900" indent="-342900">
+              <a:buSzPct val="100000"/>
+              <a:buChar char="•"/>
+            </a:pPr>
+            <a:r>
+              <a:rPr lang="en-US" sz="2000" dirty="0">
+                <a:solidFill>
+                  <a:srgbClr val="E8F3EE"/>
+                </a:solidFill>
+                <a:latin typeface="Arial" pitchFamily="34" charset="0"/>
+                <a:ea typeface="Arial" pitchFamily="34" charset="-122"/>
+                <a:cs typeface="Arial" pitchFamily="34" charset="-120"/>
+              </a:rPr>
+              <a:t>Request callback — timeline updates live</a:t>
+            </a:r>
+            <a:endParaRPr lang="en-US" sz="2000" dirty="0"/>
+          </a:p>
+          <a:p>
+            <a:pPr marL="342900" indent="-342900">
+              <a:buSzPct val="100000"/>
+              <a:buChar char="•"/>
+            </a:pPr>
+            <a:r>
+              <a:rPr lang="en-US" sz="2000" dirty="0">
+                <a:solidFill>
+                  <a:srgbClr val="E8F3EE"/>
+                </a:solidFill>
+                <a:latin typeface="Arial" pitchFamily="34" charset="0"/>
+                <a:ea typeface="Arial" pitchFamily="34" charset="-122"/>
+                <a:cs typeface="Arial" pitchFamily="34" charset="-120"/>
+              </a:rPr>
+              <a:t>Optional: recovery case or admin fraud view</a:t>
+            </a:r>
+            <a:endParaRPr lang="en-US" sz="2000" dirty="0"/>
+          </a:p>
+        </p:txBody>
       </p:sp>
       <p:sp>
         <p:nvSpPr>
@@ -3621,173 +3799,7 @@
         </p:nvSpPr>
         <p:spPr>
           <a:xfrm>
-            <a:off x="914400" y="2240280"/>
-            <a:ext cx="4572000" cy="411480"/>
-          </a:xfrm>
-          <a:prstGeom prst="rect">
-            <a:avLst/>
-          </a:prstGeom>
-          <a:noFill/>
-          <a:ln/>
-        </p:spPr>
-        <p:txBody>
-          <a:bodyPr wrap="square" rtlCol="0" anchor="ctr"/>
-          <a:lstStyle/>
-          <a:p>
-            <a:pPr indent="0" marL="0">
-              <a:buNone/>
-            </a:pPr>
-            <a:r>
-              <a:rPr lang="en-US" sz="1800" b="1" dirty="0">
-                <a:solidFill>
-                  <a:srgbClr val="E8F3EE"/>
-                </a:solidFill>
-              </a:rPr>
-              <a:t>Gabriel Rotimi Mogaji</a:t>
-            </a:r>
-            <a:endParaRPr lang="en-US" sz="1800" dirty="0"/>
-          </a:p>
-        </p:txBody>
-      </p:sp>
-      <p:sp>
-        <p:nvSpPr>
-          <p:cNvPr id="6" name="Text 4"/>
-          <p:cNvSpPr/>
-          <p:nvPr/>
-        </p:nvSpPr>
-        <p:spPr>
-          <a:xfrm>
-            <a:off x="914400" y="2697480"/>
-            <a:ext cx="4572000" cy="365760"/>
-          </a:xfrm>
-          <a:prstGeom prst="rect">
-            <a:avLst/>
-          </a:prstGeom>
-          <a:noFill/>
-          <a:ln/>
-        </p:spPr>
-        <p:txBody>
-          <a:bodyPr wrap="square" rtlCol="0" anchor="ctr"/>
-          <a:lstStyle/>
-          <a:p>
-            <a:pPr indent="0" marL="0">
-              <a:buNone/>
-            </a:pPr>
-            <a:r>
-              <a:rPr lang="en-US" sz="1400" dirty="0">
-                <a:solidFill>
-                  <a:srgbClr val="8AA89D"/>
-                </a:solidFill>
-              </a:rPr>
-              <a:t>Founder &amp; CEO</a:t>
-            </a:r>
-            <a:endParaRPr lang="en-US" sz="1400" dirty="0"/>
-          </a:p>
-        </p:txBody>
-      </p:sp>
-      <p:sp>
-        <p:nvSpPr>
-          <p:cNvPr id="7" name="Shape 5"/>
-          <p:cNvSpPr/>
-          <p:nvPr/>
-        </p:nvSpPr>
-        <p:spPr>
-          <a:xfrm>
-            <a:off x="6035040" y="1920240"/>
-            <a:ext cx="5029200" cy="1645920"/>
-          </a:xfrm>
-          <a:prstGeom prst="roundRect">
-            <a:avLst>
-              <a:gd name="adj" fmla="val 11111"/>
-            </a:avLst>
-          </a:prstGeom>
-          <a:solidFill>
-            <a:srgbClr val="0F211C"/>
-          </a:solidFill>
-          <a:ln/>
-        </p:spPr>
-      </p:sp>
-      <p:sp>
-        <p:nvSpPr>
-          <p:cNvPr id="8" name="Text 6"/>
-          <p:cNvSpPr/>
-          <p:nvPr/>
-        </p:nvSpPr>
-        <p:spPr>
-          <a:xfrm>
-            <a:off x="6309360" y="2240280"/>
-            <a:ext cx="4572000" cy="411480"/>
-          </a:xfrm>
-          <a:prstGeom prst="rect">
-            <a:avLst/>
-          </a:prstGeom>
-          <a:noFill/>
-          <a:ln/>
-        </p:spPr>
-        <p:txBody>
-          <a:bodyPr wrap="square" rtlCol="0" anchor="ctr"/>
-          <a:lstStyle/>
-          <a:p>
-            <a:pPr indent="0" marL="0">
-              <a:buNone/>
-            </a:pPr>
-            <a:r>
-              <a:rPr lang="en-US" sz="1800" b="1" dirty="0">
-                <a:solidFill>
-                  <a:srgbClr val="E8F3EE"/>
-                </a:solidFill>
-              </a:rPr>
-              <a:t>Aina Christana Olajumoke</a:t>
-            </a:r>
-            <a:endParaRPr lang="en-US" sz="1800" dirty="0"/>
-          </a:p>
-        </p:txBody>
-      </p:sp>
-      <p:sp>
-        <p:nvSpPr>
-          <p:cNvPr id="9" name="Text 7"/>
-          <p:cNvSpPr/>
-          <p:nvPr/>
-        </p:nvSpPr>
-        <p:spPr>
-          <a:xfrm>
-            <a:off x="6309360" y="2697480"/>
-            <a:ext cx="4572000" cy="365760"/>
-          </a:xfrm>
-          <a:prstGeom prst="rect">
-            <a:avLst/>
-          </a:prstGeom>
-          <a:noFill/>
-          <a:ln/>
-        </p:spPr>
-        <p:txBody>
-          <a:bodyPr wrap="square" rtlCol="0" anchor="ctr"/>
-          <a:lstStyle/>
-          <a:p>
-            <a:pPr indent="0" marL="0">
-              <a:buNone/>
-            </a:pPr>
-            <a:r>
-              <a:rPr lang="en-US" sz="1400" dirty="0">
-                <a:solidFill>
-                  <a:srgbClr val="8AA89D"/>
-                </a:solidFill>
-              </a:rPr>
-              <a:t>Co-Founder</a:t>
-            </a:r>
-            <a:endParaRPr lang="en-US" sz="1400" dirty="0"/>
-          </a:p>
-        </p:txBody>
-      </p:sp>
-      <p:sp>
-        <p:nvSpPr>
-          <p:cNvPr id="10" name="Text 8"/>
-          <p:cNvSpPr/>
-          <p:nvPr/>
-        </p:nvSpPr>
-        <p:spPr>
-          <a:xfrm>
-            <a:off x="640080" y="4114800"/>
+            <a:off x="640080" y="5029200"/>
             <a:ext cx="10058400" cy="1097280"/>
           </a:xfrm>
           <a:prstGeom prst="rect">
@@ -3806,13 +3818,13 @@
             <a:r>
               <a:rPr lang="en-US" sz="1800" dirty="0">
                 <a:solidFill>
-                  <a:srgbClr val="8AA89D"/>
-                </a:solidFill>
-                <a:latin typeface="Arial" pitchFamily="34" charset="0"/>
-                <a:ea typeface="Arial" pitchFamily="34" charset="-122"/>
-                <a:cs typeface="Arial" pitchFamily="34" charset="-120"/>
-              </a:rPr>
-              <a:t>Building Africa’s trust-first payment platform — one protected transfer at a time.</a:t>
+                  <a:srgbClr val="1EC98A"/>
+                </a:solidFill>
+                <a:latin typeface="Arial" pitchFamily="34" charset="0"/>
+                <a:ea typeface="Arial" pitchFamily="34" charset="-122"/>
+                <a:cs typeface="Arial" pitchFamily="34" charset="-120"/>
+              </a:rPr>
+              <a:t>The story: money moved — and I still had control.</a:t>
             </a:r>
             <a:endParaRPr lang="en-US" sz="1800" dirty="0"/>
           </a:p>
@@ -3829,6 +3841,343 @@
 <file path=ppt/slides/slide16.xml><?xml version="1.0" encoding="utf-8"?>
 <p:sld xmlns:a="http://schemas.openxmlformats.org/drawingml/2006/main" xmlns:r="http://schemas.openxmlformats.org/officeDocument/2006/relationships" xmlns:p="http://schemas.openxmlformats.org/presentationml/2006/main">
   <p:cSld name="Slide 16">
+    <p:bg>
+      <p:bgPr>
+        <a:solidFill>
+          <a:srgbClr val="071612"/>
+        </a:solidFill>
+      </p:bgPr>
+    </p:bg>
+    <p:spTree>
+      <p:nvGrpSpPr>
+        <p:cNvPr id="1" name=""/>
+        <p:cNvGrpSpPr/>
+        <p:nvPr/>
+      </p:nvGrpSpPr>
+      <p:grpSpPr>
+        <a:xfrm>
+          <a:off x="0" y="0"/>
+          <a:ext cx="0" cy="0"/>
+          <a:chOff x="0" y="0"/>
+          <a:chExt cx="0" cy="0"/>
+        </a:xfrm>
+      </p:grpSpPr>
+      <p:sp>
+        <p:nvSpPr>
+          <p:cNvPr id="2" name="Text 0"/>
+          <p:cNvSpPr/>
+          <p:nvPr/>
+        </p:nvSpPr>
+        <p:spPr>
+          <a:xfrm>
+            <a:off x="640080" y="411480"/>
+            <a:ext cx="10972800" cy="274320"/>
+          </a:xfrm>
+          <a:prstGeom prst="rect">
+            <a:avLst/>
+          </a:prstGeom>
+          <a:noFill/>
+          <a:ln/>
+        </p:spPr>
+        <p:txBody>
+          <a:bodyPr wrap="square" rtlCol="0" anchor="ctr"/>
+          <a:lstStyle/>
+          <a:p>
+            <a:pPr indent="0" marL="0">
+              <a:buNone/>
+            </a:pPr>
+            <a:r>
+              <a:rPr lang="en-US" sz="1100" b="1" spc="300" kern="0" dirty="0">
+                <a:solidFill>
+                  <a:srgbClr val="1EC98A"/>
+                </a:solidFill>
+                <a:latin typeface="Arial" pitchFamily="34" charset="0"/>
+                <a:ea typeface="Arial" pitchFamily="34" charset="-122"/>
+                <a:cs typeface="Arial" pitchFamily="34" charset="-120"/>
+              </a:rPr>
+              <a:t>TEAM</a:t>
+            </a:r>
+            <a:endParaRPr lang="en-US" sz="1100" dirty="0"/>
+          </a:p>
+        </p:txBody>
+      </p:sp>
+      <p:sp>
+        <p:nvSpPr>
+          <p:cNvPr id="3" name="Text 1"/>
+          <p:cNvSpPr/>
+          <p:nvPr/>
+        </p:nvSpPr>
+        <p:spPr>
+          <a:xfrm>
+            <a:off x="640080" y="822960"/>
+            <a:ext cx="10515600" cy="640080"/>
+          </a:xfrm>
+          <a:prstGeom prst="rect">
+            <a:avLst/>
+          </a:prstGeom>
+          <a:noFill/>
+          <a:ln/>
+        </p:spPr>
+        <p:txBody>
+          <a:bodyPr wrap="square" rtlCol="0" anchor="ctr"/>
+          <a:lstStyle/>
+          <a:p>
+            <a:pPr indent="0" marL="0">
+              <a:buNone/>
+            </a:pPr>
+            <a:r>
+              <a:rPr lang="en-US" sz="3200" b="1" dirty="0">
+                <a:solidFill>
+                  <a:srgbClr val="E8F3EE"/>
+                </a:solidFill>
+                <a:latin typeface="Arial" pitchFamily="34" charset="0"/>
+                <a:ea typeface="Arial" pitchFamily="34" charset="-122"/>
+                <a:cs typeface="Arial" pitchFamily="34" charset="-120"/>
+              </a:rPr>
+              <a:t>RETON PTE LTD</a:t>
+            </a:r>
+            <a:endParaRPr lang="en-US" sz="3200" dirty="0"/>
+          </a:p>
+        </p:txBody>
+      </p:sp>
+      <p:sp>
+        <p:nvSpPr>
+          <p:cNvPr id="4" name="Shape 2"/>
+          <p:cNvSpPr/>
+          <p:nvPr/>
+        </p:nvSpPr>
+        <p:spPr>
+          <a:xfrm>
+            <a:off x="640080" y="1920240"/>
+            <a:ext cx="5029200" cy="1645920"/>
+          </a:xfrm>
+          <a:prstGeom prst="roundRect">
+            <a:avLst>
+              <a:gd name="adj" fmla="val 11111"/>
+            </a:avLst>
+          </a:prstGeom>
+          <a:solidFill>
+            <a:srgbClr val="0F211C"/>
+          </a:solidFill>
+          <a:ln/>
+        </p:spPr>
+      </p:sp>
+      <p:sp>
+        <p:nvSpPr>
+          <p:cNvPr id="5" name="Text 3"/>
+          <p:cNvSpPr/>
+          <p:nvPr/>
+        </p:nvSpPr>
+        <p:spPr>
+          <a:xfrm>
+            <a:off x="914400" y="2240280"/>
+            <a:ext cx="4572000" cy="411480"/>
+          </a:xfrm>
+          <a:prstGeom prst="rect">
+            <a:avLst/>
+          </a:prstGeom>
+          <a:noFill/>
+          <a:ln/>
+        </p:spPr>
+        <p:txBody>
+          <a:bodyPr wrap="square" rtlCol="0" anchor="ctr"/>
+          <a:lstStyle/>
+          <a:p>
+            <a:pPr indent="0" marL="0">
+              <a:buNone/>
+            </a:pPr>
+            <a:r>
+              <a:rPr lang="en-US" sz="1800" b="1" dirty="0">
+                <a:solidFill>
+                  <a:srgbClr val="E8F3EE"/>
+                </a:solidFill>
+              </a:rPr>
+              <a:t>Gabriel Rotimi Mogaji</a:t>
+            </a:r>
+            <a:endParaRPr lang="en-US" sz="1800" dirty="0"/>
+          </a:p>
+        </p:txBody>
+      </p:sp>
+      <p:sp>
+        <p:nvSpPr>
+          <p:cNvPr id="6" name="Text 4"/>
+          <p:cNvSpPr/>
+          <p:nvPr/>
+        </p:nvSpPr>
+        <p:spPr>
+          <a:xfrm>
+            <a:off x="914400" y="2697480"/>
+            <a:ext cx="4572000" cy="365760"/>
+          </a:xfrm>
+          <a:prstGeom prst="rect">
+            <a:avLst/>
+          </a:prstGeom>
+          <a:noFill/>
+          <a:ln/>
+        </p:spPr>
+        <p:txBody>
+          <a:bodyPr wrap="square" rtlCol="0" anchor="ctr"/>
+          <a:lstStyle/>
+          <a:p>
+            <a:pPr indent="0" marL="0">
+              <a:buNone/>
+            </a:pPr>
+            <a:r>
+              <a:rPr lang="en-US" sz="1400" dirty="0">
+                <a:solidFill>
+                  <a:srgbClr val="8AA89D"/>
+                </a:solidFill>
+              </a:rPr>
+              <a:t>Founder &amp; CEO</a:t>
+            </a:r>
+            <a:endParaRPr lang="en-US" sz="1400" dirty="0"/>
+          </a:p>
+        </p:txBody>
+      </p:sp>
+      <p:sp>
+        <p:nvSpPr>
+          <p:cNvPr id="7" name="Shape 5"/>
+          <p:cNvSpPr/>
+          <p:nvPr/>
+        </p:nvSpPr>
+        <p:spPr>
+          <a:xfrm>
+            <a:off x="6035040" y="1920240"/>
+            <a:ext cx="5029200" cy="1645920"/>
+          </a:xfrm>
+          <a:prstGeom prst="roundRect">
+            <a:avLst>
+              <a:gd name="adj" fmla="val 11111"/>
+            </a:avLst>
+          </a:prstGeom>
+          <a:solidFill>
+            <a:srgbClr val="0F211C"/>
+          </a:solidFill>
+          <a:ln/>
+        </p:spPr>
+      </p:sp>
+      <p:sp>
+        <p:nvSpPr>
+          <p:cNvPr id="8" name="Text 6"/>
+          <p:cNvSpPr/>
+          <p:nvPr/>
+        </p:nvSpPr>
+        <p:spPr>
+          <a:xfrm>
+            <a:off x="6309360" y="2240280"/>
+            <a:ext cx="4572000" cy="411480"/>
+          </a:xfrm>
+          <a:prstGeom prst="rect">
+            <a:avLst/>
+          </a:prstGeom>
+          <a:noFill/>
+          <a:ln/>
+        </p:spPr>
+        <p:txBody>
+          <a:bodyPr wrap="square" rtlCol="0" anchor="ctr"/>
+          <a:lstStyle/>
+          <a:p>
+            <a:pPr indent="0" marL="0">
+              <a:buNone/>
+            </a:pPr>
+            <a:r>
+              <a:rPr lang="en-US" sz="1800" b="1" dirty="0">
+                <a:solidFill>
+                  <a:srgbClr val="E8F3EE"/>
+                </a:solidFill>
+              </a:rPr>
+              <a:t>Aina Christana Olajumoke</a:t>
+            </a:r>
+            <a:endParaRPr lang="en-US" sz="1800" dirty="0"/>
+          </a:p>
+        </p:txBody>
+      </p:sp>
+      <p:sp>
+        <p:nvSpPr>
+          <p:cNvPr id="9" name="Text 7"/>
+          <p:cNvSpPr/>
+          <p:nvPr/>
+        </p:nvSpPr>
+        <p:spPr>
+          <a:xfrm>
+            <a:off x="6309360" y="2697480"/>
+            <a:ext cx="4572000" cy="365760"/>
+          </a:xfrm>
+          <a:prstGeom prst="rect">
+            <a:avLst/>
+          </a:prstGeom>
+          <a:noFill/>
+          <a:ln/>
+        </p:spPr>
+        <p:txBody>
+          <a:bodyPr wrap="square" rtlCol="0" anchor="ctr"/>
+          <a:lstStyle/>
+          <a:p>
+            <a:pPr indent="0" marL="0">
+              <a:buNone/>
+            </a:pPr>
+            <a:r>
+              <a:rPr lang="en-US" sz="1400" dirty="0">
+                <a:solidFill>
+                  <a:srgbClr val="8AA89D"/>
+                </a:solidFill>
+              </a:rPr>
+              <a:t>Co-Founder</a:t>
+            </a:r>
+            <a:endParaRPr lang="en-US" sz="1400" dirty="0"/>
+          </a:p>
+        </p:txBody>
+      </p:sp>
+      <p:sp>
+        <p:nvSpPr>
+          <p:cNvPr id="10" name="Text 8"/>
+          <p:cNvSpPr/>
+          <p:nvPr/>
+        </p:nvSpPr>
+        <p:spPr>
+          <a:xfrm>
+            <a:off x="640080" y="4114800"/>
+            <a:ext cx="10058400" cy="1097280"/>
+          </a:xfrm>
+          <a:prstGeom prst="rect">
+            <a:avLst/>
+          </a:prstGeom>
+          <a:noFill/>
+          <a:ln/>
+        </p:spPr>
+        <p:txBody>
+          <a:bodyPr wrap="square" rtlCol="0" anchor="ctr"/>
+          <a:lstStyle/>
+          <a:p>
+            <a:pPr indent="0" marL="0">
+              <a:buNone/>
+            </a:pPr>
+            <a:r>
+              <a:rPr lang="en-US" sz="1800" dirty="0">
+                <a:solidFill>
+                  <a:srgbClr val="8AA89D"/>
+                </a:solidFill>
+                <a:latin typeface="Arial" pitchFamily="34" charset="0"/>
+                <a:ea typeface="Arial" pitchFamily="34" charset="-122"/>
+                <a:cs typeface="Arial" pitchFamily="34" charset="-120"/>
+              </a:rPr>
+              <a:t>Building Africa’s trust-first payment platform — one protected transfer at a time.</a:t>
+            </a:r>
+            <a:endParaRPr lang="en-US" sz="1800" dirty="0"/>
+          </a:p>
+        </p:txBody>
+      </p:sp>
+    </p:spTree>
+  </p:cSld>
+  <p:clrMapOvr>
+    <a:masterClrMapping/>
+  </p:clrMapOvr>
+</p:sld>
+</file>
+
+<file path=ppt/slides/slide17.xml><?xml version="1.0" encoding="utf-8"?>
+<p:sld xmlns:a="http://schemas.openxmlformats.org/drawingml/2006/main" xmlns:r="http://schemas.openxmlformats.org/officeDocument/2006/relationships" xmlns:p="http://schemas.openxmlformats.org/presentationml/2006/main">
+  <p:cSld name="Slide 17">
     <p:bg>
       <p:bgPr>
         <a:solidFill>

</xml_diff>